<commit_message>
Adiciona seção sobre comprar vs. construir e crescimento SaaS
Nova seção "Comprar ou construir a própria solução", posicionada antes de
"Inteligência artificial no software", cobrindo:
- quando compensa comprar uma solução pronta vs. construir a própria
- o modelo de crescimento por assinatura (SaaS)
- o ciclo de renovação como coração do modelo
- por que o fluxo de caixa se comporta de forma diferente (venda única vs.
  receita recorrente que se acumula com o tempo)

Inclui 3 novos diagramas gerados com Matplotlib, mantendo a identidade
visual já estabelecida no deck.

Co-Authored-By: Claude Sonnet 5 <noreply@anthropic.com>
Claude-Session: https://claude.ai/code/session_017dKXPAcE5bAggx1M3V9VCU
</commit_message>
<xml_diff>
--- a/presentation/apresentacao.pptx
+++ b/presentation/apresentacao.pptx
@@ -5,7 +5,7 @@
     <p:sldMasterId id="2147483648" r:id="rId1"/>
   </p:sldMasterIdLst>
   <p:notesMasterIdLst>
-    <p:notesMasterId r:id="rId33"/>
+    <p:notesMasterId r:id="rId41"/>
   </p:notesMasterIdLst>
   <p:sldIdLst>
     <p:sldId id="256" r:id="rId2"/>
@@ -39,6 +39,14 @@
     <p:sldId id="284" r:id="rId30"/>
     <p:sldId id="285" r:id="rId31"/>
     <p:sldId id="286" r:id="rId32"/>
+    <p:sldId id="287" r:id="rId33"/>
+    <p:sldId id="288" r:id="rId34"/>
+    <p:sldId id="289" r:id="rId35"/>
+    <p:sldId id="290" r:id="rId36"/>
+    <p:sldId id="291" r:id="rId37"/>
+    <p:sldId id="292" r:id="rId38"/>
+    <p:sldId id="293" r:id="rId39"/>
+    <p:sldId id="294" r:id="rId40"/>
   </p:sldIdLst>
   <p:sldSz cx="12191695" cy="6858000" type="screen4x3"/>
   <p:notesSz cx="6858000" cy="9144000"/>
@@ -702,7 +710,7 @@
             </a:pPr>
             <a:r>
               <a:rPr/>
-              <a:t>RAG: o assistente busca em documentos relevantes antes de responder, como um bom atendente que consulta o manual certo. GraphRAG vai além: entende como as informações se conectam entre si, como um mapa de relacionamentos, o que ajuda a responder perguntas mais complexas.</a:t>
+              <a:t>Antes de decidir construir algo internamente, toda empresa enfrenta essa escolha: pagar por uma solução que já existe no mercado ou investir tempo e time próprio para construir algo sob medida. Não existe resposta certa única; depende do quanto aquilo diferencia o negócio.</a:t>
             </a:r>
           </a:p>
         </p:txBody>
@@ -724,7 +732,253 @@
           <a:p>
             <a:fld id="{18BDFEC3-8487-43E8-A154-7C12CBC1FFF2}" type="slidenum">
               <a:rPr lang="en-US"/>
-              <a:t>20</a:t>
+              <a:t>19</a:t>
+            </a:fld>
+            <a:endParaRPr lang="en-US"/>
+          </a:p>
+        </p:txBody>
+      </p:sp>
+    </p:spTree>
+  </p:cSld>
+</p:notes>
+</file>
+
+<file path=ppt/notesSlides/notesSlide4.xml><?xml version="1.0" encoding="utf-8"?>
+<p:notes xmlns:a="http://schemas.openxmlformats.org/drawingml/2006/main" xmlns:r="http://schemas.openxmlformats.org/officeDocument/2006/relationships" xmlns:p="http://schemas.openxmlformats.org/presentationml/2006/main">
+  <p:cSld>
+    <p:spTree>
+      <p:nvGrpSpPr>
+        <p:cNvPr id="1" name=""/>
+        <p:cNvGrpSpPr/>
+        <p:nvPr/>
+      </p:nvGrpSpPr>
+      <p:grpSpPr>
+        <a:xfrm>
+          <a:off x="0" y="0"/>
+          <a:ext cx="0" cy="0"/>
+          <a:chOff x="0" y="0"/>
+          <a:chExt cx="0" cy="0"/>
+        </a:xfrm>
+      </p:grpSpPr>
+      <p:sp>
+        <p:nvSpPr>
+          <p:cNvPr id="2" name="Slide Image Placeholder 1"/>
+          <p:cNvSpPr>
+            <a:spLocks noGrp="1" noRot="1" noChangeAspect="1"/>
+          </p:cNvSpPr>
+          <p:nvPr>
+            <p:ph type="sldImg"/>
+          </p:nvPr>
+        </p:nvSpPr>
+        <p:spPr/>
+      </p:sp>
+      <p:sp>
+        <p:nvSpPr>
+          <p:cNvPr id="3" name="Notes Placeholder 2"/>
+          <p:cNvSpPr>
+            <a:spLocks noGrp="1"/>
+          </p:cNvSpPr>
+          <p:nvPr>
+            <p:ph type="body" idx="1"/>
+          </p:nvPr>
+        </p:nvSpPr>
+        <p:spPr/>
+        <p:txBody>
+          <a:bodyPr/>
+          <a:lstStyle/>
+          <a:p>
+            <a:pPr lvl="0" indent="0" marL="0">
+              <a:buNone/>
+            </a:pPr>
+            <a:r>
+              <a:rPr/>
+              <a:t>Diferente de uma venda única, no modelo de assinatura a venda nunca termina de verdade. A cada ciclo, o cliente decide se continua ou não, e é essa decisão repetida que sustenta o negócio.</a:t>
+            </a:r>
+          </a:p>
+        </p:txBody>
+      </p:sp>
+      <p:sp>
+        <p:nvSpPr>
+          <p:cNvPr id="4" name="Slide Number Placeholder 3"/>
+          <p:cNvSpPr>
+            <a:spLocks noGrp="1"/>
+          </p:cNvSpPr>
+          <p:nvPr>
+            <p:ph type="sldNum" sz="quarter" idx="10"/>
+          </p:nvPr>
+        </p:nvSpPr>
+        <p:spPr/>
+        <p:txBody>
+          <a:bodyPr/>
+          <a:lstStyle/>
+          <a:p>
+            <a:fld id="{18BDFEC3-8487-43E8-A154-7C12CBC1FFF2}" type="slidenum">
+              <a:rPr lang="en-US"/>
+              <a:t>23</a:t>
+            </a:fld>
+            <a:endParaRPr lang="en-US"/>
+          </a:p>
+        </p:txBody>
+      </p:sp>
+    </p:spTree>
+  </p:cSld>
+</p:notes>
+</file>
+
+<file path=ppt/notesSlides/notesSlide5.xml><?xml version="1.0" encoding="utf-8"?>
+<p:notes xmlns:a="http://schemas.openxmlformats.org/drawingml/2006/main" xmlns:r="http://schemas.openxmlformats.org/officeDocument/2006/relationships" xmlns:p="http://schemas.openxmlformats.org/presentationml/2006/main">
+  <p:cSld>
+    <p:spTree>
+      <p:nvGrpSpPr>
+        <p:cNvPr id="1" name=""/>
+        <p:cNvGrpSpPr/>
+        <p:nvPr/>
+      </p:nvGrpSpPr>
+      <p:grpSpPr>
+        <a:xfrm>
+          <a:off x="0" y="0"/>
+          <a:ext cx="0" cy="0"/>
+          <a:chOff x="0" y="0"/>
+          <a:chExt cx="0" cy="0"/>
+        </a:xfrm>
+      </p:grpSpPr>
+      <p:sp>
+        <p:nvSpPr>
+          <p:cNvPr id="2" name="Slide Image Placeholder 1"/>
+          <p:cNvSpPr>
+            <a:spLocks noGrp="1" noRot="1" noChangeAspect="1"/>
+          </p:cNvSpPr>
+          <p:nvPr>
+            <p:ph type="sldImg"/>
+          </p:nvPr>
+        </p:nvSpPr>
+        <p:spPr/>
+      </p:sp>
+      <p:sp>
+        <p:nvSpPr>
+          <p:cNvPr id="3" name="Notes Placeholder 2"/>
+          <p:cNvSpPr>
+            <a:spLocks noGrp="1"/>
+          </p:cNvSpPr>
+          <p:nvPr>
+            <p:ph type="body" idx="1"/>
+          </p:nvPr>
+        </p:nvSpPr>
+        <p:spPr/>
+        <p:txBody>
+          <a:bodyPr/>
+          <a:lstStyle/>
+          <a:p>
+            <a:pPr lvl="0" indent="0" marL="0">
+              <a:buNone/>
+            </a:pPr>
+            <a:r>
+              <a:rPr/>
+              <a:t>Uma venda tradicional traz um caixa grande de uma vez só, mas que não se repete. Uma assinatura traz valores menores no começo, porém, se a renovação for saudável, a receita se acumula e ultrapassa a venda única com o tempo. Por isso empresas de assinatura acompanham de perto a taxa de renovação: é o que garante caixa no futuro.</a:t>
+            </a:r>
+          </a:p>
+        </p:txBody>
+      </p:sp>
+      <p:sp>
+        <p:nvSpPr>
+          <p:cNvPr id="4" name="Slide Number Placeholder 3"/>
+          <p:cNvSpPr>
+            <a:spLocks noGrp="1"/>
+          </p:cNvSpPr>
+          <p:nvPr>
+            <p:ph type="sldNum" sz="quarter" idx="10"/>
+          </p:nvPr>
+        </p:nvSpPr>
+        <p:spPr/>
+        <p:txBody>
+          <a:bodyPr/>
+          <a:lstStyle/>
+          <a:p>
+            <a:fld id="{18BDFEC3-8487-43E8-A154-7C12CBC1FFF2}" type="slidenum">
+              <a:rPr lang="en-US"/>
+              <a:t>24</a:t>
+            </a:fld>
+            <a:endParaRPr lang="en-US"/>
+          </a:p>
+        </p:txBody>
+      </p:sp>
+    </p:spTree>
+  </p:cSld>
+</p:notes>
+</file>
+
+<file path=ppt/notesSlides/notesSlide6.xml><?xml version="1.0" encoding="utf-8"?>
+<p:notes xmlns:a="http://schemas.openxmlformats.org/drawingml/2006/main" xmlns:r="http://schemas.openxmlformats.org/officeDocument/2006/relationships" xmlns:p="http://schemas.openxmlformats.org/presentationml/2006/main">
+  <p:cSld>
+    <p:spTree>
+      <p:nvGrpSpPr>
+        <p:cNvPr id="1" name=""/>
+        <p:cNvGrpSpPr/>
+        <p:nvPr/>
+      </p:nvGrpSpPr>
+      <p:grpSpPr>
+        <a:xfrm>
+          <a:off x="0" y="0"/>
+          <a:ext cx="0" cy="0"/>
+          <a:chOff x="0" y="0"/>
+          <a:chExt cx="0" cy="0"/>
+        </a:xfrm>
+      </p:grpSpPr>
+      <p:sp>
+        <p:nvSpPr>
+          <p:cNvPr id="2" name="Slide Image Placeholder 1"/>
+          <p:cNvSpPr>
+            <a:spLocks noGrp="1" noRot="1" noChangeAspect="1"/>
+          </p:cNvSpPr>
+          <p:nvPr>
+            <p:ph type="sldImg"/>
+          </p:nvPr>
+        </p:nvSpPr>
+        <p:spPr/>
+      </p:sp>
+      <p:sp>
+        <p:nvSpPr>
+          <p:cNvPr id="3" name="Notes Placeholder 2"/>
+          <p:cNvSpPr>
+            <a:spLocks noGrp="1"/>
+          </p:cNvSpPr>
+          <p:nvPr>
+            <p:ph type="body" idx="1"/>
+          </p:nvPr>
+        </p:nvSpPr>
+        <p:spPr/>
+        <p:txBody>
+          <a:bodyPr/>
+          <a:lstStyle/>
+          <a:p>
+            <a:pPr lvl="0" indent="0" marL="0">
+              <a:buNone/>
+            </a:pPr>
+            <a:r>
+              <a:rPr/>
+              <a:t>RAG: o assistente busca em documentos relevantes antes de responder, como um bom atendente que consulta o manual certo. GraphRAG vai além: entende como as informações se conectam entre si, como um mapa de relacionamentos, o que ajuda a responder perguntas mais complexas.</a:t>
+            </a:r>
+          </a:p>
+        </p:txBody>
+      </p:sp>
+      <p:sp>
+        <p:nvSpPr>
+          <p:cNvPr id="4" name="Slide Number Placeholder 3"/>
+          <p:cNvSpPr>
+            <a:spLocks noGrp="1"/>
+          </p:cNvSpPr>
+          <p:nvPr>
+            <p:ph type="sldNum" sz="quarter" idx="10"/>
+          </p:nvPr>
+        </p:nvSpPr>
+        <p:spPr/>
+        <p:txBody>
+          <a:bodyPr/>
+          <a:lstStyle/>
+          <a:p>
+            <a:fld id="{18BDFEC3-8487-43E8-A154-7C12CBC1FFF2}" type="slidenum">
+              <a:rPr lang="en-US"/>
+              <a:t>28</a:t>
             </a:fld>
             <a:endParaRPr lang="en-US"/>
           </a:p>
@@ -4534,7 +4788,7 @@
             </a:pPr>
             <a:r>
               <a:rPr/>
-              <a:t>Inteligência artificial no software</a:t>
+              <a:t>Comprar ou construir a própria solução</a:t>
             </a:r>
           </a:p>
         </p:txBody>
@@ -4581,55 +4835,41 @@
             </a:pPr>
             <a:r>
               <a:rPr/>
-              <a:t>IA como uma nova camada dos produtos digitais</a:t>
-            </a:r>
-          </a:p>
-        </p:txBody>
-      </p:sp>
-      <p:sp>
-        <p:nvSpPr>
-          <p:cNvPr id="3" name="Content Placeholder 2"/>
-          <p:cNvSpPr>
-            <a:spLocks noGrp="1"/>
-          </p:cNvSpPr>
-          <p:nvPr>
-            <p:ph idx="1"/>
-          </p:nvPr>
-        </p:nvSpPr>
-        <p:spPr/>
-        <p:txBody>
-          <a:bodyPr/>
-          <a:lstStyle/>
-          <a:p>
-            <a:pPr lvl="0"/>
-            <a:r>
-              <a:rPr/>
-              <a:t>Até pouco tempo atrás, sistemas seguiam apenas regras fixas, escritas por pessoas</a:t>
-            </a:r>
-          </a:p>
-          <a:p>
-            <a:pPr lvl="0"/>
-            <a:r>
-              <a:rPr/>
-              <a:t>Hoje, a inteligência artificial permite que sistemas entendam linguagem natural e respondam de forma mais flexível</a:t>
-            </a:r>
-          </a:p>
-          <a:p>
-            <a:pPr lvl="0"/>
-            <a:r>
-              <a:rPr/>
-              <a:t>Isso abre espaço para assistentes que conversam com o cliente, resumem informações e ajudam pessoas a decidir mais rápido</a:t>
-            </a:r>
-          </a:p>
-          <a:p>
-            <a:pPr lvl="0"/>
-            <a:r>
-              <a:rPr/>
-              <a:t>O desafio deixou de ser “o sistema entende o pedido?” e passou a ser “a resposta é confiável?”</a:t>
-            </a:r>
-          </a:p>
-        </p:txBody>
-      </p:sp>
+              <a:t>Duas formas de resolver o mesmo problema</a:t>
+            </a:r>
+          </a:p>
+        </p:txBody>
+      </p:sp>
+      <p:pic>
+        <p:nvPicPr>
+          <p:cNvPr descr="assets/diagrama_comprar_construir.png" id="0" name="Picture 1"/>
+          <p:cNvPicPr>
+            <a:picLocks noGrp="1" noChangeAspect="1"/>
+          </p:cNvPicPr>
+          <p:nvPr/>
+        </p:nvPicPr>
+        <p:blipFill>
+          <a:blip r:embed="rId3"/>
+          <a:stretch>
+            <a:fillRect/>
+          </a:stretch>
+        </p:blipFill>
+        <p:spPr bwMode="auto">
+          <a:xfrm>
+            <a:off x="457200" y="2133600"/>
+            <a:ext cx="8229600" cy="3454400"/>
+          </a:xfrm>
+          <a:prstGeom prst="rect">
+            <a:avLst/>
+          </a:prstGeom>
+          <a:noFill/>
+          <a:ln w="9525">
+            <a:noFill/>
+            <a:headEnd/>
+            <a:tailEnd/>
+          </a:ln>
+        </p:spPr>
+      </p:pic>
     </p:spTree>
   </p:cSld>
 </p:sld>
@@ -4716,6 +4956,13 @@
             <a:pPr lvl="0"/>
             <a:r>
               <a:rPr/>
+              <a:t>Comprar ou construir a própria solução</a:t>
+            </a:r>
+          </a:p>
+          <a:p>
+            <a:pPr lvl="0"/>
+            <a:r>
+              <a:rPr/>
               <a:t>Inteligência artificial no software</a:t>
             </a:r>
           </a:p>
@@ -4734,6 +4981,667 @@
 </file>
 
 <file path=ppt/slides/slide20.xml><?xml version="1.0" encoding="utf-8"?>
+<p:sld xmlns:a="http://schemas.openxmlformats.org/drawingml/2006/main" xmlns:r="http://schemas.openxmlformats.org/officeDocument/2006/relationships" xmlns:p="http://schemas.openxmlformats.org/presentationml/2006/main">
+  <p:cSld>
+    <p:spTree>
+      <p:nvGrpSpPr>
+        <p:cNvPr id="1" name=""/>
+        <p:cNvGrpSpPr/>
+        <p:nvPr/>
+      </p:nvGrpSpPr>
+      <p:grpSpPr>
+        <a:xfrm>
+          <a:off x="0" y="0"/>
+          <a:ext cx="0" cy="0"/>
+          <a:chOff x="0" y="0"/>
+          <a:chExt cx="0" cy="0"/>
+        </a:xfrm>
+      </p:grpSpPr>
+      <p:sp>
+        <p:nvSpPr>
+          <p:cNvPr id="2" name="Title 1"/>
+          <p:cNvSpPr>
+            <a:spLocks noGrp="1"/>
+          </p:cNvSpPr>
+          <p:nvPr>
+            <p:ph type="title"/>
+          </p:nvPr>
+        </p:nvSpPr>
+        <p:spPr/>
+        <p:txBody>
+          <a:bodyPr/>
+          <a:lstStyle/>
+          <a:p>
+            <a:pPr lvl="0" indent="0" marL="0">
+              <a:buNone/>
+            </a:pPr>
+            <a:r>
+              <a:rPr/>
+              <a:t>Quando compensa comprar uma solução pronta</a:t>
+            </a:r>
+          </a:p>
+        </p:txBody>
+      </p:sp>
+      <p:sp>
+        <p:nvSpPr>
+          <p:cNvPr id="3" name="Content Placeholder 2"/>
+          <p:cNvSpPr>
+            <a:spLocks noGrp="1"/>
+          </p:cNvSpPr>
+          <p:nvPr>
+            <p:ph idx="1"/>
+          </p:nvPr>
+        </p:nvSpPr>
+        <p:spPr/>
+        <p:txBody>
+          <a:bodyPr/>
+          <a:lstStyle/>
+          <a:p>
+            <a:pPr lvl="0"/>
+            <a:r>
+              <a:rPr/>
+              <a:t>O problema já foi resolvido por outras empresas de forma madura e testada</a:t>
+            </a:r>
+          </a:p>
+          <a:p>
+            <a:pPr lvl="0"/>
+            <a:r>
+              <a:rPr/>
+              <a:t>A velocidade de implantação importa mais do que a personalização</a:t>
+            </a:r>
+          </a:p>
+          <a:p>
+            <a:pPr lvl="0"/>
+            <a:r>
+              <a:rPr/>
+              <a:t>O time interno pode focar energia no que realmente diferencia o negócio</a:t>
+            </a:r>
+          </a:p>
+          <a:p>
+            <a:pPr lvl="0"/>
+            <a:r>
+              <a:rPr/>
+              <a:t>O custo inicial é mais previsível e geralmente mais baixo</a:t>
+            </a:r>
+          </a:p>
+        </p:txBody>
+      </p:sp>
+    </p:spTree>
+  </p:cSld>
+</p:sld>
+</file>
+
+<file path=ppt/slides/slide21.xml><?xml version="1.0" encoding="utf-8"?>
+<p:sld xmlns:a="http://schemas.openxmlformats.org/drawingml/2006/main" xmlns:r="http://schemas.openxmlformats.org/officeDocument/2006/relationships" xmlns:p="http://schemas.openxmlformats.org/presentationml/2006/main">
+  <p:cSld>
+    <p:spTree>
+      <p:nvGrpSpPr>
+        <p:cNvPr id="1" name=""/>
+        <p:cNvGrpSpPr/>
+        <p:nvPr/>
+      </p:nvGrpSpPr>
+      <p:grpSpPr>
+        <a:xfrm>
+          <a:off x="0" y="0"/>
+          <a:ext cx="0" cy="0"/>
+          <a:chOff x="0" y="0"/>
+          <a:chExt cx="0" cy="0"/>
+        </a:xfrm>
+      </p:grpSpPr>
+      <p:sp>
+        <p:nvSpPr>
+          <p:cNvPr id="2" name="Title 1"/>
+          <p:cNvSpPr>
+            <a:spLocks noGrp="1"/>
+          </p:cNvSpPr>
+          <p:nvPr>
+            <p:ph type="title"/>
+          </p:nvPr>
+        </p:nvSpPr>
+        <p:spPr/>
+        <p:txBody>
+          <a:bodyPr/>
+          <a:lstStyle/>
+          <a:p>
+            <a:pPr lvl="0" indent="0" marL="0">
+              <a:buNone/>
+            </a:pPr>
+            <a:r>
+              <a:rPr/>
+              <a:t>Quando compensa construir a própria solução</a:t>
+            </a:r>
+          </a:p>
+        </p:txBody>
+      </p:sp>
+      <p:sp>
+        <p:nvSpPr>
+          <p:cNvPr id="3" name="Content Placeholder 2"/>
+          <p:cNvSpPr>
+            <a:spLocks noGrp="1"/>
+          </p:cNvSpPr>
+          <p:nvPr>
+            <p:ph idx="1"/>
+          </p:nvPr>
+        </p:nvSpPr>
+        <p:spPr/>
+        <p:txBody>
+          <a:bodyPr/>
+          <a:lstStyle/>
+          <a:p>
+            <a:pPr lvl="0"/>
+            <a:r>
+              <a:rPr/>
+              <a:t>A necessidade é muito específica do negócio, e não existe solução pronta parecida</a:t>
+            </a:r>
+          </a:p>
+          <a:p>
+            <a:pPr lvl="0"/>
+            <a:r>
+              <a:rPr/>
+              <a:t>Essa capacidade é uma vantagem competitiva que vale a pena proteger</a:t>
+            </a:r>
+          </a:p>
+          <a:p>
+            <a:pPr lvl="0"/>
+            <a:r>
+              <a:rPr/>
+              <a:t>Há dependência de integração profunda com outros sistemas internos</a:t>
+            </a:r>
+          </a:p>
+          <a:p>
+            <a:pPr lvl="0"/>
+            <a:r>
+              <a:rPr/>
+              <a:t>No longo prazo, construir pode custar menos do que pagar por uso crescente</a:t>
+            </a:r>
+          </a:p>
+        </p:txBody>
+      </p:sp>
+    </p:spTree>
+  </p:cSld>
+</p:sld>
+</file>
+
+<file path=ppt/slides/slide22.xml><?xml version="1.0" encoding="utf-8"?>
+<p:sld xmlns:a="http://schemas.openxmlformats.org/drawingml/2006/main" xmlns:r="http://schemas.openxmlformats.org/officeDocument/2006/relationships" xmlns:p="http://schemas.openxmlformats.org/presentationml/2006/main">
+  <p:cSld>
+    <p:spTree>
+      <p:nvGrpSpPr>
+        <p:cNvPr id="1" name=""/>
+        <p:cNvGrpSpPr/>
+        <p:nvPr/>
+      </p:nvGrpSpPr>
+      <p:grpSpPr>
+        <a:xfrm>
+          <a:off x="0" y="0"/>
+          <a:ext cx="0" cy="0"/>
+          <a:chOff x="0" y="0"/>
+          <a:chExt cx="0" cy="0"/>
+        </a:xfrm>
+      </p:grpSpPr>
+      <p:sp>
+        <p:nvSpPr>
+          <p:cNvPr id="2" name="Title 1"/>
+          <p:cNvSpPr>
+            <a:spLocks noGrp="1"/>
+          </p:cNvSpPr>
+          <p:nvPr>
+            <p:ph type="title"/>
+          </p:nvPr>
+        </p:nvSpPr>
+        <p:spPr/>
+        <p:txBody>
+          <a:bodyPr/>
+          <a:lstStyle/>
+          <a:p>
+            <a:pPr lvl="0" indent="0" marL="0">
+              <a:buNone/>
+            </a:pPr>
+            <a:r>
+              <a:rPr/>
+              <a:t>O crescimento das assinaturas (SaaS)</a:t>
+            </a:r>
+          </a:p>
+        </p:txBody>
+      </p:sp>
+      <p:sp>
+        <p:nvSpPr>
+          <p:cNvPr id="3" name="Content Placeholder 2"/>
+          <p:cNvSpPr>
+            <a:spLocks noGrp="1"/>
+          </p:cNvSpPr>
+          <p:nvPr>
+            <p:ph idx="1"/>
+          </p:nvPr>
+        </p:nvSpPr>
+        <p:spPr/>
+        <p:txBody>
+          <a:bodyPr/>
+          <a:lstStyle/>
+          <a:p>
+            <a:pPr lvl="0"/>
+            <a:r>
+              <a:rPr/>
+              <a:t>Cada vez mais empresas oferecem software como um serviço por assinatura, em vez de vender uma licença única</a:t>
+            </a:r>
+          </a:p>
+          <a:p>
+            <a:pPr lvl="0"/>
+            <a:r>
+              <a:rPr/>
+              <a:t>O cliente paga um valor recorrente, geralmente mensal ou anual, para continuar usando</a:t>
+            </a:r>
+          </a:p>
+          <a:p>
+            <a:pPr lvl="0"/>
+            <a:r>
+              <a:rPr/>
+              <a:t>Isso reduz o investimento inicial de quem compra, e cria uma receita previsível para quem vende</a:t>
+            </a:r>
+          </a:p>
+          <a:p>
+            <a:pPr lvl="0"/>
+            <a:r>
+              <a:rPr/>
+              <a:t>O sucesso desse modelo depende de uma coisa acima de tudo: o cliente continuar renovando</a:t>
+            </a:r>
+          </a:p>
+        </p:txBody>
+      </p:sp>
+    </p:spTree>
+  </p:cSld>
+</p:sld>
+</file>
+
+<file path=ppt/slides/slide23.xml><?xml version="1.0" encoding="utf-8"?>
+<p:sld xmlns:a="http://schemas.openxmlformats.org/drawingml/2006/main" xmlns:r="http://schemas.openxmlformats.org/officeDocument/2006/relationships" xmlns:p="http://schemas.openxmlformats.org/presentationml/2006/main">
+  <p:cSld>
+    <p:spTree>
+      <p:nvGrpSpPr>
+        <p:cNvPr id="1" name=""/>
+        <p:cNvGrpSpPr/>
+        <p:nvPr/>
+      </p:nvGrpSpPr>
+      <p:grpSpPr>
+        <a:xfrm>
+          <a:off x="0" y="0"/>
+          <a:ext cx="0" cy="0"/>
+          <a:chOff x="0" y="0"/>
+          <a:chExt cx="0" cy="0"/>
+        </a:xfrm>
+      </p:grpSpPr>
+      <p:sp>
+        <p:nvSpPr>
+          <p:cNvPr id="2" name="Title 1"/>
+          <p:cNvSpPr>
+            <a:spLocks noGrp="1"/>
+          </p:cNvSpPr>
+          <p:nvPr>
+            <p:ph type="title"/>
+          </p:nvPr>
+        </p:nvSpPr>
+        <p:spPr/>
+        <p:txBody>
+          <a:bodyPr/>
+          <a:lstStyle/>
+          <a:p>
+            <a:pPr lvl="0" indent="0" marL="0">
+              <a:buNone/>
+            </a:pPr>
+            <a:r>
+              <a:rPr/>
+              <a:t>O coração do modelo: a renovação</a:t>
+            </a:r>
+          </a:p>
+        </p:txBody>
+      </p:sp>
+      <p:pic>
+        <p:nvPicPr>
+          <p:cNvPr descr="assets/diagrama_ciclo_assinatura.png" id="0" name="Picture 1"/>
+          <p:cNvPicPr>
+            <a:picLocks noGrp="1" noChangeAspect="1"/>
+          </p:cNvPicPr>
+          <p:nvPr/>
+        </p:nvPicPr>
+        <p:blipFill>
+          <a:blip r:embed="rId3"/>
+          <a:stretch>
+            <a:fillRect/>
+          </a:stretch>
+        </p:blipFill>
+        <p:spPr bwMode="auto">
+          <a:xfrm>
+            <a:off x="457200" y="1803400"/>
+            <a:ext cx="8229600" cy="4114800"/>
+          </a:xfrm>
+          <a:prstGeom prst="rect">
+            <a:avLst/>
+          </a:prstGeom>
+          <a:noFill/>
+          <a:ln w="9525">
+            <a:noFill/>
+            <a:headEnd/>
+            <a:tailEnd/>
+          </a:ln>
+        </p:spPr>
+      </p:pic>
+    </p:spTree>
+  </p:cSld>
+</p:sld>
+</file>
+
+<file path=ppt/slides/slide24.xml><?xml version="1.0" encoding="utf-8"?>
+<p:sld xmlns:a="http://schemas.openxmlformats.org/drawingml/2006/main" xmlns:r="http://schemas.openxmlformats.org/officeDocument/2006/relationships" xmlns:p="http://schemas.openxmlformats.org/presentationml/2006/main">
+  <p:cSld>
+    <p:spTree>
+      <p:nvGrpSpPr>
+        <p:cNvPr id="1" name=""/>
+        <p:cNvGrpSpPr/>
+        <p:nvPr/>
+      </p:nvGrpSpPr>
+      <p:grpSpPr>
+        <a:xfrm>
+          <a:off x="0" y="0"/>
+          <a:ext cx="0" cy="0"/>
+          <a:chOff x="0" y="0"/>
+          <a:chExt cx="0" cy="0"/>
+        </a:xfrm>
+      </p:grpSpPr>
+      <p:sp>
+        <p:nvSpPr>
+          <p:cNvPr id="2" name="Title 1"/>
+          <p:cNvSpPr>
+            <a:spLocks noGrp="1"/>
+          </p:cNvSpPr>
+          <p:nvPr>
+            <p:ph type="title"/>
+          </p:nvPr>
+        </p:nvSpPr>
+        <p:spPr/>
+        <p:txBody>
+          <a:bodyPr/>
+          <a:lstStyle/>
+          <a:p>
+            <a:pPr lvl="0" indent="0" marL="0">
+              <a:buNone/>
+            </a:pPr>
+            <a:r>
+              <a:rPr/>
+              <a:t>Por que o fluxo de caixa muda tanto</a:t>
+            </a:r>
+          </a:p>
+        </p:txBody>
+      </p:sp>
+      <p:pic>
+        <p:nvPicPr>
+          <p:cNvPr descr="assets/diagrama_fluxo_caixa_saas.png" id="0" name="Picture 1"/>
+          <p:cNvPicPr>
+            <a:picLocks noGrp="1" noChangeAspect="1"/>
+          </p:cNvPicPr>
+          <p:nvPr/>
+        </p:nvPicPr>
+        <p:blipFill>
+          <a:blip r:embed="rId3"/>
+          <a:stretch>
+            <a:fillRect/>
+          </a:stretch>
+        </p:blipFill>
+        <p:spPr bwMode="auto">
+          <a:xfrm>
+            <a:off x="457200" y="1765300"/>
+            <a:ext cx="8229600" cy="4178300"/>
+          </a:xfrm>
+          <a:prstGeom prst="rect">
+            <a:avLst/>
+          </a:prstGeom>
+          <a:noFill/>
+          <a:ln w="9525">
+            <a:noFill/>
+            <a:headEnd/>
+            <a:tailEnd/>
+          </a:ln>
+        </p:spPr>
+      </p:pic>
+    </p:spTree>
+  </p:cSld>
+</p:sld>
+</file>
+
+<file path=ppt/slides/slide25.xml><?xml version="1.0" encoding="utf-8"?>
+<p:sld xmlns:a="http://schemas.openxmlformats.org/drawingml/2006/main" xmlns:r="http://schemas.openxmlformats.org/officeDocument/2006/relationships" xmlns:p="http://schemas.openxmlformats.org/presentationml/2006/main">
+  <p:cSld>
+    <p:spTree>
+      <p:nvGrpSpPr>
+        <p:cNvPr id="1" name=""/>
+        <p:cNvGrpSpPr/>
+        <p:nvPr/>
+      </p:nvGrpSpPr>
+      <p:grpSpPr>
+        <a:xfrm>
+          <a:off x="0" y="0"/>
+          <a:ext cx="0" cy="0"/>
+          <a:chOff x="0" y="0"/>
+          <a:chExt cx="0" cy="0"/>
+        </a:xfrm>
+      </p:grpSpPr>
+      <p:sp>
+        <p:nvSpPr>
+          <p:cNvPr id="2" name="Title 1"/>
+          <p:cNvSpPr>
+            <a:spLocks noGrp="1"/>
+          </p:cNvSpPr>
+          <p:nvPr>
+            <p:ph type="title"/>
+          </p:nvPr>
+        </p:nvSpPr>
+        <p:spPr/>
+        <p:txBody>
+          <a:bodyPr/>
+          <a:lstStyle/>
+          <a:p>
+            <a:pPr lvl="0" indent="0" marL="0">
+              <a:buNone/>
+            </a:pPr>
+            <a:r>
+              <a:rPr/>
+              <a:t>O que isso significa para quem decide</a:t>
+            </a:r>
+          </a:p>
+        </p:txBody>
+      </p:sp>
+      <p:sp>
+        <p:nvSpPr>
+          <p:cNvPr id="3" name="Content Placeholder 2"/>
+          <p:cNvSpPr>
+            <a:spLocks noGrp="1"/>
+          </p:cNvSpPr>
+          <p:nvPr>
+            <p:ph idx="1"/>
+          </p:nvPr>
+        </p:nvSpPr>
+        <p:spPr/>
+        <p:txBody>
+          <a:bodyPr/>
+          <a:lstStyle/>
+          <a:p>
+            <a:pPr lvl="0"/>
+            <a:r>
+              <a:rPr/>
+              <a:t>Comprar ou construir depende do quanto aquela solução diferencia o negócio, não só do preço</a:t>
+            </a:r>
+          </a:p>
+          <a:p>
+            <a:pPr lvl="0"/>
+            <a:r>
+              <a:rPr/>
+              <a:t>Um contrato de assinatura troca um gasto grande e único por um compromisso contínuo</a:t>
+            </a:r>
+          </a:p>
+          <a:p>
+            <a:pPr lvl="0"/>
+            <a:r>
+              <a:rPr/>
+              <a:t>A saúde financeira de um negócio de assinatura se mede pela renovação, não só pela venda inicial</a:t>
+            </a:r>
+          </a:p>
+          <a:p>
+            <a:pPr lvl="0"/>
+            <a:r>
+              <a:rPr/>
+              <a:t>Cancelamentos custam caro: cada cliente perdido reduz a receita futura já esperada</a:t>
+            </a:r>
+          </a:p>
+        </p:txBody>
+      </p:sp>
+    </p:spTree>
+  </p:cSld>
+</p:sld>
+</file>
+
+<file path=ppt/slides/slide26.xml><?xml version="1.0" encoding="utf-8"?>
+<p:sld xmlns:a="http://schemas.openxmlformats.org/drawingml/2006/main" xmlns:r="http://schemas.openxmlformats.org/officeDocument/2006/relationships" xmlns:p="http://schemas.openxmlformats.org/presentationml/2006/main">
+  <p:cSld>
+    <p:spTree>
+      <p:nvGrpSpPr>
+        <p:cNvPr id="1" name=""/>
+        <p:cNvGrpSpPr/>
+        <p:nvPr/>
+      </p:nvGrpSpPr>
+      <p:grpSpPr>
+        <a:xfrm>
+          <a:off x="0" y="0"/>
+          <a:ext cx="0" cy="0"/>
+          <a:chOff x="0" y="0"/>
+          <a:chExt cx="0" cy="0"/>
+        </a:xfrm>
+      </p:grpSpPr>
+      <p:sp>
+        <p:nvSpPr>
+          <p:cNvPr id="2" name="Title 1"/>
+          <p:cNvSpPr>
+            <a:spLocks noGrp="1"/>
+          </p:cNvSpPr>
+          <p:nvPr>
+            <p:ph type="title"/>
+          </p:nvPr>
+        </p:nvSpPr>
+        <p:spPr>
+          <a:xfrm>
+            <a:off x="722313" y="4406900"/>
+            <a:ext cx="7772400" cy="1362075"/>
+          </a:xfrm>
+        </p:spPr>
+        <p:txBody>
+          <a:bodyPr/>
+          <a:lstStyle/>
+          <a:p>
+            <a:pPr lvl="0" indent="0" marL="0">
+              <a:buNone/>
+            </a:pPr>
+            <a:r>
+              <a:rPr/>
+              <a:t>Inteligência artificial no software</a:t>
+            </a:r>
+          </a:p>
+        </p:txBody>
+      </p:sp>
+    </p:spTree>
+  </p:cSld>
+</p:sld>
+</file>
+
+<file path=ppt/slides/slide27.xml><?xml version="1.0" encoding="utf-8"?>
+<p:sld xmlns:a="http://schemas.openxmlformats.org/drawingml/2006/main" xmlns:r="http://schemas.openxmlformats.org/officeDocument/2006/relationships" xmlns:p="http://schemas.openxmlformats.org/presentationml/2006/main">
+  <p:cSld>
+    <p:spTree>
+      <p:nvGrpSpPr>
+        <p:cNvPr id="1" name=""/>
+        <p:cNvGrpSpPr/>
+        <p:nvPr/>
+      </p:nvGrpSpPr>
+      <p:grpSpPr>
+        <a:xfrm>
+          <a:off x="0" y="0"/>
+          <a:ext cx="0" cy="0"/>
+          <a:chOff x="0" y="0"/>
+          <a:chExt cx="0" cy="0"/>
+        </a:xfrm>
+      </p:grpSpPr>
+      <p:sp>
+        <p:nvSpPr>
+          <p:cNvPr id="2" name="Title 1"/>
+          <p:cNvSpPr>
+            <a:spLocks noGrp="1"/>
+          </p:cNvSpPr>
+          <p:nvPr>
+            <p:ph type="title"/>
+          </p:nvPr>
+        </p:nvSpPr>
+        <p:spPr/>
+        <p:txBody>
+          <a:bodyPr/>
+          <a:lstStyle/>
+          <a:p>
+            <a:pPr lvl="0" indent="0" marL="0">
+              <a:buNone/>
+            </a:pPr>
+            <a:r>
+              <a:rPr/>
+              <a:t>IA como uma nova camada dos produtos digitais</a:t>
+            </a:r>
+          </a:p>
+        </p:txBody>
+      </p:sp>
+      <p:sp>
+        <p:nvSpPr>
+          <p:cNvPr id="3" name="Content Placeholder 2"/>
+          <p:cNvSpPr>
+            <a:spLocks noGrp="1"/>
+          </p:cNvSpPr>
+          <p:nvPr>
+            <p:ph idx="1"/>
+          </p:nvPr>
+        </p:nvSpPr>
+        <p:spPr/>
+        <p:txBody>
+          <a:bodyPr/>
+          <a:lstStyle/>
+          <a:p>
+            <a:pPr lvl="0"/>
+            <a:r>
+              <a:rPr/>
+              <a:t>Até pouco tempo atrás, sistemas seguiam apenas regras fixas, escritas por pessoas</a:t>
+            </a:r>
+          </a:p>
+          <a:p>
+            <a:pPr lvl="0"/>
+            <a:r>
+              <a:rPr/>
+              <a:t>Hoje, a inteligência artificial permite que sistemas entendam linguagem natural e respondam de forma mais flexível</a:t>
+            </a:r>
+          </a:p>
+          <a:p>
+            <a:pPr lvl="0"/>
+            <a:r>
+              <a:rPr/>
+              <a:t>Isso abre espaço para assistentes que conversam com o cliente, resumem informações e ajudam pessoas a decidir mais rápido</a:t>
+            </a:r>
+          </a:p>
+          <a:p>
+            <a:pPr lvl="0"/>
+            <a:r>
+              <a:rPr/>
+              <a:t>O desafio deixou de ser “o sistema entende o pedido?” e passou a ser “a resposta é confiável?”</a:t>
+            </a:r>
+          </a:p>
+        </p:txBody>
+      </p:sp>
+    </p:spTree>
+  </p:cSld>
+</p:sld>
+</file>
+
+<file path=ppt/slides/slide28.xml><?xml version="1.0" encoding="utf-8"?>
 <p:sld xmlns:a="http://schemas.openxmlformats.org/drawingml/2006/main" xmlns:r="http://schemas.openxmlformats.org/officeDocument/2006/relationships" xmlns:p="http://schemas.openxmlformats.org/presentationml/2006/main">
   <p:cSld>
     <p:spTree>
@@ -4810,7 +5718,7 @@
 </p:sld>
 </file>
 
-<file path=ppt/slides/slide21.xml><?xml version="1.0" encoding="utf-8"?>
+<file path=ppt/slides/slide29.xml><?xml version="1.0" encoding="utf-8"?>
 <p:sld xmlns:a="http://schemas.openxmlformats.org/drawingml/2006/main" xmlns:r="http://schemas.openxmlformats.org/officeDocument/2006/relationships" xmlns:p="http://schemas.openxmlformats.org/presentationml/2006/main">
   <p:cSld>
     <p:spTree>
@@ -4862,7 +5770,7 @@
 </p:sld>
 </file>
 
-<file path=ppt/slides/slide22.xml><?xml version="1.0" encoding="utf-8"?>
+<file path=ppt/slides/slide3.xml><?xml version="1.0" encoding="utf-8"?>
 <p:sld xmlns:a="http://schemas.openxmlformats.org/drawingml/2006/main" xmlns:r="http://schemas.openxmlformats.org/officeDocument/2006/relationships" xmlns:p="http://schemas.openxmlformats.org/presentationml/2006/main">
   <p:cSld>
     <p:spTree>
@@ -4889,7 +5797,12 @@
             <p:ph type="title"/>
           </p:nvPr>
         </p:nvSpPr>
-        <p:spPr/>
+        <p:spPr>
+          <a:xfrm>
+            <a:off x="722313" y="4406900"/>
+            <a:ext cx="7772400" cy="1362075"/>
+          </a:xfrm>
+        </p:spPr>
         <p:txBody>
           <a:bodyPr/>
           <a:lstStyle/>
@@ -4899,51 +5812,7 @@
             </a:pPr>
             <a:r>
               <a:rPr/>
-              <a:t>O contexto: NovaSeguro Corretora (exemplo fictício)</a:t>
-            </a:r>
-          </a:p>
-        </p:txBody>
-      </p:sp>
-      <p:sp>
-        <p:nvSpPr>
-          <p:cNvPr id="3" name="Content Placeholder 2"/>
-          <p:cNvSpPr>
-            <a:spLocks noGrp="1"/>
-          </p:cNvSpPr>
-          <p:nvPr>
-            <p:ph idx="1"/>
-          </p:nvPr>
-        </p:nvSpPr>
-        <p:spPr/>
-        <p:txBody>
-          <a:bodyPr/>
-          <a:lstStyle/>
-          <a:p>
-            <a:pPr lvl="0"/>
-            <a:r>
-              <a:rPr/>
-              <a:t>A NovaSeguro trabalha com várias seguradoras parceiras ao mesmo tempo</a:t>
-            </a:r>
-          </a:p>
-          <a:p>
-            <a:pPr lvl="0"/>
-            <a:r>
-              <a:rPr/>
-              <a:t>Cada seguradora tem suas próprias regras, apólices, coberturas e prazos</a:t>
-            </a:r>
-          </a:p>
-          <a:p>
-            <a:pPr lvl="0"/>
-            <a:r>
-              <a:rPr/>
-              <a:t>Os corretores precisam responder perguntas de clientes com rapidez e precisão</a:t>
-            </a:r>
-          </a:p>
-          <a:p>
-            <a:pPr lvl="0"/>
-            <a:r>
-              <a:rPr/>
-              <a:t>Hoje, essa informação está espalhada entre manuais, planilhas e sistemas diferentes</a:t>
+              <a:t>Da ideia ao produto no ar</a:t>
             </a:r>
           </a:p>
         </p:txBody>
@@ -4953,7 +5822,7 @@
 </p:sld>
 </file>
 
-<file path=ppt/slides/slide23.xml><?xml version="1.0" encoding="utf-8"?>
+<file path=ppt/slides/slide30.xml><?xml version="1.0" encoding="utf-8"?>
 <p:sld xmlns:a="http://schemas.openxmlformats.org/drawingml/2006/main" xmlns:r="http://schemas.openxmlformats.org/officeDocument/2006/relationships" xmlns:p="http://schemas.openxmlformats.org/presentationml/2006/main">
   <p:cSld>
     <p:spTree>
@@ -4990,7 +5859,7 @@
             </a:pPr>
             <a:r>
               <a:rPr/>
-              <a:t>O desafio do dia a dia</a:t>
+              <a:t>O contexto: NovaSeguro Corretora (exemplo fictício)</a:t>
             </a:r>
           </a:p>
         </p:txBody>
@@ -5013,28 +5882,28 @@
             <a:pPr lvl="0"/>
             <a:r>
               <a:rPr/>
-              <a:t>Encontrar a informação certa toma tempo e depende de quem está de plantão</a:t>
-            </a:r>
-          </a:p>
-          <a:p>
-            <a:pPr lvl="0"/>
-            <a:r>
-              <a:rPr/>
-              <a:t>É difícil comparar coberturas entre seguradoras diferentes na hora da conversa com o cliente</a:t>
-            </a:r>
-          </a:p>
-          <a:p>
-            <a:pPr lvl="0"/>
-            <a:r>
-              <a:rPr/>
-              <a:t>Perguntas mais complexas, como possíveis sobreposições de cobertura, quase nunca são respondidas na hora</a:t>
-            </a:r>
-          </a:p>
-          <a:p>
-            <a:pPr lvl="0"/>
-            <a:r>
-              <a:rPr/>
-              <a:t>O resultado é atendimento mais lento e risco de informação incorreta</a:t>
+              <a:t>A NovaSeguro trabalha com várias seguradoras parceiras ao mesmo tempo</a:t>
+            </a:r>
+          </a:p>
+          <a:p>
+            <a:pPr lvl="0"/>
+            <a:r>
+              <a:rPr/>
+              <a:t>Cada seguradora tem suas próprias regras, apólices, coberturas e prazos</a:t>
+            </a:r>
+          </a:p>
+          <a:p>
+            <a:pPr lvl="0"/>
+            <a:r>
+              <a:rPr/>
+              <a:t>Os corretores precisam responder perguntas de clientes com rapidez e precisão</a:t>
+            </a:r>
+          </a:p>
+          <a:p>
+            <a:pPr lvl="0"/>
+            <a:r>
+              <a:rPr/>
+              <a:t>Hoje, essa informação está espalhada entre manuais, planilhas e sistemas diferentes</a:t>
             </a:r>
           </a:p>
         </p:txBody>
@@ -5044,7 +5913,98 @@
 </p:sld>
 </file>
 
-<file path=ppt/slides/slide24.xml><?xml version="1.0" encoding="utf-8"?>
+<file path=ppt/slides/slide31.xml><?xml version="1.0" encoding="utf-8"?>
+<p:sld xmlns:a="http://schemas.openxmlformats.org/drawingml/2006/main" xmlns:r="http://schemas.openxmlformats.org/officeDocument/2006/relationships" xmlns:p="http://schemas.openxmlformats.org/presentationml/2006/main">
+  <p:cSld>
+    <p:spTree>
+      <p:nvGrpSpPr>
+        <p:cNvPr id="1" name=""/>
+        <p:cNvGrpSpPr/>
+        <p:nvPr/>
+      </p:nvGrpSpPr>
+      <p:grpSpPr>
+        <a:xfrm>
+          <a:off x="0" y="0"/>
+          <a:ext cx="0" cy="0"/>
+          <a:chOff x="0" y="0"/>
+          <a:chExt cx="0" cy="0"/>
+        </a:xfrm>
+      </p:grpSpPr>
+      <p:sp>
+        <p:nvSpPr>
+          <p:cNvPr id="2" name="Title 1"/>
+          <p:cNvSpPr>
+            <a:spLocks noGrp="1"/>
+          </p:cNvSpPr>
+          <p:nvPr>
+            <p:ph type="title"/>
+          </p:nvPr>
+        </p:nvSpPr>
+        <p:spPr/>
+        <p:txBody>
+          <a:bodyPr/>
+          <a:lstStyle/>
+          <a:p>
+            <a:pPr lvl="0" indent="0" marL="0">
+              <a:buNone/>
+            </a:pPr>
+            <a:r>
+              <a:rPr/>
+              <a:t>O desafio do dia a dia</a:t>
+            </a:r>
+          </a:p>
+        </p:txBody>
+      </p:sp>
+      <p:sp>
+        <p:nvSpPr>
+          <p:cNvPr id="3" name="Content Placeholder 2"/>
+          <p:cNvSpPr>
+            <a:spLocks noGrp="1"/>
+          </p:cNvSpPr>
+          <p:nvPr>
+            <p:ph idx="1"/>
+          </p:nvPr>
+        </p:nvSpPr>
+        <p:spPr/>
+        <p:txBody>
+          <a:bodyPr/>
+          <a:lstStyle/>
+          <a:p>
+            <a:pPr lvl="0"/>
+            <a:r>
+              <a:rPr/>
+              <a:t>Encontrar a informação certa toma tempo e depende de quem está de plantão</a:t>
+            </a:r>
+          </a:p>
+          <a:p>
+            <a:pPr lvl="0"/>
+            <a:r>
+              <a:rPr/>
+              <a:t>É difícil comparar coberturas entre seguradoras diferentes na hora da conversa com o cliente</a:t>
+            </a:r>
+          </a:p>
+          <a:p>
+            <a:pPr lvl="0"/>
+            <a:r>
+              <a:rPr/>
+              <a:t>Perguntas mais complexas, como possíveis sobreposições de cobertura, quase nunca são respondidas na hora</a:t>
+            </a:r>
+          </a:p>
+          <a:p>
+            <a:pPr lvl="0"/>
+            <a:r>
+              <a:rPr/>
+              <a:t>O resultado é atendimento mais lento e risco de informação incorreta</a:t>
+            </a:r>
+          </a:p>
+        </p:txBody>
+      </p:sp>
+    </p:spTree>
+  </p:cSld>
+</p:sld>
+</file>
+
+<file path=ppt/slides/slide32.xml><?xml version="1.0" encoding="utf-8"?>
 <p:sld xmlns:a="http://schemas.openxmlformats.org/drawingml/2006/main" xmlns:r="http://schemas.openxmlformats.org/officeDocument/2006/relationships" xmlns:p="http://schemas.openxmlformats.org/presentationml/2006/main">
   <p:cSld>
     <p:spTree>
@@ -5121,7 +6081,7 @@
 </p:sld>
 </file>
 
-<file path=ppt/slides/slide25.xml><?xml version="1.0" encoding="utf-8"?>
+<file path=ppt/slides/slide33.xml><?xml version="1.0" encoding="utf-8"?>
 <p:sld xmlns:a="http://schemas.openxmlformats.org/drawingml/2006/main" xmlns:r="http://schemas.openxmlformats.org/officeDocument/2006/relationships" xmlns:p="http://schemas.openxmlformats.org/presentationml/2006/main">
   <p:cSld>
     <p:spTree>
@@ -5212,7 +6172,7 @@
 </p:sld>
 </file>
 
-<file path=ppt/slides/slide26.xml><?xml version="1.0" encoding="utf-8"?>
+<file path=ppt/slides/slide34.xml><?xml version="1.0" encoding="utf-8"?>
 <p:sld xmlns:a="http://schemas.openxmlformats.org/drawingml/2006/main" xmlns:r="http://schemas.openxmlformats.org/officeDocument/2006/relationships" xmlns:p="http://schemas.openxmlformats.org/presentationml/2006/main">
   <p:cSld>
     <p:spTree>
@@ -5303,7 +6263,7 @@
 </p:sld>
 </file>
 
-<file path=ppt/slides/slide27.xml><?xml version="1.0" encoding="utf-8"?>
+<file path=ppt/slides/slide35.xml><?xml version="1.0" encoding="utf-8"?>
 <p:sld xmlns:a="http://schemas.openxmlformats.org/drawingml/2006/main" xmlns:r="http://schemas.openxmlformats.org/officeDocument/2006/relationships" xmlns:p="http://schemas.openxmlformats.org/presentationml/2006/main">
   <p:cSld>
     <p:spTree>
@@ -5394,7 +6354,7 @@
 </p:sld>
 </file>
 
-<file path=ppt/slides/slide28.xml><?xml version="1.0" encoding="utf-8"?>
+<file path=ppt/slides/slide36.xml><?xml version="1.0" encoding="utf-8"?>
 <p:sld xmlns:a="http://schemas.openxmlformats.org/drawingml/2006/main" xmlns:r="http://schemas.openxmlformats.org/officeDocument/2006/relationships" xmlns:p="http://schemas.openxmlformats.org/presentationml/2006/main">
   <p:cSld>
     <p:spTree>
@@ -5485,7 +6445,7 @@
 </p:sld>
 </file>
 
-<file path=ppt/slides/slide29.xml><?xml version="1.0" encoding="utf-8"?>
+<file path=ppt/slides/slide37.xml><?xml version="1.0" encoding="utf-8"?>
 <p:sld xmlns:a="http://schemas.openxmlformats.org/drawingml/2006/main" xmlns:r="http://schemas.openxmlformats.org/officeDocument/2006/relationships" xmlns:p="http://schemas.openxmlformats.org/presentationml/2006/main">
   <p:cSld>
     <p:spTree>
@@ -5537,7 +6497,7 @@
 </p:sld>
 </file>
 
-<file path=ppt/slides/slide3.xml><?xml version="1.0" encoding="utf-8"?>
+<file path=ppt/slides/slide38.xml><?xml version="1.0" encoding="utf-8"?>
 <p:sld xmlns:a="http://schemas.openxmlformats.org/drawingml/2006/main" xmlns:r="http://schemas.openxmlformats.org/officeDocument/2006/relationships" xmlns:p="http://schemas.openxmlformats.org/presentationml/2006/main">
   <p:cSld>
     <p:spTree>
@@ -5564,12 +6524,7 @@
             <p:ph type="title"/>
           </p:nvPr>
         </p:nvSpPr>
-        <p:spPr>
-          <a:xfrm>
-            <a:off x="722313" y="4406900"/>
-            <a:ext cx="7772400" cy="1362075"/>
-          </a:xfrm>
-        </p:spPr>
+        <p:spPr/>
         <p:txBody>
           <a:bodyPr/>
           <a:lstStyle/>
@@ -5579,7 +6534,51 @@
             </a:pPr>
             <a:r>
               <a:rPr/>
-              <a:t>Da ideia ao produto no ar</a:t>
+              <a:t>O que vale levar desta conversa</a:t>
+            </a:r>
+          </a:p>
+        </p:txBody>
+      </p:sp>
+      <p:sp>
+        <p:nvSpPr>
+          <p:cNvPr id="3" name="Content Placeholder 2"/>
+          <p:cNvSpPr>
+            <a:spLocks noGrp="1"/>
+          </p:cNvSpPr>
+          <p:nvPr>
+            <p:ph idx="1"/>
+          </p:nvPr>
+        </p:nvSpPr>
+        <p:spPr/>
+        <p:txBody>
+          <a:bodyPr/>
+          <a:lstStyle/>
+          <a:p>
+            <a:pPr lvl="0"/>
+            <a:r>
+              <a:rPr/>
+              <a:t>Todo produto e toda funcionalidade seguem um ciclo, da oportunidade ao aprendizado</a:t>
+            </a:r>
+          </a:p>
+          <a:p>
+            <a:pPr lvl="0"/>
+            <a:r>
+              <a:rPr/>
+              <a:t>Product Owner, System Engineer e Tech Lead olham para o mesmo problema sob ângulos diferentes</a:t>
+            </a:r>
+          </a:p>
+          <a:p>
+            <a:pPr lvl="0"/>
+            <a:r>
+              <a:rPr/>
+              <a:t>Ciclos curtos e validação rápida reduzem risco e aceleram resultados</a:t>
+            </a:r>
+          </a:p>
+          <a:p>
+            <a:pPr lvl="0"/>
+            <a:r>
+              <a:rPr/>
+              <a:t>A inteligência artificial adiciona uma nova camada de valor, mas exige dados confiáveis e boa governança</a:t>
             </a:r>
           </a:p>
         </p:txBody>
@@ -5589,98 +6588,7 @@
 </p:sld>
 </file>
 
-<file path=ppt/slides/slide30.xml><?xml version="1.0" encoding="utf-8"?>
-<p:sld xmlns:a="http://schemas.openxmlformats.org/drawingml/2006/main" xmlns:r="http://schemas.openxmlformats.org/officeDocument/2006/relationships" xmlns:p="http://schemas.openxmlformats.org/presentationml/2006/main">
-  <p:cSld>
-    <p:spTree>
-      <p:nvGrpSpPr>
-        <p:cNvPr id="1" name=""/>
-        <p:cNvGrpSpPr/>
-        <p:nvPr/>
-      </p:nvGrpSpPr>
-      <p:grpSpPr>
-        <a:xfrm>
-          <a:off x="0" y="0"/>
-          <a:ext cx="0" cy="0"/>
-          <a:chOff x="0" y="0"/>
-          <a:chExt cx="0" cy="0"/>
-        </a:xfrm>
-      </p:grpSpPr>
-      <p:sp>
-        <p:nvSpPr>
-          <p:cNvPr id="2" name="Title 1"/>
-          <p:cNvSpPr>
-            <a:spLocks noGrp="1"/>
-          </p:cNvSpPr>
-          <p:nvPr>
-            <p:ph type="title"/>
-          </p:nvPr>
-        </p:nvSpPr>
-        <p:spPr/>
-        <p:txBody>
-          <a:bodyPr/>
-          <a:lstStyle/>
-          <a:p>
-            <a:pPr lvl="0" indent="0" marL="0">
-              <a:buNone/>
-            </a:pPr>
-            <a:r>
-              <a:rPr/>
-              <a:t>O que vale levar desta conversa</a:t>
-            </a:r>
-          </a:p>
-        </p:txBody>
-      </p:sp>
-      <p:sp>
-        <p:nvSpPr>
-          <p:cNvPr id="3" name="Content Placeholder 2"/>
-          <p:cNvSpPr>
-            <a:spLocks noGrp="1"/>
-          </p:cNvSpPr>
-          <p:nvPr>
-            <p:ph idx="1"/>
-          </p:nvPr>
-        </p:nvSpPr>
-        <p:spPr/>
-        <p:txBody>
-          <a:bodyPr/>
-          <a:lstStyle/>
-          <a:p>
-            <a:pPr lvl="0"/>
-            <a:r>
-              <a:rPr/>
-              <a:t>Todo produto e toda funcionalidade seguem um ciclo, da oportunidade ao aprendizado</a:t>
-            </a:r>
-          </a:p>
-          <a:p>
-            <a:pPr lvl="0"/>
-            <a:r>
-              <a:rPr/>
-              <a:t>Product Owner, System Engineer e Tech Lead olham para o mesmo problema sob ângulos diferentes</a:t>
-            </a:r>
-          </a:p>
-          <a:p>
-            <a:pPr lvl="0"/>
-            <a:r>
-              <a:rPr/>
-              <a:t>Ciclos curtos e validação rápida reduzem risco e aceleram resultados</a:t>
-            </a:r>
-          </a:p>
-          <a:p>
-            <a:pPr lvl="0"/>
-            <a:r>
-              <a:rPr/>
-              <a:t>A inteligência artificial adiciona uma nova camada de valor, mas exige dados confiáveis e boa governança</a:t>
-            </a:r>
-          </a:p>
-        </p:txBody>
-      </p:sp>
-    </p:spTree>
-  </p:cSld>
-</p:sld>
-</file>
-
-<file path=ppt/slides/slide31.xml><?xml version="1.0" encoding="utf-8"?>
+<file path=ppt/slides/slide39.xml><?xml version="1.0" encoding="utf-8"?>
 <p:sld xmlns:a="http://schemas.openxmlformats.org/drawingml/2006/main" xmlns:r="http://schemas.openxmlformats.org/officeDocument/2006/relationships" xmlns:p="http://schemas.openxmlformats.org/presentationml/2006/main">
   <p:cSld>
     <p:spTree>

</xml_diff>

<commit_message>
Adiciona seção sobre métricas de sucesso de produto e negócio
Nova seção "Como medir o sucesso de um produto", posicionada após "Comprar
ou construir" e antes de "Inteligência artificial", cobrindo:
- por que medir fecha o ciclo de aprendizado do produto
- três grupos de métricas: uso/adoção, receita/retenção, satisfação
- licenças/usuários ativos como sinal de uso real, não só de venda
- % de renovação como termômetro da saúde do negócio
- o risco de métricas de vaidade vs. métricas que realmente importam

Inclui 2 novos diagramas gerados com Matplotlib, mantendo a identidade
visual do deck.

Co-Authored-By: Claude Sonnet 5 <noreply@anthropic.com>
Claude-Session: https://claude.ai/code/session_017dKXPAcE5bAggx1M3V9VCU
</commit_message>
<xml_diff>
--- a/presentation/apresentacao.pptx
+++ b/presentation/apresentacao.pptx
@@ -5,7 +5,7 @@
     <p:sldMasterId id="2147483648" r:id="rId1"/>
   </p:sldMasterIdLst>
   <p:notesMasterIdLst>
-    <p:notesMasterId r:id="rId41"/>
+    <p:notesMasterId r:id="rId48"/>
   </p:notesMasterIdLst>
   <p:sldIdLst>
     <p:sldId id="256" r:id="rId2"/>
@@ -47,6 +47,13 @@
     <p:sldId id="292" r:id="rId38"/>
     <p:sldId id="293" r:id="rId39"/>
     <p:sldId id="294" r:id="rId40"/>
+    <p:sldId id="295" r:id="rId41"/>
+    <p:sldId id="296" r:id="rId42"/>
+    <p:sldId id="297" r:id="rId43"/>
+    <p:sldId id="298" r:id="rId44"/>
+    <p:sldId id="299" r:id="rId45"/>
+    <p:sldId id="300" r:id="rId46"/>
+    <p:sldId id="301" r:id="rId47"/>
   </p:sldIdLst>
   <p:sldSz cx="12191695" cy="6858000" type="screen4x3"/>
   <p:notesSz cx="6858000" cy="9144000"/>
@@ -956,7 +963,7 @@
             </a:pPr>
             <a:r>
               <a:rPr/>
-              <a:t>RAG: o assistente busca em documentos relevantes antes de responder, como um bom atendente que consulta o manual certo. GraphRAG vai além: entende como as informações se conectam entre si, como um mapa de relacionamentos, o que ajuda a responder perguntas mais complexas.</a:t>
+              <a:t>Uso e adoção mostram se o produto está sendo aproveitado de verdade. Receita e retenção mostram a saúde financeira do negócio. Satisfação mostra se o cliente recomendaria o produto a outra pessoa. Os três juntos dão uma visão completa; olhar só para um deles esconde parte do quadro.</a:t>
             </a:r>
           </a:p>
         </p:txBody>
@@ -979,6 +986,170 @@
             <a:fld id="{18BDFEC3-8487-43E8-A154-7C12CBC1FFF2}" type="slidenum">
               <a:rPr lang="en-US"/>
               <a:t>28</a:t>
+            </a:fld>
+            <a:endParaRPr lang="en-US"/>
+          </a:p>
+        </p:txBody>
+      </p:sp>
+    </p:spTree>
+  </p:cSld>
+</p:notes>
+</file>
+
+<file path=ppt/notesSlides/notesSlide7.xml><?xml version="1.0" encoding="utf-8"?>
+<p:notes xmlns:a="http://schemas.openxmlformats.org/drawingml/2006/main" xmlns:r="http://schemas.openxmlformats.org/officeDocument/2006/relationships" xmlns:p="http://schemas.openxmlformats.org/presentationml/2006/main">
+  <p:cSld>
+    <p:spTree>
+      <p:nvGrpSpPr>
+        <p:cNvPr id="1" name=""/>
+        <p:cNvGrpSpPr/>
+        <p:nvPr/>
+      </p:nvGrpSpPr>
+      <p:grpSpPr>
+        <a:xfrm>
+          <a:off x="0" y="0"/>
+          <a:ext cx="0" cy="0"/>
+          <a:chOff x="0" y="0"/>
+          <a:chExt cx="0" cy="0"/>
+        </a:xfrm>
+      </p:grpSpPr>
+      <p:sp>
+        <p:nvSpPr>
+          <p:cNvPr id="2" name="Slide Image Placeholder 1"/>
+          <p:cNvSpPr>
+            <a:spLocks noGrp="1" noRot="1" noChangeAspect="1"/>
+          </p:cNvSpPr>
+          <p:nvPr>
+            <p:ph type="sldImg"/>
+          </p:nvPr>
+        </p:nvSpPr>
+        <p:spPr/>
+      </p:sp>
+      <p:sp>
+        <p:nvSpPr>
+          <p:cNvPr id="3" name="Notes Placeholder 2"/>
+          <p:cNvSpPr>
+            <a:spLocks noGrp="1"/>
+          </p:cNvSpPr>
+          <p:nvPr>
+            <p:ph type="body" idx="1"/>
+          </p:nvPr>
+        </p:nvSpPr>
+        <p:spPr/>
+        <p:txBody>
+          <a:bodyPr/>
+          <a:lstStyle/>
+          <a:p>
+            <a:pPr lvl="0" indent="0" marL="0">
+              <a:buNone/>
+            </a:pPr>
+            <a:r>
+              <a:rPr/>
+              <a:t>É tentador comemorar números grandes e visíveis, como total de downloads ou visitas. Mas esses números podem crescer mesmo que o produto não esteja gerando valor real. O time de negócio deve sempre perguntar: essa métrica prova que o cliente está satisfeito e vai continuar pagando?</a:t>
+            </a:r>
+          </a:p>
+        </p:txBody>
+      </p:sp>
+      <p:sp>
+        <p:nvSpPr>
+          <p:cNvPr id="4" name="Slide Number Placeholder 3"/>
+          <p:cNvSpPr>
+            <a:spLocks noGrp="1"/>
+          </p:cNvSpPr>
+          <p:nvPr>
+            <p:ph type="sldNum" sz="quarter" idx="10"/>
+          </p:nvPr>
+        </p:nvSpPr>
+        <p:spPr/>
+        <p:txBody>
+          <a:bodyPr/>
+          <a:lstStyle/>
+          <a:p>
+            <a:fld id="{18BDFEC3-8487-43E8-A154-7C12CBC1FFF2}" type="slidenum">
+              <a:rPr lang="en-US"/>
+              <a:t>31</a:t>
+            </a:fld>
+            <a:endParaRPr lang="en-US"/>
+          </a:p>
+        </p:txBody>
+      </p:sp>
+    </p:spTree>
+  </p:cSld>
+</p:notes>
+</file>
+
+<file path=ppt/notesSlides/notesSlide8.xml><?xml version="1.0" encoding="utf-8"?>
+<p:notes xmlns:a="http://schemas.openxmlformats.org/drawingml/2006/main" xmlns:r="http://schemas.openxmlformats.org/officeDocument/2006/relationships" xmlns:p="http://schemas.openxmlformats.org/presentationml/2006/main">
+  <p:cSld>
+    <p:spTree>
+      <p:nvGrpSpPr>
+        <p:cNvPr id="1" name=""/>
+        <p:cNvGrpSpPr/>
+        <p:nvPr/>
+      </p:nvGrpSpPr>
+      <p:grpSpPr>
+        <a:xfrm>
+          <a:off x="0" y="0"/>
+          <a:ext cx="0" cy="0"/>
+          <a:chOff x="0" y="0"/>
+          <a:chExt cx="0" cy="0"/>
+        </a:xfrm>
+      </p:grpSpPr>
+      <p:sp>
+        <p:nvSpPr>
+          <p:cNvPr id="2" name="Slide Image Placeholder 1"/>
+          <p:cNvSpPr>
+            <a:spLocks noGrp="1" noRot="1" noChangeAspect="1"/>
+          </p:cNvSpPr>
+          <p:nvPr>
+            <p:ph type="sldImg"/>
+          </p:nvPr>
+        </p:nvSpPr>
+        <p:spPr/>
+      </p:sp>
+      <p:sp>
+        <p:nvSpPr>
+          <p:cNvPr id="3" name="Notes Placeholder 2"/>
+          <p:cNvSpPr>
+            <a:spLocks noGrp="1"/>
+          </p:cNvSpPr>
+          <p:nvPr>
+            <p:ph type="body" idx="1"/>
+          </p:nvPr>
+        </p:nvSpPr>
+        <p:spPr/>
+        <p:txBody>
+          <a:bodyPr/>
+          <a:lstStyle/>
+          <a:p>
+            <a:pPr lvl="0" indent="0" marL="0">
+              <a:buNone/>
+            </a:pPr>
+            <a:r>
+              <a:rPr/>
+              <a:t>RAG: o assistente busca em documentos relevantes antes de responder, como um bom atendente que consulta o manual certo. GraphRAG vai além: entende como as informações se conectam entre si, como um mapa de relacionamentos, o que ajuda a responder perguntas mais complexas.</a:t>
+            </a:r>
+          </a:p>
+        </p:txBody>
+      </p:sp>
+      <p:sp>
+        <p:nvSpPr>
+          <p:cNvPr id="4" name="Slide Number Placeholder 3"/>
+          <p:cNvSpPr>
+            <a:spLocks noGrp="1"/>
+          </p:cNvSpPr>
+          <p:nvPr>
+            <p:ph type="sldNum" sz="quarter" idx="10"/>
+          </p:nvPr>
+        </p:nvSpPr>
+        <p:spPr/>
+        <p:txBody>
+          <a:bodyPr/>
+          <a:lstStyle/>
+          <a:p>
+            <a:fld id="{18BDFEC3-8487-43E8-A154-7C12CBC1FFF2}" type="slidenum">
+              <a:rPr lang="en-US"/>
+              <a:t>35</a:t>
             </a:fld>
             <a:endParaRPr lang="en-US"/>
           </a:p>
@@ -4963,6 +5134,13 @@
             <a:pPr lvl="0"/>
             <a:r>
               <a:rPr/>
+              <a:t>Como medir o sucesso de um produto</a:t>
+            </a:r>
+          </a:p>
+          <a:p>
+            <a:pPr lvl="0"/>
+            <a:r>
+              <a:rPr/>
               <a:t>Inteligência artificial no software</a:t>
             </a:r>
           </a:p>
@@ -5540,7 +5718,7 @@
             </a:pPr>
             <a:r>
               <a:rPr/>
-              <a:t>Inteligência artificial no software</a:t>
+              <a:t>Como medir o sucesso de um produto</a:t>
             </a:r>
           </a:p>
         </p:txBody>
@@ -5587,7 +5765,7 @@
             </a:pPr>
             <a:r>
               <a:rPr/>
-              <a:t>IA como uma nova camada dos produtos digitais</a:t>
+              <a:t>Por que medir importa</a:t>
             </a:r>
           </a:p>
         </p:txBody>
@@ -5610,28 +5788,28 @@
             <a:pPr lvl="0"/>
             <a:r>
               <a:rPr/>
-              <a:t>Até pouco tempo atrás, sistemas seguiam apenas regras fixas, escritas por pessoas</a:t>
-            </a:r>
-          </a:p>
-          <a:p>
-            <a:pPr lvl="0"/>
-            <a:r>
-              <a:rPr/>
-              <a:t>Hoje, a inteligência artificial permite que sistemas entendam linguagem natural e respondam de forma mais flexível</a:t>
-            </a:r>
-          </a:p>
-          <a:p>
-            <a:pPr lvl="0"/>
-            <a:r>
-              <a:rPr/>
-              <a:t>Isso abre espaço para assistentes que conversam com o cliente, resumem informações e ajudam pessoas a decidir mais rápido</a:t>
-            </a:r>
-          </a:p>
-          <a:p>
-            <a:pPr lvl="0"/>
-            <a:r>
-              <a:rPr/>
-              <a:t>O desafio deixou de ser “o sistema entende o pedido?” e passou a ser “a resposta é confiável?”</a:t>
+              <a:t>Lançar um produto ou uma funcionalidade não é o fim da história, é o começo de uma nova etapa</a:t>
+            </a:r>
+          </a:p>
+          <a:p>
+            <a:pPr lvl="0"/>
+            <a:r>
+              <a:rPr/>
+              <a:t>Sem números, decisões viram opinião: “eu acho que está indo bem” não é o mesmo que saber</a:t>
+            </a:r>
+          </a:p>
+          <a:p>
+            <a:pPr lvl="0"/>
+            <a:r>
+              <a:rPr/>
+              <a:t>Métricas bem escolhidas mostram se o problema do cliente foi realmente resolvido</a:t>
+            </a:r>
+          </a:p>
+          <a:p>
+            <a:pPr lvl="0"/>
+            <a:r>
+              <a:rPr/>
+              <a:t>É esse acompanhamento que fecha o ciclo de aprendizado visto no início desta conversa</a:t>
             </a:r>
           </a:p>
         </p:txBody>
@@ -5642,6 +5820,628 @@
 </file>
 
 <file path=ppt/slides/slide28.xml><?xml version="1.0" encoding="utf-8"?>
+<p:sld xmlns:a="http://schemas.openxmlformats.org/drawingml/2006/main" xmlns:r="http://schemas.openxmlformats.org/officeDocument/2006/relationships" xmlns:p="http://schemas.openxmlformats.org/presentationml/2006/main">
+  <p:cSld>
+    <p:spTree>
+      <p:nvGrpSpPr>
+        <p:cNvPr id="1" name=""/>
+        <p:cNvGrpSpPr/>
+        <p:nvPr/>
+      </p:nvGrpSpPr>
+      <p:grpSpPr>
+        <a:xfrm>
+          <a:off x="0" y="0"/>
+          <a:ext cx="0" cy="0"/>
+          <a:chOff x="0" y="0"/>
+          <a:chExt cx="0" cy="0"/>
+        </a:xfrm>
+      </p:grpSpPr>
+      <p:sp>
+        <p:nvSpPr>
+          <p:cNvPr id="2" name="Title 1"/>
+          <p:cNvSpPr>
+            <a:spLocks noGrp="1"/>
+          </p:cNvSpPr>
+          <p:nvPr>
+            <p:ph type="title"/>
+          </p:nvPr>
+        </p:nvSpPr>
+        <p:spPr/>
+        <p:txBody>
+          <a:bodyPr/>
+          <a:lstStyle/>
+          <a:p>
+            <a:pPr lvl="0" indent="0" marL="0">
+              <a:buNone/>
+            </a:pPr>
+            <a:r>
+              <a:rPr/>
+              <a:t>Três grupos de métricas para acompanhar</a:t>
+            </a:r>
+          </a:p>
+        </p:txBody>
+      </p:sp>
+      <p:pic>
+        <p:nvPicPr>
+          <p:cNvPr descr="assets/diagrama_metricas_sucesso.png" id="0" name="Picture 1"/>
+          <p:cNvPicPr>
+            <a:picLocks noGrp="1" noChangeAspect="1"/>
+          </p:cNvPicPr>
+          <p:nvPr/>
+        </p:nvPicPr>
+        <p:blipFill>
+          <a:blip r:embed="rId3"/>
+          <a:stretch>
+            <a:fillRect/>
+          </a:stretch>
+        </p:blipFill>
+        <p:spPr bwMode="auto">
+          <a:xfrm>
+            <a:off x="457200" y="1968500"/>
+            <a:ext cx="8229600" cy="3797300"/>
+          </a:xfrm>
+          <a:prstGeom prst="rect">
+            <a:avLst/>
+          </a:prstGeom>
+          <a:noFill/>
+          <a:ln w="9525">
+            <a:noFill/>
+            <a:headEnd/>
+            <a:tailEnd/>
+          </a:ln>
+        </p:spPr>
+      </p:pic>
+    </p:spTree>
+  </p:cSld>
+</p:sld>
+</file>
+
+<file path=ppt/slides/slide29.xml><?xml version="1.0" encoding="utf-8"?>
+<p:sld xmlns:a="http://schemas.openxmlformats.org/drawingml/2006/main" xmlns:r="http://schemas.openxmlformats.org/officeDocument/2006/relationships" xmlns:p="http://schemas.openxmlformats.org/presentationml/2006/main">
+  <p:cSld>
+    <p:spTree>
+      <p:nvGrpSpPr>
+        <p:cNvPr id="1" name=""/>
+        <p:cNvGrpSpPr/>
+        <p:nvPr/>
+      </p:nvGrpSpPr>
+      <p:grpSpPr>
+        <a:xfrm>
+          <a:off x="0" y="0"/>
+          <a:ext cx="0" cy="0"/>
+          <a:chOff x="0" y="0"/>
+          <a:chExt cx="0" cy="0"/>
+        </a:xfrm>
+      </p:grpSpPr>
+      <p:sp>
+        <p:nvSpPr>
+          <p:cNvPr id="2" name="Title 1"/>
+          <p:cNvSpPr>
+            <a:spLocks noGrp="1"/>
+          </p:cNvSpPr>
+          <p:nvPr>
+            <p:ph type="title"/>
+          </p:nvPr>
+        </p:nvSpPr>
+        <p:spPr/>
+        <p:txBody>
+          <a:bodyPr/>
+          <a:lstStyle/>
+          <a:p>
+            <a:pPr lvl="0" indent="0" marL="0">
+              <a:buNone/>
+            </a:pPr>
+            <a:r>
+              <a:rPr/>
+              <a:t>Licenças ativas: quantidade não é tudo</a:t>
+            </a:r>
+          </a:p>
+        </p:txBody>
+      </p:sp>
+      <p:sp>
+        <p:nvSpPr>
+          <p:cNvPr id="3" name="Content Placeholder 2"/>
+          <p:cNvSpPr>
+            <a:spLocks noGrp="1"/>
+          </p:cNvSpPr>
+          <p:nvPr>
+            <p:ph idx="1"/>
+          </p:nvPr>
+        </p:nvSpPr>
+        <p:spPr/>
+        <p:txBody>
+          <a:bodyPr/>
+          <a:lstStyle/>
+          <a:p>
+            <a:pPr lvl="0"/>
+            <a:r>
+              <a:rPr/>
+              <a:t>Contar licenças ou usuários ativos é o primeiro passo, mas não o único</a:t>
+            </a:r>
+          </a:p>
+          <a:p>
+            <a:pPr lvl="0"/>
+            <a:r>
+              <a:rPr/>
+              <a:t>Uma licença comprada e nunca usada é um sinal de alerta, não de sucesso</a:t>
+            </a:r>
+          </a:p>
+          <a:p>
+            <a:pPr lvl="0"/>
+            <a:r>
+              <a:rPr/>
+              <a:t>O que importa é a proporção de usuários que voltam a usar o produto com frequência</a:t>
+            </a:r>
+          </a:p>
+          <a:p>
+            <a:pPr lvl="0"/>
+            <a:r>
+              <a:rPr/>
+              <a:t>Esse número ajuda a antecipar cancelamentos antes que eles aconteçam</a:t>
+            </a:r>
+          </a:p>
+        </p:txBody>
+      </p:sp>
+    </p:spTree>
+  </p:cSld>
+</p:sld>
+</file>
+
+<file path=ppt/slides/slide3.xml><?xml version="1.0" encoding="utf-8"?>
+<p:sld xmlns:a="http://schemas.openxmlformats.org/drawingml/2006/main" xmlns:r="http://schemas.openxmlformats.org/officeDocument/2006/relationships" xmlns:p="http://schemas.openxmlformats.org/presentationml/2006/main">
+  <p:cSld>
+    <p:spTree>
+      <p:nvGrpSpPr>
+        <p:cNvPr id="1" name=""/>
+        <p:cNvGrpSpPr/>
+        <p:nvPr/>
+      </p:nvGrpSpPr>
+      <p:grpSpPr>
+        <a:xfrm>
+          <a:off x="0" y="0"/>
+          <a:ext cx="0" cy="0"/>
+          <a:chOff x="0" y="0"/>
+          <a:chExt cx="0" cy="0"/>
+        </a:xfrm>
+      </p:grpSpPr>
+      <p:sp>
+        <p:nvSpPr>
+          <p:cNvPr id="2" name="Title 1"/>
+          <p:cNvSpPr>
+            <a:spLocks noGrp="1"/>
+          </p:cNvSpPr>
+          <p:nvPr>
+            <p:ph type="title"/>
+          </p:nvPr>
+        </p:nvSpPr>
+        <p:spPr>
+          <a:xfrm>
+            <a:off x="722313" y="4406900"/>
+            <a:ext cx="7772400" cy="1362075"/>
+          </a:xfrm>
+        </p:spPr>
+        <p:txBody>
+          <a:bodyPr/>
+          <a:lstStyle/>
+          <a:p>
+            <a:pPr lvl="0" indent="0" marL="0">
+              <a:buNone/>
+            </a:pPr>
+            <a:r>
+              <a:rPr/>
+              <a:t>Da ideia ao produto no ar</a:t>
+            </a:r>
+          </a:p>
+        </p:txBody>
+      </p:sp>
+    </p:spTree>
+  </p:cSld>
+</p:sld>
+</file>
+
+<file path=ppt/slides/slide30.xml><?xml version="1.0" encoding="utf-8"?>
+<p:sld xmlns:a="http://schemas.openxmlformats.org/drawingml/2006/main" xmlns:r="http://schemas.openxmlformats.org/officeDocument/2006/relationships" xmlns:p="http://schemas.openxmlformats.org/presentationml/2006/main">
+  <p:cSld>
+    <p:spTree>
+      <p:nvGrpSpPr>
+        <p:cNvPr id="1" name=""/>
+        <p:cNvGrpSpPr/>
+        <p:nvPr/>
+      </p:nvGrpSpPr>
+      <p:grpSpPr>
+        <a:xfrm>
+          <a:off x="0" y="0"/>
+          <a:ext cx="0" cy="0"/>
+          <a:chOff x="0" y="0"/>
+          <a:chExt cx="0" cy="0"/>
+        </a:xfrm>
+      </p:grpSpPr>
+      <p:sp>
+        <p:nvSpPr>
+          <p:cNvPr id="2" name="Title 1"/>
+          <p:cNvSpPr>
+            <a:spLocks noGrp="1"/>
+          </p:cNvSpPr>
+          <p:nvPr>
+            <p:ph type="title"/>
+          </p:nvPr>
+        </p:nvSpPr>
+        <p:spPr/>
+        <p:txBody>
+          <a:bodyPr/>
+          <a:lstStyle/>
+          <a:p>
+            <a:pPr lvl="0" indent="0" marL="0">
+              <a:buNone/>
+            </a:pPr>
+            <a:r>
+              <a:rPr/>
+              <a:t>A porcentagem de renovação: o termômetro do negócio</a:t>
+            </a:r>
+          </a:p>
+        </p:txBody>
+      </p:sp>
+      <p:sp>
+        <p:nvSpPr>
+          <p:cNvPr id="3" name="Content Placeholder 2"/>
+          <p:cNvSpPr>
+            <a:spLocks noGrp="1"/>
+          </p:cNvSpPr>
+          <p:nvPr>
+            <p:ph idx="1"/>
+          </p:nvPr>
+        </p:nvSpPr>
+        <p:spPr/>
+        <p:txBody>
+          <a:bodyPr/>
+          <a:lstStyle/>
+          <a:p>
+            <a:pPr lvl="0"/>
+            <a:r>
+              <a:rPr/>
+              <a:t>Mede quantos clientes decidem continuar, quando chega a hora de renovar</a:t>
+            </a:r>
+          </a:p>
+          <a:p>
+            <a:pPr lvl="0"/>
+            <a:r>
+              <a:rPr/>
+              <a:t>Uma renovação alta confirma que o produto entrega valor de forma consistente</a:t>
+            </a:r>
+          </a:p>
+          <a:p>
+            <a:pPr lvl="0"/>
+            <a:r>
+              <a:rPr/>
+              <a:t>Uma renovação baixa é um alerta antecipado, mesmo que a venda inicial tenha sido um sucesso</a:t>
+            </a:r>
+          </a:p>
+          <a:p>
+            <a:pPr lvl="0"/>
+            <a:r>
+              <a:rPr/>
+              <a:t>É a métrica mais próxima de uma resposta direta à pergunta: “o cliente pagaria por isso de novo?”</a:t>
+            </a:r>
+          </a:p>
+        </p:txBody>
+      </p:sp>
+    </p:spTree>
+  </p:cSld>
+</p:sld>
+</file>
+
+<file path=ppt/slides/slide31.xml><?xml version="1.0" encoding="utf-8"?>
+<p:sld xmlns:a="http://schemas.openxmlformats.org/drawingml/2006/main" xmlns:r="http://schemas.openxmlformats.org/officeDocument/2006/relationships" xmlns:p="http://schemas.openxmlformats.org/presentationml/2006/main">
+  <p:cSld>
+    <p:spTree>
+      <p:nvGrpSpPr>
+        <p:cNvPr id="1" name=""/>
+        <p:cNvGrpSpPr/>
+        <p:nvPr/>
+      </p:nvGrpSpPr>
+      <p:grpSpPr>
+        <a:xfrm>
+          <a:off x="0" y="0"/>
+          <a:ext cx="0" cy="0"/>
+          <a:chOff x="0" y="0"/>
+          <a:chExt cx="0" cy="0"/>
+        </a:xfrm>
+      </p:grpSpPr>
+      <p:sp>
+        <p:nvSpPr>
+          <p:cNvPr id="2" name="Title 1"/>
+          <p:cNvSpPr>
+            <a:spLocks noGrp="1"/>
+          </p:cNvSpPr>
+          <p:nvPr>
+            <p:ph type="title"/>
+          </p:nvPr>
+        </p:nvSpPr>
+        <p:spPr/>
+        <p:txBody>
+          <a:bodyPr/>
+          <a:lstStyle/>
+          <a:p>
+            <a:pPr lvl="0" indent="0" marL="0">
+              <a:buNone/>
+            </a:pPr>
+            <a:r>
+              <a:rPr/>
+              <a:t>Cuidado com métricas de vaidade</a:t>
+            </a:r>
+          </a:p>
+        </p:txBody>
+      </p:sp>
+      <p:pic>
+        <p:nvPicPr>
+          <p:cNvPr descr="assets/diagrama_metricas_vaidade.png" id="0" name="Picture 1"/>
+          <p:cNvPicPr>
+            <a:picLocks noGrp="1" noChangeAspect="1"/>
+          </p:cNvPicPr>
+          <p:nvPr/>
+        </p:nvPicPr>
+        <p:blipFill>
+          <a:blip r:embed="rId3"/>
+          <a:stretch>
+            <a:fillRect/>
+          </a:stretch>
+        </p:blipFill>
+        <p:spPr bwMode="auto">
+          <a:xfrm>
+            <a:off x="457200" y="1993900"/>
+            <a:ext cx="8229600" cy="3721100"/>
+          </a:xfrm>
+          <a:prstGeom prst="rect">
+            <a:avLst/>
+          </a:prstGeom>
+          <a:noFill/>
+          <a:ln w="9525">
+            <a:noFill/>
+            <a:headEnd/>
+            <a:tailEnd/>
+          </a:ln>
+        </p:spPr>
+      </p:pic>
+    </p:spTree>
+  </p:cSld>
+</p:sld>
+</file>
+
+<file path=ppt/slides/slide32.xml><?xml version="1.0" encoding="utf-8"?>
+<p:sld xmlns:a="http://schemas.openxmlformats.org/drawingml/2006/main" xmlns:r="http://schemas.openxmlformats.org/officeDocument/2006/relationships" xmlns:p="http://schemas.openxmlformats.org/presentationml/2006/main">
+  <p:cSld>
+    <p:spTree>
+      <p:nvGrpSpPr>
+        <p:cNvPr id="1" name=""/>
+        <p:cNvGrpSpPr/>
+        <p:nvPr/>
+      </p:nvGrpSpPr>
+      <p:grpSpPr>
+        <a:xfrm>
+          <a:off x="0" y="0"/>
+          <a:ext cx="0" cy="0"/>
+          <a:chOff x="0" y="0"/>
+          <a:chExt cx="0" cy="0"/>
+        </a:xfrm>
+      </p:grpSpPr>
+      <p:sp>
+        <p:nvSpPr>
+          <p:cNvPr id="2" name="Title 1"/>
+          <p:cNvSpPr>
+            <a:spLocks noGrp="1"/>
+          </p:cNvSpPr>
+          <p:nvPr>
+            <p:ph type="title"/>
+          </p:nvPr>
+        </p:nvSpPr>
+        <p:spPr/>
+        <p:txBody>
+          <a:bodyPr/>
+          <a:lstStyle/>
+          <a:p>
+            <a:pPr lvl="0" indent="0" marL="0">
+              <a:buNone/>
+            </a:pPr>
+            <a:r>
+              <a:rPr/>
+              <a:t>Transformando números em decisão</a:t>
+            </a:r>
+          </a:p>
+        </p:txBody>
+      </p:sp>
+      <p:sp>
+        <p:nvSpPr>
+          <p:cNvPr id="3" name="Content Placeholder 2"/>
+          <p:cNvSpPr>
+            <a:spLocks noGrp="1"/>
+          </p:cNvSpPr>
+          <p:nvPr>
+            <p:ph idx="1"/>
+          </p:nvPr>
+        </p:nvSpPr>
+        <p:spPr/>
+        <p:txBody>
+          <a:bodyPr/>
+          <a:lstStyle/>
+          <a:p>
+            <a:pPr lvl="0"/>
+            <a:r>
+              <a:rPr/>
+              <a:t>Escolher poucas métricas, bem definidas, vale mais do que acompanhar dezenas de números soltos</a:t>
+            </a:r>
+          </a:p>
+          <a:p>
+            <a:pPr lvl="0"/>
+            <a:r>
+              <a:rPr/>
+              <a:t>Cada métrica deve ter um responsável e um motivo claro para existir</a:t>
+            </a:r>
+          </a:p>
+          <a:p>
+            <a:pPr lvl="0"/>
+            <a:r>
+              <a:rPr/>
+              <a:t>Uma métrica só é útil se ela muda alguma decisão quando o número se move</a:t>
+            </a:r>
+          </a:p>
+          <a:p>
+            <a:pPr lvl="0"/>
+            <a:r>
+              <a:rPr/>
+              <a:t>Revisar essas métricas com frequência é parte do trabalho, não uma tarefa extra</a:t>
+            </a:r>
+          </a:p>
+        </p:txBody>
+      </p:sp>
+    </p:spTree>
+  </p:cSld>
+</p:sld>
+</file>
+
+<file path=ppt/slides/slide33.xml><?xml version="1.0" encoding="utf-8"?>
+<p:sld xmlns:a="http://schemas.openxmlformats.org/drawingml/2006/main" xmlns:r="http://schemas.openxmlformats.org/officeDocument/2006/relationships" xmlns:p="http://schemas.openxmlformats.org/presentationml/2006/main">
+  <p:cSld>
+    <p:spTree>
+      <p:nvGrpSpPr>
+        <p:cNvPr id="1" name=""/>
+        <p:cNvGrpSpPr/>
+        <p:nvPr/>
+      </p:nvGrpSpPr>
+      <p:grpSpPr>
+        <a:xfrm>
+          <a:off x="0" y="0"/>
+          <a:ext cx="0" cy="0"/>
+          <a:chOff x="0" y="0"/>
+          <a:chExt cx="0" cy="0"/>
+        </a:xfrm>
+      </p:grpSpPr>
+      <p:sp>
+        <p:nvSpPr>
+          <p:cNvPr id="2" name="Title 1"/>
+          <p:cNvSpPr>
+            <a:spLocks noGrp="1"/>
+          </p:cNvSpPr>
+          <p:nvPr>
+            <p:ph type="title"/>
+          </p:nvPr>
+        </p:nvSpPr>
+        <p:spPr>
+          <a:xfrm>
+            <a:off x="722313" y="4406900"/>
+            <a:ext cx="7772400" cy="1362075"/>
+          </a:xfrm>
+        </p:spPr>
+        <p:txBody>
+          <a:bodyPr/>
+          <a:lstStyle/>
+          <a:p>
+            <a:pPr lvl="0" indent="0" marL="0">
+              <a:buNone/>
+            </a:pPr>
+            <a:r>
+              <a:rPr/>
+              <a:t>Inteligência artificial no software</a:t>
+            </a:r>
+          </a:p>
+        </p:txBody>
+      </p:sp>
+    </p:spTree>
+  </p:cSld>
+</p:sld>
+</file>
+
+<file path=ppt/slides/slide34.xml><?xml version="1.0" encoding="utf-8"?>
+<p:sld xmlns:a="http://schemas.openxmlformats.org/drawingml/2006/main" xmlns:r="http://schemas.openxmlformats.org/officeDocument/2006/relationships" xmlns:p="http://schemas.openxmlformats.org/presentationml/2006/main">
+  <p:cSld>
+    <p:spTree>
+      <p:nvGrpSpPr>
+        <p:cNvPr id="1" name=""/>
+        <p:cNvGrpSpPr/>
+        <p:nvPr/>
+      </p:nvGrpSpPr>
+      <p:grpSpPr>
+        <a:xfrm>
+          <a:off x="0" y="0"/>
+          <a:ext cx="0" cy="0"/>
+          <a:chOff x="0" y="0"/>
+          <a:chExt cx="0" cy="0"/>
+        </a:xfrm>
+      </p:grpSpPr>
+      <p:sp>
+        <p:nvSpPr>
+          <p:cNvPr id="2" name="Title 1"/>
+          <p:cNvSpPr>
+            <a:spLocks noGrp="1"/>
+          </p:cNvSpPr>
+          <p:nvPr>
+            <p:ph type="title"/>
+          </p:nvPr>
+        </p:nvSpPr>
+        <p:spPr/>
+        <p:txBody>
+          <a:bodyPr/>
+          <a:lstStyle/>
+          <a:p>
+            <a:pPr lvl="0" indent="0" marL="0">
+              <a:buNone/>
+            </a:pPr>
+            <a:r>
+              <a:rPr/>
+              <a:t>IA como uma nova camada dos produtos digitais</a:t>
+            </a:r>
+          </a:p>
+        </p:txBody>
+      </p:sp>
+      <p:sp>
+        <p:nvSpPr>
+          <p:cNvPr id="3" name="Content Placeholder 2"/>
+          <p:cNvSpPr>
+            <a:spLocks noGrp="1"/>
+          </p:cNvSpPr>
+          <p:nvPr>
+            <p:ph idx="1"/>
+          </p:nvPr>
+        </p:nvSpPr>
+        <p:spPr/>
+        <p:txBody>
+          <a:bodyPr/>
+          <a:lstStyle/>
+          <a:p>
+            <a:pPr lvl="0"/>
+            <a:r>
+              <a:rPr/>
+              <a:t>Até pouco tempo atrás, sistemas seguiam apenas regras fixas, escritas por pessoas</a:t>
+            </a:r>
+          </a:p>
+          <a:p>
+            <a:pPr lvl="0"/>
+            <a:r>
+              <a:rPr/>
+              <a:t>Hoje, a inteligência artificial permite que sistemas entendam linguagem natural e respondam de forma mais flexível</a:t>
+            </a:r>
+          </a:p>
+          <a:p>
+            <a:pPr lvl="0"/>
+            <a:r>
+              <a:rPr/>
+              <a:t>Isso abre espaço para assistentes que conversam com o cliente, resumem informações e ajudam pessoas a decidir mais rápido</a:t>
+            </a:r>
+          </a:p>
+          <a:p>
+            <a:pPr lvl="0"/>
+            <a:r>
+              <a:rPr/>
+              <a:t>O desafio deixou de ser “o sistema entende o pedido?” e passou a ser “a resposta é confiável?”</a:t>
+            </a:r>
+          </a:p>
+        </p:txBody>
+      </p:sp>
+    </p:spTree>
+  </p:cSld>
+</p:sld>
+</file>
+
+<file path=ppt/slides/slide35.xml><?xml version="1.0" encoding="utf-8"?>
 <p:sld xmlns:a="http://schemas.openxmlformats.org/drawingml/2006/main" xmlns:r="http://schemas.openxmlformats.org/officeDocument/2006/relationships" xmlns:p="http://schemas.openxmlformats.org/presentationml/2006/main">
   <p:cSld>
     <p:spTree>
@@ -5718,7 +6518,7 @@
 </p:sld>
 </file>
 
-<file path=ppt/slides/slide29.xml><?xml version="1.0" encoding="utf-8"?>
+<file path=ppt/slides/slide36.xml><?xml version="1.0" encoding="utf-8"?>
 <p:sld xmlns:a="http://schemas.openxmlformats.org/drawingml/2006/main" xmlns:r="http://schemas.openxmlformats.org/officeDocument/2006/relationships" xmlns:p="http://schemas.openxmlformats.org/presentationml/2006/main">
   <p:cSld>
     <p:spTree>
@@ -5770,7 +6570,7 @@
 </p:sld>
 </file>
 
-<file path=ppt/slides/slide3.xml><?xml version="1.0" encoding="utf-8"?>
+<file path=ppt/slides/slide37.xml><?xml version="1.0" encoding="utf-8"?>
 <p:sld xmlns:a="http://schemas.openxmlformats.org/drawingml/2006/main" xmlns:r="http://schemas.openxmlformats.org/officeDocument/2006/relationships" xmlns:p="http://schemas.openxmlformats.org/presentationml/2006/main">
   <p:cSld>
     <p:spTree>
@@ -5797,12 +6597,7 @@
             <p:ph type="title"/>
           </p:nvPr>
         </p:nvSpPr>
-        <p:spPr>
-          <a:xfrm>
-            <a:off x="722313" y="4406900"/>
-            <a:ext cx="7772400" cy="1362075"/>
-          </a:xfrm>
-        </p:spPr>
+        <p:spPr/>
         <p:txBody>
           <a:bodyPr/>
           <a:lstStyle/>
@@ -5812,7 +6607,51 @@
             </a:pPr>
             <a:r>
               <a:rPr/>
-              <a:t>Da ideia ao produto no ar</a:t>
+              <a:t>O contexto: NovaSeguro Corretora (exemplo fictício)</a:t>
+            </a:r>
+          </a:p>
+        </p:txBody>
+      </p:sp>
+      <p:sp>
+        <p:nvSpPr>
+          <p:cNvPr id="3" name="Content Placeholder 2"/>
+          <p:cNvSpPr>
+            <a:spLocks noGrp="1"/>
+          </p:cNvSpPr>
+          <p:nvPr>
+            <p:ph idx="1"/>
+          </p:nvPr>
+        </p:nvSpPr>
+        <p:spPr/>
+        <p:txBody>
+          <a:bodyPr/>
+          <a:lstStyle/>
+          <a:p>
+            <a:pPr lvl="0"/>
+            <a:r>
+              <a:rPr/>
+              <a:t>A NovaSeguro trabalha com várias seguradoras parceiras ao mesmo tempo</a:t>
+            </a:r>
+          </a:p>
+          <a:p>
+            <a:pPr lvl="0"/>
+            <a:r>
+              <a:rPr/>
+              <a:t>Cada seguradora tem suas próprias regras, apólices, coberturas e prazos</a:t>
+            </a:r>
+          </a:p>
+          <a:p>
+            <a:pPr lvl="0"/>
+            <a:r>
+              <a:rPr/>
+              <a:t>Os corretores precisam responder perguntas de clientes com rapidez e precisão</a:t>
+            </a:r>
+          </a:p>
+          <a:p>
+            <a:pPr lvl="0"/>
+            <a:r>
+              <a:rPr/>
+              <a:t>Hoje, essa informação está espalhada entre manuais, planilhas e sistemas diferentes</a:t>
             </a:r>
           </a:p>
         </p:txBody>
@@ -5822,7 +6661,7 @@
 </p:sld>
 </file>
 
-<file path=ppt/slides/slide30.xml><?xml version="1.0" encoding="utf-8"?>
+<file path=ppt/slides/slide38.xml><?xml version="1.0" encoding="utf-8"?>
 <p:sld xmlns:a="http://schemas.openxmlformats.org/drawingml/2006/main" xmlns:r="http://schemas.openxmlformats.org/officeDocument/2006/relationships" xmlns:p="http://schemas.openxmlformats.org/presentationml/2006/main">
   <p:cSld>
     <p:spTree>
@@ -5859,7 +6698,7 @@
             </a:pPr>
             <a:r>
               <a:rPr/>
-              <a:t>O contexto: NovaSeguro Corretora (exemplo fictício)</a:t>
+              <a:t>O desafio do dia a dia</a:t>
             </a:r>
           </a:p>
         </p:txBody>
@@ -5882,28 +6721,28 @@
             <a:pPr lvl="0"/>
             <a:r>
               <a:rPr/>
-              <a:t>A NovaSeguro trabalha com várias seguradoras parceiras ao mesmo tempo</a:t>
-            </a:r>
-          </a:p>
-          <a:p>
-            <a:pPr lvl="0"/>
-            <a:r>
-              <a:rPr/>
-              <a:t>Cada seguradora tem suas próprias regras, apólices, coberturas e prazos</a:t>
-            </a:r>
-          </a:p>
-          <a:p>
-            <a:pPr lvl="0"/>
-            <a:r>
-              <a:rPr/>
-              <a:t>Os corretores precisam responder perguntas de clientes com rapidez e precisão</a:t>
-            </a:r>
-          </a:p>
-          <a:p>
-            <a:pPr lvl="0"/>
-            <a:r>
-              <a:rPr/>
-              <a:t>Hoje, essa informação está espalhada entre manuais, planilhas e sistemas diferentes</a:t>
+              <a:t>Encontrar a informação certa toma tempo e depende de quem está de plantão</a:t>
+            </a:r>
+          </a:p>
+          <a:p>
+            <a:pPr lvl="0"/>
+            <a:r>
+              <a:rPr/>
+              <a:t>É difícil comparar coberturas entre seguradoras diferentes na hora da conversa com o cliente</a:t>
+            </a:r>
+          </a:p>
+          <a:p>
+            <a:pPr lvl="0"/>
+            <a:r>
+              <a:rPr/>
+              <a:t>Perguntas mais complexas, como possíveis sobreposições de cobertura, quase nunca são respondidas na hora</a:t>
+            </a:r>
+          </a:p>
+          <a:p>
+            <a:pPr lvl="0"/>
+            <a:r>
+              <a:rPr/>
+              <a:t>O resultado é atendimento mais lento e risco de informação incorreta</a:t>
             </a:r>
           </a:p>
         </p:txBody>
@@ -5913,98 +6752,7 @@
 </p:sld>
 </file>
 
-<file path=ppt/slides/slide31.xml><?xml version="1.0" encoding="utf-8"?>
-<p:sld xmlns:a="http://schemas.openxmlformats.org/drawingml/2006/main" xmlns:r="http://schemas.openxmlformats.org/officeDocument/2006/relationships" xmlns:p="http://schemas.openxmlformats.org/presentationml/2006/main">
-  <p:cSld>
-    <p:spTree>
-      <p:nvGrpSpPr>
-        <p:cNvPr id="1" name=""/>
-        <p:cNvGrpSpPr/>
-        <p:nvPr/>
-      </p:nvGrpSpPr>
-      <p:grpSpPr>
-        <a:xfrm>
-          <a:off x="0" y="0"/>
-          <a:ext cx="0" cy="0"/>
-          <a:chOff x="0" y="0"/>
-          <a:chExt cx="0" cy="0"/>
-        </a:xfrm>
-      </p:grpSpPr>
-      <p:sp>
-        <p:nvSpPr>
-          <p:cNvPr id="2" name="Title 1"/>
-          <p:cNvSpPr>
-            <a:spLocks noGrp="1"/>
-          </p:cNvSpPr>
-          <p:nvPr>
-            <p:ph type="title"/>
-          </p:nvPr>
-        </p:nvSpPr>
-        <p:spPr/>
-        <p:txBody>
-          <a:bodyPr/>
-          <a:lstStyle/>
-          <a:p>
-            <a:pPr lvl="0" indent="0" marL="0">
-              <a:buNone/>
-            </a:pPr>
-            <a:r>
-              <a:rPr/>
-              <a:t>O desafio do dia a dia</a:t>
-            </a:r>
-          </a:p>
-        </p:txBody>
-      </p:sp>
-      <p:sp>
-        <p:nvSpPr>
-          <p:cNvPr id="3" name="Content Placeholder 2"/>
-          <p:cNvSpPr>
-            <a:spLocks noGrp="1"/>
-          </p:cNvSpPr>
-          <p:nvPr>
-            <p:ph idx="1"/>
-          </p:nvPr>
-        </p:nvSpPr>
-        <p:spPr/>
-        <p:txBody>
-          <a:bodyPr/>
-          <a:lstStyle/>
-          <a:p>
-            <a:pPr lvl="0"/>
-            <a:r>
-              <a:rPr/>
-              <a:t>Encontrar a informação certa toma tempo e depende de quem está de plantão</a:t>
-            </a:r>
-          </a:p>
-          <a:p>
-            <a:pPr lvl="0"/>
-            <a:r>
-              <a:rPr/>
-              <a:t>É difícil comparar coberturas entre seguradoras diferentes na hora da conversa com o cliente</a:t>
-            </a:r>
-          </a:p>
-          <a:p>
-            <a:pPr lvl="0"/>
-            <a:r>
-              <a:rPr/>
-              <a:t>Perguntas mais complexas, como possíveis sobreposições de cobertura, quase nunca são respondidas na hora</a:t>
-            </a:r>
-          </a:p>
-          <a:p>
-            <a:pPr lvl="0"/>
-            <a:r>
-              <a:rPr/>
-              <a:t>O resultado é atendimento mais lento e risco de informação incorreta</a:t>
-            </a:r>
-          </a:p>
-        </p:txBody>
-      </p:sp>
-    </p:spTree>
-  </p:cSld>
-</p:sld>
-</file>
-
-<file path=ppt/slides/slide32.xml><?xml version="1.0" encoding="utf-8"?>
+<file path=ppt/slides/slide39.xml><?xml version="1.0" encoding="utf-8"?>
 <p:sld xmlns:a="http://schemas.openxmlformats.org/drawingml/2006/main" xmlns:r="http://schemas.openxmlformats.org/officeDocument/2006/relationships" xmlns:p="http://schemas.openxmlformats.org/presentationml/2006/main">
   <p:cSld>
     <p:spTree>
@@ -6081,565 +6829,6 @@
 </p:sld>
 </file>
 
-<file path=ppt/slides/slide33.xml><?xml version="1.0" encoding="utf-8"?>
-<p:sld xmlns:a="http://schemas.openxmlformats.org/drawingml/2006/main" xmlns:r="http://schemas.openxmlformats.org/officeDocument/2006/relationships" xmlns:p="http://schemas.openxmlformats.org/presentationml/2006/main">
-  <p:cSld>
-    <p:spTree>
-      <p:nvGrpSpPr>
-        <p:cNvPr id="1" name=""/>
-        <p:cNvGrpSpPr/>
-        <p:nvPr/>
-      </p:nvGrpSpPr>
-      <p:grpSpPr>
-        <a:xfrm>
-          <a:off x="0" y="0"/>
-          <a:ext cx="0" cy="0"/>
-          <a:chOff x="0" y="0"/>
-          <a:chExt cx="0" cy="0"/>
-        </a:xfrm>
-      </p:grpSpPr>
-      <p:sp>
-        <p:nvSpPr>
-          <p:cNvPr id="2" name="Title 1"/>
-          <p:cNvSpPr>
-            <a:spLocks noGrp="1"/>
-          </p:cNvSpPr>
-          <p:nvPr>
-            <p:ph type="title"/>
-          </p:nvPr>
-        </p:nvSpPr>
-        <p:spPr/>
-        <p:txBody>
-          <a:bodyPr/>
-          <a:lstStyle/>
-          <a:p>
-            <a:pPr lvl="0" indent="0" marL="0">
-              <a:buNone/>
-            </a:pPr>
-            <a:r>
-              <a:rPr/>
-              <a:t>Começando simples: consulta a documentos</a:t>
-            </a:r>
-          </a:p>
-        </p:txBody>
-      </p:sp>
-      <p:sp>
-        <p:nvSpPr>
-          <p:cNvPr id="3" name="Content Placeholder 2"/>
-          <p:cNvSpPr>
-            <a:spLocks noGrp="1"/>
-          </p:cNvSpPr>
-          <p:nvPr>
-            <p:ph idx="1"/>
-          </p:nvPr>
-        </p:nvSpPr>
-        <p:spPr/>
-        <p:txBody>
-          <a:bodyPr/>
-          <a:lstStyle/>
-          <a:p>
-            <a:pPr lvl="0"/>
-            <a:r>
-              <a:rPr/>
-              <a:t>O assistente é treinado para consultar manuais, apólices e contratos das seguradoras parceiras</a:t>
-            </a:r>
-          </a:p>
-          <a:p>
-            <a:pPr lvl="0"/>
-            <a:r>
-              <a:rPr/>
-              <a:t>Quando o corretor faz uma pergunta, ele busca a informação nos documentos certos</a:t>
-            </a:r>
-          </a:p>
-          <a:p>
-            <a:pPr lvl="0"/>
-            <a:r>
-              <a:rPr/>
-              <a:t>A resposta sempre indica de onde veio a informação, para gerar confiança</a:t>
-            </a:r>
-          </a:p>
-          <a:p>
-            <a:pPr lvl="0"/>
-            <a:r>
-              <a:rPr/>
-              <a:t>Essa é a base: uma forma de a IA responder com apoio em fontes confiáveis, e não apenas “adivinhar”</a:t>
-            </a:r>
-          </a:p>
-        </p:txBody>
-      </p:sp>
-    </p:spTree>
-  </p:cSld>
-</p:sld>
-</file>
-
-<file path=ppt/slides/slide34.xml><?xml version="1.0" encoding="utf-8"?>
-<p:sld xmlns:a="http://schemas.openxmlformats.org/drawingml/2006/main" xmlns:r="http://schemas.openxmlformats.org/officeDocument/2006/relationships" xmlns:p="http://schemas.openxmlformats.org/presentationml/2006/main">
-  <p:cSld>
-    <p:spTree>
-      <p:nvGrpSpPr>
-        <p:cNvPr id="1" name=""/>
-        <p:cNvGrpSpPr/>
-        <p:nvPr/>
-      </p:nvGrpSpPr>
-      <p:grpSpPr>
-        <a:xfrm>
-          <a:off x="0" y="0"/>
-          <a:ext cx="0" cy="0"/>
-          <a:chOff x="0" y="0"/>
-          <a:chExt cx="0" cy="0"/>
-        </a:xfrm>
-      </p:grpSpPr>
-      <p:sp>
-        <p:nvSpPr>
-          <p:cNvPr id="2" name="Title 1"/>
-          <p:cNvSpPr>
-            <a:spLocks noGrp="1"/>
-          </p:cNvSpPr>
-          <p:nvPr>
-            <p:ph type="title"/>
-          </p:nvPr>
-        </p:nvSpPr>
-        <p:spPr/>
-        <p:txBody>
-          <a:bodyPr/>
-          <a:lstStyle/>
-          <a:p>
-            <a:pPr lvl="0" indent="0" marL="0">
-              <a:buNone/>
-            </a:pPr>
-            <a:r>
-              <a:rPr/>
-              <a:t>Evoluindo: entendendo as conexões entre as informações</a:t>
-            </a:r>
-          </a:p>
-        </p:txBody>
-      </p:sp>
-      <p:sp>
-        <p:nvSpPr>
-          <p:cNvPr id="3" name="Content Placeholder 2"/>
-          <p:cNvSpPr>
-            <a:spLocks noGrp="1"/>
-          </p:cNvSpPr>
-          <p:nvPr>
-            <p:ph idx="1"/>
-          </p:nvPr>
-        </p:nvSpPr>
-        <p:spPr/>
-        <p:txBody>
-          <a:bodyPr/>
-          <a:lstStyle/>
-          <a:p>
-            <a:pPr lvl="0"/>
-            <a:r>
-              <a:rPr/>
-              <a:t>Com o tempo, a NovaSeguro passa a mapear como as informações se relacionam: clientes, apólices, coberturas, sinistros e seguradoras</a:t>
-            </a:r>
-          </a:p>
-          <a:p>
-            <a:pPr lvl="0"/>
-            <a:r>
-              <a:rPr/>
-              <a:t>Isso permite responder perguntas mais ricas, como identificar sobreposições de cobertura entre seguradoras diferentes</a:t>
-            </a:r>
-          </a:p>
-          <a:p>
-            <a:pPr lvl="0"/>
-            <a:r>
-              <a:rPr/>
-              <a:t>O assistente passa a enxergar o panorama completo do cliente, e não apenas um documento isolado</a:t>
-            </a:r>
-          </a:p>
-          <a:p>
-            <a:pPr lvl="0"/>
-            <a:r>
-              <a:rPr/>
-              <a:t>É um salto de “responder perguntas” para “gerar recomendações de negócio”</a:t>
-            </a:r>
-          </a:p>
-        </p:txBody>
-      </p:sp>
-    </p:spTree>
-  </p:cSld>
-</p:sld>
-</file>
-
-<file path=ppt/slides/slide35.xml><?xml version="1.0" encoding="utf-8"?>
-<p:sld xmlns:a="http://schemas.openxmlformats.org/drawingml/2006/main" xmlns:r="http://schemas.openxmlformats.org/officeDocument/2006/relationships" xmlns:p="http://schemas.openxmlformats.org/presentationml/2006/main">
-  <p:cSld>
-    <p:spTree>
-      <p:nvGrpSpPr>
-        <p:cNvPr id="1" name=""/>
-        <p:cNvGrpSpPr/>
-        <p:nvPr/>
-      </p:nvGrpSpPr>
-      <p:grpSpPr>
-        <a:xfrm>
-          <a:off x="0" y="0"/>
-          <a:ext cx="0" cy="0"/>
-          <a:chOff x="0" y="0"/>
-          <a:chExt cx="0" cy="0"/>
-        </a:xfrm>
-      </p:grpSpPr>
-      <p:sp>
-        <p:nvSpPr>
-          <p:cNvPr id="2" name="Title 1"/>
-          <p:cNvSpPr>
-            <a:spLocks noGrp="1"/>
-          </p:cNvSpPr>
-          <p:nvPr>
-            <p:ph type="title"/>
-          </p:nvPr>
-        </p:nvSpPr>
-        <p:spPr/>
-        <p:txBody>
-          <a:bodyPr/>
-          <a:lstStyle/>
-          <a:p>
-            <a:pPr lvl="0" indent="0" marL="0">
-              <a:buNone/>
-            </a:pPr>
-            <a:r>
-              <a:rPr/>
-              <a:t>Benefícios para o negócio</a:t>
-            </a:r>
-          </a:p>
-        </p:txBody>
-      </p:sp>
-      <p:sp>
-        <p:nvSpPr>
-          <p:cNvPr id="3" name="Content Placeholder 2"/>
-          <p:cNvSpPr>
-            <a:spLocks noGrp="1"/>
-          </p:cNvSpPr>
-          <p:nvPr>
-            <p:ph idx="1"/>
-          </p:nvPr>
-        </p:nvSpPr>
-        <p:spPr/>
-        <p:txBody>
-          <a:bodyPr/>
-          <a:lstStyle/>
-          <a:p>
-            <a:pPr lvl="0"/>
-            <a:r>
-              <a:rPr/>
-              <a:t>Atendimento mais rápido, com menos tempo de espera para o cliente</a:t>
-            </a:r>
-          </a:p>
-          <a:p>
-            <a:pPr lvl="0"/>
-            <a:r>
-              <a:rPr/>
-              <a:t>Menos erros por informação desatualizada ou mal interpretada</a:t>
-            </a:r>
-          </a:p>
-          <a:p>
-            <a:pPr lvl="0"/>
-            <a:r>
-              <a:rPr/>
-              <a:t>Decisões melhores, apoiadas em uma visão mais completa do cliente</a:t>
-            </a:r>
-          </a:p>
-          <a:p>
-            <a:pPr lvl="0"/>
-            <a:r>
-              <a:rPr/>
-              <a:t>Integração mais simples com os sistemas de cada seguradora parceira</a:t>
-            </a:r>
-          </a:p>
-        </p:txBody>
-      </p:sp>
-    </p:spTree>
-  </p:cSld>
-</p:sld>
-</file>
-
-<file path=ppt/slides/slide36.xml><?xml version="1.0" encoding="utf-8"?>
-<p:sld xmlns:a="http://schemas.openxmlformats.org/drawingml/2006/main" xmlns:r="http://schemas.openxmlformats.org/officeDocument/2006/relationships" xmlns:p="http://schemas.openxmlformats.org/presentationml/2006/main">
-  <p:cSld>
-    <p:spTree>
-      <p:nvGrpSpPr>
-        <p:cNvPr id="1" name=""/>
-        <p:cNvGrpSpPr/>
-        <p:nvPr/>
-      </p:nvGrpSpPr>
-      <p:grpSpPr>
-        <a:xfrm>
-          <a:off x="0" y="0"/>
-          <a:ext cx="0" cy="0"/>
-          <a:chOff x="0" y="0"/>
-          <a:chExt cx="0" cy="0"/>
-        </a:xfrm>
-      </p:grpSpPr>
-      <p:sp>
-        <p:nvSpPr>
-          <p:cNvPr id="2" name="Title 1"/>
-          <p:cNvSpPr>
-            <a:spLocks noGrp="1"/>
-          </p:cNvSpPr>
-          <p:nvPr>
-            <p:ph type="title"/>
-          </p:nvPr>
-        </p:nvSpPr>
-        <p:spPr/>
-        <p:txBody>
-          <a:bodyPr/>
-          <a:lstStyle/>
-          <a:p>
-            <a:pPr lvl="0" indent="0" marL="0">
-              <a:buNone/>
-            </a:pPr>
-            <a:r>
-              <a:rPr/>
-              <a:t>Cuidados importantes</a:t>
-            </a:r>
-          </a:p>
-        </p:txBody>
-      </p:sp>
-      <p:sp>
-        <p:nvSpPr>
-          <p:cNvPr id="3" name="Content Placeholder 2"/>
-          <p:cNvSpPr>
-            <a:spLocks noGrp="1"/>
-          </p:cNvSpPr>
-          <p:nvPr>
-            <p:ph idx="1"/>
-          </p:nvPr>
-        </p:nvSpPr>
-        <p:spPr/>
-        <p:txBody>
-          <a:bodyPr/>
-          <a:lstStyle/>
-          <a:p>
-            <a:pPr lvl="0"/>
-            <a:r>
-              <a:rPr/>
-              <a:t>A qualidade da resposta depende da qualidade dos dados usados como fonte</a:t>
-            </a:r>
-          </a:p>
-          <a:p>
-            <a:pPr lvl="0"/>
-            <a:r>
-              <a:rPr/>
-              <a:t>Pessoas continuam responsáveis por revisar decisões de maior impacto</a:t>
-            </a:r>
-          </a:p>
-          <a:p>
-            <a:pPr lvl="0"/>
-            <a:r>
-              <a:rPr/>
-              <a:t>É preciso definir regras claras de acesso e uso da informação dos clientes</a:t>
-            </a:r>
-          </a:p>
-          <a:p>
-            <a:pPr lvl="0"/>
-            <a:r>
-              <a:rPr/>
-              <a:t>Inteligência artificial é uma ferramenta poderosa, mas não substitui a governança do negócio</a:t>
-            </a:r>
-          </a:p>
-        </p:txBody>
-      </p:sp>
-    </p:spTree>
-  </p:cSld>
-</p:sld>
-</file>
-
-<file path=ppt/slides/slide37.xml><?xml version="1.0" encoding="utf-8"?>
-<p:sld xmlns:a="http://schemas.openxmlformats.org/drawingml/2006/main" xmlns:r="http://schemas.openxmlformats.org/officeDocument/2006/relationships" xmlns:p="http://schemas.openxmlformats.org/presentationml/2006/main">
-  <p:cSld>
-    <p:spTree>
-      <p:nvGrpSpPr>
-        <p:cNvPr id="1" name=""/>
-        <p:cNvGrpSpPr/>
-        <p:nvPr/>
-      </p:nvGrpSpPr>
-      <p:grpSpPr>
-        <a:xfrm>
-          <a:off x="0" y="0"/>
-          <a:ext cx="0" cy="0"/>
-          <a:chOff x="0" y="0"/>
-          <a:chExt cx="0" cy="0"/>
-        </a:xfrm>
-      </p:grpSpPr>
-      <p:sp>
-        <p:nvSpPr>
-          <p:cNvPr id="2" name="Title 1"/>
-          <p:cNvSpPr>
-            <a:spLocks noGrp="1"/>
-          </p:cNvSpPr>
-          <p:nvPr>
-            <p:ph type="title"/>
-          </p:nvPr>
-        </p:nvSpPr>
-        <p:spPr>
-          <a:xfrm>
-            <a:off x="722313" y="4406900"/>
-            <a:ext cx="7772400" cy="1362075"/>
-          </a:xfrm>
-        </p:spPr>
-        <p:txBody>
-          <a:bodyPr/>
-          <a:lstStyle/>
-          <a:p>
-            <a:pPr lvl="0" indent="0" marL="0">
-              <a:buNone/>
-            </a:pPr>
-            <a:r>
-              <a:rPr/>
-              <a:t>Mensagens-chave</a:t>
-            </a:r>
-          </a:p>
-        </p:txBody>
-      </p:sp>
-    </p:spTree>
-  </p:cSld>
-</p:sld>
-</file>
-
-<file path=ppt/slides/slide38.xml><?xml version="1.0" encoding="utf-8"?>
-<p:sld xmlns:a="http://schemas.openxmlformats.org/drawingml/2006/main" xmlns:r="http://schemas.openxmlformats.org/officeDocument/2006/relationships" xmlns:p="http://schemas.openxmlformats.org/presentationml/2006/main">
-  <p:cSld>
-    <p:spTree>
-      <p:nvGrpSpPr>
-        <p:cNvPr id="1" name=""/>
-        <p:cNvGrpSpPr/>
-        <p:nvPr/>
-      </p:nvGrpSpPr>
-      <p:grpSpPr>
-        <a:xfrm>
-          <a:off x="0" y="0"/>
-          <a:ext cx="0" cy="0"/>
-          <a:chOff x="0" y="0"/>
-          <a:chExt cx="0" cy="0"/>
-        </a:xfrm>
-      </p:grpSpPr>
-      <p:sp>
-        <p:nvSpPr>
-          <p:cNvPr id="2" name="Title 1"/>
-          <p:cNvSpPr>
-            <a:spLocks noGrp="1"/>
-          </p:cNvSpPr>
-          <p:nvPr>
-            <p:ph type="title"/>
-          </p:nvPr>
-        </p:nvSpPr>
-        <p:spPr/>
-        <p:txBody>
-          <a:bodyPr/>
-          <a:lstStyle/>
-          <a:p>
-            <a:pPr lvl="0" indent="0" marL="0">
-              <a:buNone/>
-            </a:pPr>
-            <a:r>
-              <a:rPr/>
-              <a:t>O que vale levar desta conversa</a:t>
-            </a:r>
-          </a:p>
-        </p:txBody>
-      </p:sp>
-      <p:sp>
-        <p:nvSpPr>
-          <p:cNvPr id="3" name="Content Placeholder 2"/>
-          <p:cNvSpPr>
-            <a:spLocks noGrp="1"/>
-          </p:cNvSpPr>
-          <p:nvPr>
-            <p:ph idx="1"/>
-          </p:nvPr>
-        </p:nvSpPr>
-        <p:spPr/>
-        <p:txBody>
-          <a:bodyPr/>
-          <a:lstStyle/>
-          <a:p>
-            <a:pPr lvl="0"/>
-            <a:r>
-              <a:rPr/>
-              <a:t>Todo produto e toda funcionalidade seguem um ciclo, da oportunidade ao aprendizado</a:t>
-            </a:r>
-          </a:p>
-          <a:p>
-            <a:pPr lvl="0"/>
-            <a:r>
-              <a:rPr/>
-              <a:t>Product Owner, System Engineer e Tech Lead olham para o mesmo problema sob ângulos diferentes</a:t>
-            </a:r>
-          </a:p>
-          <a:p>
-            <a:pPr lvl="0"/>
-            <a:r>
-              <a:rPr/>
-              <a:t>Ciclos curtos e validação rápida reduzem risco e aceleram resultados</a:t>
-            </a:r>
-          </a:p>
-          <a:p>
-            <a:pPr lvl="0"/>
-            <a:r>
-              <a:rPr/>
-              <a:t>A inteligência artificial adiciona uma nova camada de valor, mas exige dados confiáveis e boa governança</a:t>
-            </a:r>
-          </a:p>
-        </p:txBody>
-      </p:sp>
-    </p:spTree>
-  </p:cSld>
-</p:sld>
-</file>
-
-<file path=ppt/slides/slide39.xml><?xml version="1.0" encoding="utf-8"?>
-<p:sld xmlns:a="http://schemas.openxmlformats.org/drawingml/2006/main" xmlns:r="http://schemas.openxmlformats.org/officeDocument/2006/relationships" xmlns:p="http://schemas.openxmlformats.org/presentationml/2006/main">
-  <p:cSld>
-    <p:spTree>
-      <p:nvGrpSpPr>
-        <p:cNvPr id="1" name=""/>
-        <p:cNvGrpSpPr/>
-        <p:nvPr/>
-      </p:nvGrpSpPr>
-      <p:grpSpPr>
-        <a:xfrm>
-          <a:off x="0" y="0"/>
-          <a:ext cx="0" cy="0"/>
-          <a:chOff x="0" y="0"/>
-          <a:chExt cx="0" cy="0"/>
-        </a:xfrm>
-      </p:grpSpPr>
-      <p:sp>
-        <p:nvSpPr>
-          <p:cNvPr id="2" name="Title 1"/>
-          <p:cNvSpPr>
-            <a:spLocks noGrp="1"/>
-          </p:cNvSpPr>
-          <p:nvPr>
-            <p:ph type="title"/>
-          </p:nvPr>
-        </p:nvSpPr>
-        <p:spPr>
-          <a:xfrm>
-            <a:off x="722313" y="4406900"/>
-            <a:ext cx="7772400" cy="1362075"/>
-          </a:xfrm>
-        </p:spPr>
-        <p:txBody>
-          <a:bodyPr/>
-          <a:lstStyle/>
-          <a:p>
-            <a:pPr lvl="0" indent="0" marL="0">
-              <a:buNone/>
-            </a:pPr>
-            <a:r>
-              <a:rPr/>
-              <a:t>Obrigado</a:t>
-            </a:r>
-          </a:p>
-        </p:txBody>
-      </p:sp>
-    </p:spTree>
-  </p:cSld>
-</p:sld>
-</file>
-
 <file path=ppt/slides/slide4.xml><?xml version="1.0" encoding="utf-8"?>
 <p:sld xmlns:a="http://schemas.openxmlformats.org/drawingml/2006/main" xmlns:r="http://schemas.openxmlformats.org/officeDocument/2006/relationships" xmlns:p="http://schemas.openxmlformats.org/presentationml/2006/main">
   <p:cSld>
@@ -6722,6 +6911,565 @@
             <a:r>
               <a:rPr/>
               <a:t>Cada uma delas passa por um ciclo parecido, do problema até o uso real pelo cliente</a:t>
+            </a:r>
+          </a:p>
+        </p:txBody>
+      </p:sp>
+    </p:spTree>
+  </p:cSld>
+</p:sld>
+</file>
+
+<file path=ppt/slides/slide40.xml><?xml version="1.0" encoding="utf-8"?>
+<p:sld xmlns:a="http://schemas.openxmlformats.org/drawingml/2006/main" xmlns:r="http://schemas.openxmlformats.org/officeDocument/2006/relationships" xmlns:p="http://schemas.openxmlformats.org/presentationml/2006/main">
+  <p:cSld>
+    <p:spTree>
+      <p:nvGrpSpPr>
+        <p:cNvPr id="1" name=""/>
+        <p:cNvGrpSpPr/>
+        <p:nvPr/>
+      </p:nvGrpSpPr>
+      <p:grpSpPr>
+        <a:xfrm>
+          <a:off x="0" y="0"/>
+          <a:ext cx="0" cy="0"/>
+          <a:chOff x="0" y="0"/>
+          <a:chExt cx="0" cy="0"/>
+        </a:xfrm>
+      </p:grpSpPr>
+      <p:sp>
+        <p:nvSpPr>
+          <p:cNvPr id="2" name="Title 1"/>
+          <p:cNvSpPr>
+            <a:spLocks noGrp="1"/>
+          </p:cNvSpPr>
+          <p:nvPr>
+            <p:ph type="title"/>
+          </p:nvPr>
+        </p:nvSpPr>
+        <p:spPr/>
+        <p:txBody>
+          <a:bodyPr/>
+          <a:lstStyle/>
+          <a:p>
+            <a:pPr lvl="0" indent="0" marL="0">
+              <a:buNone/>
+            </a:pPr>
+            <a:r>
+              <a:rPr/>
+              <a:t>Começando simples: consulta a documentos</a:t>
+            </a:r>
+          </a:p>
+        </p:txBody>
+      </p:sp>
+      <p:sp>
+        <p:nvSpPr>
+          <p:cNvPr id="3" name="Content Placeholder 2"/>
+          <p:cNvSpPr>
+            <a:spLocks noGrp="1"/>
+          </p:cNvSpPr>
+          <p:nvPr>
+            <p:ph idx="1"/>
+          </p:nvPr>
+        </p:nvSpPr>
+        <p:spPr/>
+        <p:txBody>
+          <a:bodyPr/>
+          <a:lstStyle/>
+          <a:p>
+            <a:pPr lvl="0"/>
+            <a:r>
+              <a:rPr/>
+              <a:t>O assistente é treinado para consultar manuais, apólices e contratos das seguradoras parceiras</a:t>
+            </a:r>
+          </a:p>
+          <a:p>
+            <a:pPr lvl="0"/>
+            <a:r>
+              <a:rPr/>
+              <a:t>Quando o corretor faz uma pergunta, ele busca a informação nos documentos certos</a:t>
+            </a:r>
+          </a:p>
+          <a:p>
+            <a:pPr lvl="0"/>
+            <a:r>
+              <a:rPr/>
+              <a:t>A resposta sempre indica de onde veio a informação, para gerar confiança</a:t>
+            </a:r>
+          </a:p>
+          <a:p>
+            <a:pPr lvl="0"/>
+            <a:r>
+              <a:rPr/>
+              <a:t>Essa é a base: uma forma de a IA responder com apoio em fontes confiáveis, e não apenas “adivinhar”</a:t>
+            </a:r>
+          </a:p>
+        </p:txBody>
+      </p:sp>
+    </p:spTree>
+  </p:cSld>
+</p:sld>
+</file>
+
+<file path=ppt/slides/slide41.xml><?xml version="1.0" encoding="utf-8"?>
+<p:sld xmlns:a="http://schemas.openxmlformats.org/drawingml/2006/main" xmlns:r="http://schemas.openxmlformats.org/officeDocument/2006/relationships" xmlns:p="http://schemas.openxmlformats.org/presentationml/2006/main">
+  <p:cSld>
+    <p:spTree>
+      <p:nvGrpSpPr>
+        <p:cNvPr id="1" name=""/>
+        <p:cNvGrpSpPr/>
+        <p:nvPr/>
+      </p:nvGrpSpPr>
+      <p:grpSpPr>
+        <a:xfrm>
+          <a:off x="0" y="0"/>
+          <a:ext cx="0" cy="0"/>
+          <a:chOff x="0" y="0"/>
+          <a:chExt cx="0" cy="0"/>
+        </a:xfrm>
+      </p:grpSpPr>
+      <p:sp>
+        <p:nvSpPr>
+          <p:cNvPr id="2" name="Title 1"/>
+          <p:cNvSpPr>
+            <a:spLocks noGrp="1"/>
+          </p:cNvSpPr>
+          <p:nvPr>
+            <p:ph type="title"/>
+          </p:nvPr>
+        </p:nvSpPr>
+        <p:spPr/>
+        <p:txBody>
+          <a:bodyPr/>
+          <a:lstStyle/>
+          <a:p>
+            <a:pPr lvl="0" indent="0" marL="0">
+              <a:buNone/>
+            </a:pPr>
+            <a:r>
+              <a:rPr/>
+              <a:t>Evoluindo: entendendo as conexões entre as informações</a:t>
+            </a:r>
+          </a:p>
+        </p:txBody>
+      </p:sp>
+      <p:sp>
+        <p:nvSpPr>
+          <p:cNvPr id="3" name="Content Placeholder 2"/>
+          <p:cNvSpPr>
+            <a:spLocks noGrp="1"/>
+          </p:cNvSpPr>
+          <p:nvPr>
+            <p:ph idx="1"/>
+          </p:nvPr>
+        </p:nvSpPr>
+        <p:spPr/>
+        <p:txBody>
+          <a:bodyPr/>
+          <a:lstStyle/>
+          <a:p>
+            <a:pPr lvl="0"/>
+            <a:r>
+              <a:rPr/>
+              <a:t>Com o tempo, a NovaSeguro passa a mapear como as informações se relacionam: clientes, apólices, coberturas, sinistros e seguradoras</a:t>
+            </a:r>
+          </a:p>
+          <a:p>
+            <a:pPr lvl="0"/>
+            <a:r>
+              <a:rPr/>
+              <a:t>Isso permite responder perguntas mais ricas, como identificar sobreposições de cobertura entre seguradoras diferentes</a:t>
+            </a:r>
+          </a:p>
+          <a:p>
+            <a:pPr lvl="0"/>
+            <a:r>
+              <a:rPr/>
+              <a:t>O assistente passa a enxergar o panorama completo do cliente, e não apenas um documento isolado</a:t>
+            </a:r>
+          </a:p>
+          <a:p>
+            <a:pPr lvl="0"/>
+            <a:r>
+              <a:rPr/>
+              <a:t>É um salto de “responder perguntas” para “gerar recomendações de negócio”</a:t>
+            </a:r>
+          </a:p>
+        </p:txBody>
+      </p:sp>
+    </p:spTree>
+  </p:cSld>
+</p:sld>
+</file>
+
+<file path=ppt/slides/slide42.xml><?xml version="1.0" encoding="utf-8"?>
+<p:sld xmlns:a="http://schemas.openxmlformats.org/drawingml/2006/main" xmlns:r="http://schemas.openxmlformats.org/officeDocument/2006/relationships" xmlns:p="http://schemas.openxmlformats.org/presentationml/2006/main">
+  <p:cSld>
+    <p:spTree>
+      <p:nvGrpSpPr>
+        <p:cNvPr id="1" name=""/>
+        <p:cNvGrpSpPr/>
+        <p:nvPr/>
+      </p:nvGrpSpPr>
+      <p:grpSpPr>
+        <a:xfrm>
+          <a:off x="0" y="0"/>
+          <a:ext cx="0" cy="0"/>
+          <a:chOff x="0" y="0"/>
+          <a:chExt cx="0" cy="0"/>
+        </a:xfrm>
+      </p:grpSpPr>
+      <p:sp>
+        <p:nvSpPr>
+          <p:cNvPr id="2" name="Title 1"/>
+          <p:cNvSpPr>
+            <a:spLocks noGrp="1"/>
+          </p:cNvSpPr>
+          <p:nvPr>
+            <p:ph type="title"/>
+          </p:nvPr>
+        </p:nvSpPr>
+        <p:spPr/>
+        <p:txBody>
+          <a:bodyPr/>
+          <a:lstStyle/>
+          <a:p>
+            <a:pPr lvl="0" indent="0" marL="0">
+              <a:buNone/>
+            </a:pPr>
+            <a:r>
+              <a:rPr/>
+              <a:t>Benefícios para o negócio</a:t>
+            </a:r>
+          </a:p>
+        </p:txBody>
+      </p:sp>
+      <p:sp>
+        <p:nvSpPr>
+          <p:cNvPr id="3" name="Content Placeholder 2"/>
+          <p:cNvSpPr>
+            <a:spLocks noGrp="1"/>
+          </p:cNvSpPr>
+          <p:nvPr>
+            <p:ph idx="1"/>
+          </p:nvPr>
+        </p:nvSpPr>
+        <p:spPr/>
+        <p:txBody>
+          <a:bodyPr/>
+          <a:lstStyle/>
+          <a:p>
+            <a:pPr lvl="0"/>
+            <a:r>
+              <a:rPr/>
+              <a:t>Atendimento mais rápido, com menos tempo de espera para o cliente</a:t>
+            </a:r>
+          </a:p>
+          <a:p>
+            <a:pPr lvl="0"/>
+            <a:r>
+              <a:rPr/>
+              <a:t>Menos erros por informação desatualizada ou mal interpretada</a:t>
+            </a:r>
+          </a:p>
+          <a:p>
+            <a:pPr lvl="0"/>
+            <a:r>
+              <a:rPr/>
+              <a:t>Decisões melhores, apoiadas em uma visão mais completa do cliente</a:t>
+            </a:r>
+          </a:p>
+          <a:p>
+            <a:pPr lvl="0"/>
+            <a:r>
+              <a:rPr/>
+              <a:t>Integração mais simples com os sistemas de cada seguradora parceira</a:t>
+            </a:r>
+          </a:p>
+        </p:txBody>
+      </p:sp>
+    </p:spTree>
+  </p:cSld>
+</p:sld>
+</file>
+
+<file path=ppt/slides/slide43.xml><?xml version="1.0" encoding="utf-8"?>
+<p:sld xmlns:a="http://schemas.openxmlformats.org/drawingml/2006/main" xmlns:r="http://schemas.openxmlformats.org/officeDocument/2006/relationships" xmlns:p="http://schemas.openxmlformats.org/presentationml/2006/main">
+  <p:cSld>
+    <p:spTree>
+      <p:nvGrpSpPr>
+        <p:cNvPr id="1" name=""/>
+        <p:cNvGrpSpPr/>
+        <p:nvPr/>
+      </p:nvGrpSpPr>
+      <p:grpSpPr>
+        <a:xfrm>
+          <a:off x="0" y="0"/>
+          <a:ext cx="0" cy="0"/>
+          <a:chOff x="0" y="0"/>
+          <a:chExt cx="0" cy="0"/>
+        </a:xfrm>
+      </p:grpSpPr>
+      <p:sp>
+        <p:nvSpPr>
+          <p:cNvPr id="2" name="Title 1"/>
+          <p:cNvSpPr>
+            <a:spLocks noGrp="1"/>
+          </p:cNvSpPr>
+          <p:nvPr>
+            <p:ph type="title"/>
+          </p:nvPr>
+        </p:nvSpPr>
+        <p:spPr/>
+        <p:txBody>
+          <a:bodyPr/>
+          <a:lstStyle/>
+          <a:p>
+            <a:pPr lvl="0" indent="0" marL="0">
+              <a:buNone/>
+            </a:pPr>
+            <a:r>
+              <a:rPr/>
+              <a:t>Cuidados importantes</a:t>
+            </a:r>
+          </a:p>
+        </p:txBody>
+      </p:sp>
+      <p:sp>
+        <p:nvSpPr>
+          <p:cNvPr id="3" name="Content Placeholder 2"/>
+          <p:cNvSpPr>
+            <a:spLocks noGrp="1"/>
+          </p:cNvSpPr>
+          <p:nvPr>
+            <p:ph idx="1"/>
+          </p:nvPr>
+        </p:nvSpPr>
+        <p:spPr/>
+        <p:txBody>
+          <a:bodyPr/>
+          <a:lstStyle/>
+          <a:p>
+            <a:pPr lvl="0"/>
+            <a:r>
+              <a:rPr/>
+              <a:t>A qualidade da resposta depende da qualidade dos dados usados como fonte</a:t>
+            </a:r>
+          </a:p>
+          <a:p>
+            <a:pPr lvl="0"/>
+            <a:r>
+              <a:rPr/>
+              <a:t>Pessoas continuam responsáveis por revisar decisões de maior impacto</a:t>
+            </a:r>
+          </a:p>
+          <a:p>
+            <a:pPr lvl="0"/>
+            <a:r>
+              <a:rPr/>
+              <a:t>É preciso definir regras claras de acesso e uso da informação dos clientes</a:t>
+            </a:r>
+          </a:p>
+          <a:p>
+            <a:pPr lvl="0"/>
+            <a:r>
+              <a:rPr/>
+              <a:t>Inteligência artificial é uma ferramenta poderosa, mas não substitui a governança do negócio</a:t>
+            </a:r>
+          </a:p>
+        </p:txBody>
+      </p:sp>
+    </p:spTree>
+  </p:cSld>
+</p:sld>
+</file>
+
+<file path=ppt/slides/slide44.xml><?xml version="1.0" encoding="utf-8"?>
+<p:sld xmlns:a="http://schemas.openxmlformats.org/drawingml/2006/main" xmlns:r="http://schemas.openxmlformats.org/officeDocument/2006/relationships" xmlns:p="http://schemas.openxmlformats.org/presentationml/2006/main">
+  <p:cSld>
+    <p:spTree>
+      <p:nvGrpSpPr>
+        <p:cNvPr id="1" name=""/>
+        <p:cNvGrpSpPr/>
+        <p:nvPr/>
+      </p:nvGrpSpPr>
+      <p:grpSpPr>
+        <a:xfrm>
+          <a:off x="0" y="0"/>
+          <a:ext cx="0" cy="0"/>
+          <a:chOff x="0" y="0"/>
+          <a:chExt cx="0" cy="0"/>
+        </a:xfrm>
+      </p:grpSpPr>
+      <p:sp>
+        <p:nvSpPr>
+          <p:cNvPr id="2" name="Title 1"/>
+          <p:cNvSpPr>
+            <a:spLocks noGrp="1"/>
+          </p:cNvSpPr>
+          <p:nvPr>
+            <p:ph type="title"/>
+          </p:nvPr>
+        </p:nvSpPr>
+        <p:spPr>
+          <a:xfrm>
+            <a:off x="722313" y="4406900"/>
+            <a:ext cx="7772400" cy="1362075"/>
+          </a:xfrm>
+        </p:spPr>
+        <p:txBody>
+          <a:bodyPr/>
+          <a:lstStyle/>
+          <a:p>
+            <a:pPr lvl="0" indent="0" marL="0">
+              <a:buNone/>
+            </a:pPr>
+            <a:r>
+              <a:rPr/>
+              <a:t>Mensagens-chave</a:t>
+            </a:r>
+          </a:p>
+        </p:txBody>
+      </p:sp>
+    </p:spTree>
+  </p:cSld>
+</p:sld>
+</file>
+
+<file path=ppt/slides/slide45.xml><?xml version="1.0" encoding="utf-8"?>
+<p:sld xmlns:a="http://schemas.openxmlformats.org/drawingml/2006/main" xmlns:r="http://schemas.openxmlformats.org/officeDocument/2006/relationships" xmlns:p="http://schemas.openxmlformats.org/presentationml/2006/main">
+  <p:cSld>
+    <p:spTree>
+      <p:nvGrpSpPr>
+        <p:cNvPr id="1" name=""/>
+        <p:cNvGrpSpPr/>
+        <p:nvPr/>
+      </p:nvGrpSpPr>
+      <p:grpSpPr>
+        <a:xfrm>
+          <a:off x="0" y="0"/>
+          <a:ext cx="0" cy="0"/>
+          <a:chOff x="0" y="0"/>
+          <a:chExt cx="0" cy="0"/>
+        </a:xfrm>
+      </p:grpSpPr>
+      <p:sp>
+        <p:nvSpPr>
+          <p:cNvPr id="2" name="Title 1"/>
+          <p:cNvSpPr>
+            <a:spLocks noGrp="1"/>
+          </p:cNvSpPr>
+          <p:nvPr>
+            <p:ph type="title"/>
+          </p:nvPr>
+        </p:nvSpPr>
+        <p:spPr/>
+        <p:txBody>
+          <a:bodyPr/>
+          <a:lstStyle/>
+          <a:p>
+            <a:pPr lvl="0" indent="0" marL="0">
+              <a:buNone/>
+            </a:pPr>
+            <a:r>
+              <a:rPr/>
+              <a:t>O que vale levar desta conversa</a:t>
+            </a:r>
+          </a:p>
+        </p:txBody>
+      </p:sp>
+      <p:sp>
+        <p:nvSpPr>
+          <p:cNvPr id="3" name="Content Placeholder 2"/>
+          <p:cNvSpPr>
+            <a:spLocks noGrp="1"/>
+          </p:cNvSpPr>
+          <p:nvPr>
+            <p:ph idx="1"/>
+          </p:nvPr>
+        </p:nvSpPr>
+        <p:spPr/>
+        <p:txBody>
+          <a:bodyPr/>
+          <a:lstStyle/>
+          <a:p>
+            <a:pPr lvl="0"/>
+            <a:r>
+              <a:rPr/>
+              <a:t>Todo produto e toda funcionalidade seguem um ciclo, da oportunidade ao aprendizado</a:t>
+            </a:r>
+          </a:p>
+          <a:p>
+            <a:pPr lvl="0"/>
+            <a:r>
+              <a:rPr/>
+              <a:t>Product Owner, System Engineer e Tech Lead olham para o mesmo problema sob ângulos diferentes</a:t>
+            </a:r>
+          </a:p>
+          <a:p>
+            <a:pPr lvl="0"/>
+            <a:r>
+              <a:rPr/>
+              <a:t>Ciclos curtos e validação rápida reduzem risco e aceleram resultados</a:t>
+            </a:r>
+          </a:p>
+          <a:p>
+            <a:pPr lvl="0"/>
+            <a:r>
+              <a:rPr/>
+              <a:t>A inteligência artificial adiciona uma nova camada de valor, mas exige dados confiáveis e boa governança</a:t>
+            </a:r>
+          </a:p>
+        </p:txBody>
+      </p:sp>
+    </p:spTree>
+  </p:cSld>
+</p:sld>
+</file>
+
+<file path=ppt/slides/slide46.xml><?xml version="1.0" encoding="utf-8"?>
+<p:sld xmlns:a="http://schemas.openxmlformats.org/drawingml/2006/main" xmlns:r="http://schemas.openxmlformats.org/officeDocument/2006/relationships" xmlns:p="http://schemas.openxmlformats.org/presentationml/2006/main">
+  <p:cSld>
+    <p:spTree>
+      <p:nvGrpSpPr>
+        <p:cNvPr id="1" name=""/>
+        <p:cNvGrpSpPr/>
+        <p:nvPr/>
+      </p:nvGrpSpPr>
+      <p:grpSpPr>
+        <a:xfrm>
+          <a:off x="0" y="0"/>
+          <a:ext cx="0" cy="0"/>
+          <a:chOff x="0" y="0"/>
+          <a:chExt cx="0" cy="0"/>
+        </a:xfrm>
+      </p:grpSpPr>
+      <p:sp>
+        <p:nvSpPr>
+          <p:cNvPr id="2" name="Title 1"/>
+          <p:cNvSpPr>
+            <a:spLocks noGrp="1"/>
+          </p:cNvSpPr>
+          <p:nvPr>
+            <p:ph type="title"/>
+          </p:nvPr>
+        </p:nvSpPr>
+        <p:spPr>
+          <a:xfrm>
+            <a:off x="722313" y="4406900"/>
+            <a:ext cx="7772400" cy="1362075"/>
+          </a:xfrm>
+        </p:spPr>
+        <p:txBody>
+          <a:bodyPr/>
+          <a:lstStyle/>
+          <a:p>
+            <a:pPr lvl="0" indent="0" marL="0">
+              <a:buNone/>
+            </a:pPr>
+            <a:r>
+              <a:rPr/>
+              <a:t>Obrigado</a:t>
             </a:r>
           </a:p>
         </p:txBody>

</xml_diff>

<commit_message>
Adiciona prints reais do NovaSeguro Copiloto ao caso prático
Insere 5 slides com screenshots da aplicação de verdade (home pública,
painel, chat com o assistente de IA, lista de clientes e a tela de envio
de PDFs/Docling), logo após os diagramas conceituais de previsão e
renovação e antes de "Benefícios para o negócio" — mostrando que o caso
descrito na apresentação foi de fato construído, não ficou só no conceito.

Co-Authored-By: Claude Sonnet 5 <noreply@anthropic.com>
Claude-Session: https://claude.ai/code/session_017dKXPAcE5bAggx1M3V9VCU
</commit_message>
<xml_diff>
--- a/presentation/apresentacao.pptx
+++ b/presentation/apresentacao.pptx
@@ -5,7 +5,7 @@
     <p:sldMasterId id="2147483648" r:id="rId1"/>
   </p:sldMasterIdLst>
   <p:notesMasterIdLst>
-    <p:notesMasterId r:id="rId51"/>
+    <p:notesMasterId r:id="rId56"/>
   </p:notesMasterIdLst>
   <p:sldIdLst>
     <p:sldId id="256" r:id="rId2"/>
@@ -57,6 +57,11 @@
     <p:sldId id="302" r:id="rId48"/>
     <p:sldId id="303" r:id="rId49"/>
     <p:sldId id="304" r:id="rId50"/>
+    <p:sldId id="305" r:id="rId51"/>
+    <p:sldId id="306" r:id="rId52"/>
+    <p:sldId id="307" r:id="rId53"/>
+    <p:sldId id="308" r:id="rId54"/>
+    <p:sldId id="309" r:id="rId55"/>
   </p:sldIdLst>
   <p:sldSz cx="12191695" cy="6858000" type="screen4x3"/>
   <p:notesSz cx="6858000" cy="9144000"/>
@@ -579,6 +584,88 @@
             <a:fld id="{18BDFEC3-8487-43E8-A154-7C12CBC1FFF2}" type="slidenum">
               <a:rPr lang="en-US"/>
               <a:t>2</a:t>
+            </a:fld>
+            <a:endParaRPr lang="en-US"/>
+          </a:p>
+        </p:txBody>
+      </p:sp>
+    </p:spTree>
+  </p:cSld>
+</p:notes>
+</file>
+
+<file path=ppt/notesSlides/notesSlide10.xml><?xml version="1.0" encoding="utf-8"?>
+<p:notes xmlns:a="http://schemas.openxmlformats.org/drawingml/2006/main" xmlns:r="http://schemas.openxmlformats.org/officeDocument/2006/relationships" xmlns:p="http://schemas.openxmlformats.org/presentationml/2006/main">
+  <p:cSld>
+    <p:spTree>
+      <p:nvGrpSpPr>
+        <p:cNvPr id="1" name=""/>
+        <p:cNvGrpSpPr/>
+        <p:nvPr/>
+      </p:nvGrpSpPr>
+      <p:grpSpPr>
+        <a:xfrm>
+          <a:off x="0" y="0"/>
+          <a:ext cx="0" cy="0"/>
+          <a:chOff x="0" y="0"/>
+          <a:chExt cx="0" cy="0"/>
+        </a:xfrm>
+      </p:grpSpPr>
+      <p:sp>
+        <p:nvSpPr>
+          <p:cNvPr id="2" name="Slide Image Placeholder 1"/>
+          <p:cNvSpPr>
+            <a:spLocks noGrp="1" noRot="1" noChangeAspect="1"/>
+          </p:cNvSpPr>
+          <p:nvPr>
+            <p:ph type="sldImg"/>
+          </p:nvPr>
+        </p:nvSpPr>
+        <p:spPr/>
+      </p:sp>
+      <p:sp>
+        <p:nvSpPr>
+          <p:cNvPr id="3" name="Notes Placeholder 2"/>
+          <p:cNvSpPr>
+            <a:spLocks noGrp="1"/>
+          </p:cNvSpPr>
+          <p:nvPr>
+            <p:ph type="body" idx="1"/>
+          </p:nvPr>
+        </p:nvSpPr>
+        <p:spPr/>
+        <p:txBody>
+          <a:bodyPr/>
+          <a:lstStyle/>
+          <a:p>
+            <a:pPr lvl="0" indent="0" marL="0">
+              <a:buNone/>
+            </a:pPr>
+            <a:r>
+              <a:rPr/>
+              <a:t>Tudo que foi descrito até aqui não ficou só no conceito: esta é a página inicial real da ferramenta, já construída, com a mesma identidade visual usada nesta apresentação. A partir daqui, alguns prints do dia a dia de quem usa o copiloto.</a:t>
+            </a:r>
+          </a:p>
+        </p:txBody>
+      </p:sp>
+      <p:sp>
+        <p:nvSpPr>
+          <p:cNvPr id="4" name="Slide Number Placeholder 3"/>
+          <p:cNvSpPr>
+            <a:spLocks noGrp="1"/>
+          </p:cNvSpPr>
+          <p:nvPr>
+            <p:ph type="sldNum" sz="quarter" idx="10"/>
+          </p:nvPr>
+        </p:nvSpPr>
+        <p:spPr/>
+        <p:txBody>
+          <a:bodyPr/>
+          <a:lstStyle/>
+          <a:p>
+            <a:fld id="{18BDFEC3-8487-43E8-A154-7C12CBC1FFF2}" type="slidenum">
+              <a:rPr lang="en-US"/>
+              <a:t>47</a:t>
             </a:fld>
             <a:endParaRPr lang="en-US"/>
           </a:p>
@@ -7640,55 +7727,41 @@
             </a:pPr>
             <a:r>
               <a:rPr/>
-              <a:t>Benefícios para o negócio</a:t>
-            </a:r>
-          </a:p>
-        </p:txBody>
-      </p:sp>
-      <p:sp>
-        <p:nvSpPr>
-          <p:cNvPr id="3" name="Content Placeholder 2"/>
-          <p:cNvSpPr>
-            <a:spLocks noGrp="1"/>
-          </p:cNvSpPr>
-          <p:nvPr>
-            <p:ph idx="1"/>
-          </p:nvPr>
-        </p:nvSpPr>
-        <p:spPr/>
-        <p:txBody>
-          <a:bodyPr/>
-          <a:lstStyle/>
-          <a:p>
-            <a:pPr lvl="0"/>
-            <a:r>
-              <a:rPr/>
-              <a:t>Atendimento mais rápido e preciso, com menos tempo de espera para o cliente</a:t>
-            </a:r>
-          </a:p>
-          <a:p>
-            <a:pPr lvl="0"/>
-            <a:r>
-              <a:rPr/>
-              <a:t>Menos cancelamentos, porque sinais de risco são tratados antes do vencimento da apólice</a:t>
-            </a:r>
-          </a:p>
-          <a:p>
-            <a:pPr lvl="0"/>
-            <a:r>
-              <a:rPr/>
-              <a:t>Previsão de receita mais confiável, o que ajuda o planejamento financeiro da corretora</a:t>
-            </a:r>
-          </a:p>
-          <a:p>
-            <a:pPr lvl="0"/>
-            <a:r>
-              <a:rPr/>
-              <a:t>Decisões melhores, apoiadas em uma visão mais completa de cada cliente</a:t>
-            </a:r>
-          </a:p>
-        </p:txBody>
-      </p:sp>
+              <a:t>Do papel para a tela: a ferramenta em produção</a:t>
+            </a:r>
+          </a:p>
+        </p:txBody>
+      </p:sp>
+      <p:pic>
+        <p:nvPicPr>
+          <p:cNvPr descr="assets/screenshots/app_home.png" id="0" name="Picture 1"/>
+          <p:cNvPicPr>
+            <a:picLocks noGrp="1" noChangeAspect="1"/>
+          </p:cNvPicPr>
+          <p:nvPr/>
+        </p:nvPicPr>
+        <p:blipFill>
+          <a:blip r:embed="rId3"/>
+          <a:stretch>
+            <a:fillRect/>
+          </a:stretch>
+        </p:blipFill>
+        <p:spPr bwMode="auto">
+          <a:xfrm>
+            <a:off x="952500" y="1600200"/>
+            <a:ext cx="7239000" cy="4521200"/>
+          </a:xfrm>
+          <a:prstGeom prst="rect">
+            <a:avLst/>
+          </a:prstGeom>
+          <a:noFill/>
+          <a:ln w="9525">
+            <a:noFill/>
+            <a:headEnd/>
+            <a:tailEnd/>
+          </a:ln>
+        </p:spPr>
+      </p:pic>
     </p:spTree>
   </p:cSld>
 </p:sld>
@@ -7731,55 +7804,41 @@
             </a:pPr>
             <a:r>
               <a:rPr/>
-              <a:t>Cuidados importantes</a:t>
-            </a:r>
-          </a:p>
-        </p:txBody>
-      </p:sp>
-      <p:sp>
-        <p:nvSpPr>
-          <p:cNvPr id="3" name="Content Placeholder 2"/>
-          <p:cNvSpPr>
-            <a:spLocks noGrp="1"/>
-          </p:cNvSpPr>
-          <p:nvPr>
-            <p:ph idx="1"/>
-          </p:nvPr>
-        </p:nvSpPr>
-        <p:spPr/>
-        <p:txBody>
-          <a:bodyPr/>
-          <a:lstStyle/>
-          <a:p>
-            <a:pPr lvl="0"/>
-            <a:r>
-              <a:rPr/>
-              <a:t>A qualidade da previsão depende da qualidade dos dados usados como fonte</a:t>
-            </a:r>
-          </a:p>
-          <a:p>
-            <a:pPr lvl="0"/>
-            <a:r>
-              <a:rPr/>
-              <a:t>Pessoas continuam responsáveis por revisar decisões de maior impacto</a:t>
-            </a:r>
-          </a:p>
-          <a:p>
-            <a:pPr lvl="0"/>
-            <a:r>
-              <a:rPr/>
-              <a:t>O contato automático com o cliente precisa ser cuidadoso, sem parecer invasivo ou impessoal</a:t>
-            </a:r>
-          </a:p>
-          <a:p>
-            <a:pPr lvl="0"/>
-            <a:r>
-              <a:rPr/>
-              <a:t>Inteligência artificial é uma ferramenta poderosa, mas não substitui a governança do negócio</a:t>
-            </a:r>
-          </a:p>
-        </p:txBody>
-      </p:sp>
+              <a:t>Painel do corretor, com dados reais da carteira</a:t>
+            </a:r>
+          </a:p>
+        </p:txBody>
+      </p:sp>
+      <p:pic>
+        <p:nvPicPr>
+          <p:cNvPr descr="assets/screenshots/app_dashboard.png" id="0" name="Picture 1"/>
+          <p:cNvPicPr>
+            <a:picLocks noGrp="1" noChangeAspect="1"/>
+          </p:cNvPicPr>
+          <p:nvPr/>
+        </p:nvPicPr>
+        <p:blipFill>
+          <a:blip r:embed="rId2"/>
+          <a:stretch>
+            <a:fillRect/>
+          </a:stretch>
+        </p:blipFill>
+        <p:spPr bwMode="auto">
+          <a:xfrm>
+            <a:off x="952500" y="1600200"/>
+            <a:ext cx="7239000" cy="4521200"/>
+          </a:xfrm>
+          <a:prstGeom prst="rect">
+            <a:avLst/>
+          </a:prstGeom>
+          <a:noFill/>
+          <a:ln w="9525">
+            <a:noFill/>
+            <a:headEnd/>
+            <a:tailEnd/>
+          </a:ln>
+        </p:spPr>
+      </p:pic>
     </p:spTree>
   </p:cSld>
 </p:sld>
@@ -7812,12 +7871,7 @@
             <p:ph type="title"/>
           </p:nvPr>
         </p:nvSpPr>
-        <p:spPr>
-          <a:xfrm>
-            <a:off x="722313" y="4406900"/>
-            <a:ext cx="7772400" cy="1362075"/>
-          </a:xfrm>
-        </p:spPr>
+        <p:spPr/>
         <p:txBody>
           <a:bodyPr/>
           <a:lstStyle/>
@@ -7827,11 +7881,41 @@
             </a:pPr>
             <a:r>
               <a:rPr/>
-              <a:t>Obrigado</a:t>
-            </a:r>
-          </a:p>
-        </p:txBody>
-      </p:sp>
+              <a:t>Conversando com o copiloto de IA</a:t>
+            </a:r>
+          </a:p>
+        </p:txBody>
+      </p:sp>
+      <p:pic>
+        <p:nvPicPr>
+          <p:cNvPr descr="assets/screenshots/app_chat.png" id="0" name="Picture 1"/>
+          <p:cNvPicPr>
+            <a:picLocks noGrp="1" noChangeAspect="1"/>
+          </p:cNvPicPr>
+          <p:nvPr/>
+        </p:nvPicPr>
+        <p:blipFill>
+          <a:blip r:embed="rId2"/>
+          <a:stretch>
+            <a:fillRect/>
+          </a:stretch>
+        </p:blipFill>
+        <p:spPr bwMode="auto">
+          <a:xfrm>
+            <a:off x="952500" y="1600200"/>
+            <a:ext cx="7239000" cy="4521200"/>
+          </a:xfrm>
+          <a:prstGeom prst="rect">
+            <a:avLst/>
+          </a:prstGeom>
+          <a:noFill/>
+          <a:ln w="9525">
+            <a:noFill/>
+            <a:headEnd/>
+            <a:tailEnd/>
+          </a:ln>
+        </p:spPr>
+      </p:pic>
     </p:spTree>
   </p:cSld>
 </p:sld>
@@ -7909,6 +7993,394 @@
           </a:ln>
         </p:spPr>
       </p:pic>
+    </p:spTree>
+  </p:cSld>
+</p:sld>
+</file>
+
+<file path=ppt/slides/slide50.xml><?xml version="1.0" encoding="utf-8"?>
+<p:sld xmlns:a="http://schemas.openxmlformats.org/drawingml/2006/main" xmlns:r="http://schemas.openxmlformats.org/officeDocument/2006/relationships" xmlns:p="http://schemas.openxmlformats.org/presentationml/2006/main">
+  <p:cSld>
+    <p:spTree>
+      <p:nvGrpSpPr>
+        <p:cNvPr id="1" name=""/>
+        <p:cNvGrpSpPr/>
+        <p:nvPr/>
+      </p:nvGrpSpPr>
+      <p:grpSpPr>
+        <a:xfrm>
+          <a:off x="0" y="0"/>
+          <a:ext cx="0" cy="0"/>
+          <a:chOff x="0" y="0"/>
+          <a:chExt cx="0" cy="0"/>
+        </a:xfrm>
+      </p:grpSpPr>
+      <p:sp>
+        <p:nvSpPr>
+          <p:cNvPr id="2" name="Title 1"/>
+          <p:cNvSpPr>
+            <a:spLocks noGrp="1"/>
+          </p:cNvSpPr>
+          <p:nvPr>
+            <p:ph type="title"/>
+          </p:nvPr>
+        </p:nvSpPr>
+        <p:spPr/>
+        <p:txBody>
+          <a:bodyPr/>
+          <a:lstStyle/>
+          <a:p>
+            <a:pPr lvl="0" indent="0" marL="0">
+              <a:buNone/>
+            </a:pPr>
+            <a:r>
+              <a:rPr/>
+              <a:t>Visão da carteira de clientes</a:t>
+            </a:r>
+          </a:p>
+        </p:txBody>
+      </p:sp>
+      <p:pic>
+        <p:nvPicPr>
+          <p:cNvPr descr="assets/screenshots/app_clientes.png" id="0" name="Picture 1"/>
+          <p:cNvPicPr>
+            <a:picLocks noGrp="1" noChangeAspect="1"/>
+          </p:cNvPicPr>
+          <p:nvPr/>
+        </p:nvPicPr>
+        <p:blipFill>
+          <a:blip r:embed="rId2"/>
+          <a:stretch>
+            <a:fillRect/>
+          </a:stretch>
+        </p:blipFill>
+        <p:spPr bwMode="auto">
+          <a:xfrm>
+            <a:off x="952500" y="1600200"/>
+            <a:ext cx="7239000" cy="4521200"/>
+          </a:xfrm>
+          <a:prstGeom prst="rect">
+            <a:avLst/>
+          </a:prstGeom>
+          <a:noFill/>
+          <a:ln w="9525">
+            <a:noFill/>
+            <a:headEnd/>
+            <a:tailEnd/>
+          </a:ln>
+        </p:spPr>
+      </p:pic>
+    </p:spTree>
+  </p:cSld>
+</p:sld>
+</file>
+
+<file path=ppt/slides/slide51.xml><?xml version="1.0" encoding="utf-8"?>
+<p:sld xmlns:a="http://schemas.openxmlformats.org/drawingml/2006/main" xmlns:r="http://schemas.openxmlformats.org/officeDocument/2006/relationships" xmlns:p="http://schemas.openxmlformats.org/presentationml/2006/main">
+  <p:cSld>
+    <p:spTree>
+      <p:nvGrpSpPr>
+        <p:cNvPr id="1" name=""/>
+        <p:cNvGrpSpPr/>
+        <p:nvPr/>
+      </p:nvGrpSpPr>
+      <p:grpSpPr>
+        <a:xfrm>
+          <a:off x="0" y="0"/>
+          <a:ext cx="0" cy="0"/>
+          <a:chOff x="0" y="0"/>
+          <a:chExt cx="0" cy="0"/>
+        </a:xfrm>
+      </p:grpSpPr>
+      <p:sp>
+        <p:nvSpPr>
+          <p:cNvPr id="2" name="Title 1"/>
+          <p:cNvSpPr>
+            <a:spLocks noGrp="1"/>
+          </p:cNvSpPr>
+          <p:nvPr>
+            <p:ph type="title"/>
+          </p:nvPr>
+        </p:nvSpPr>
+        <p:spPr/>
+        <p:txBody>
+          <a:bodyPr/>
+          <a:lstStyle/>
+          <a:p>
+            <a:pPr lvl="0" indent="0" marL="0">
+              <a:buNone/>
+            </a:pPr>
+            <a:r>
+              <a:rPr/>
+              <a:t>Enviando apólices em PDF para a base de conhecimento</a:t>
+            </a:r>
+          </a:p>
+        </p:txBody>
+      </p:sp>
+      <p:pic>
+        <p:nvPicPr>
+          <p:cNvPr descr="assets/screenshots/app_documentos.png" id="0" name="Picture 1"/>
+          <p:cNvPicPr>
+            <a:picLocks noGrp="1" noChangeAspect="1"/>
+          </p:cNvPicPr>
+          <p:nvPr/>
+        </p:nvPicPr>
+        <p:blipFill>
+          <a:blip r:embed="rId2"/>
+          <a:stretch>
+            <a:fillRect/>
+          </a:stretch>
+        </p:blipFill>
+        <p:spPr bwMode="auto">
+          <a:xfrm>
+            <a:off x="952500" y="1600200"/>
+            <a:ext cx="7239000" cy="4521200"/>
+          </a:xfrm>
+          <a:prstGeom prst="rect">
+            <a:avLst/>
+          </a:prstGeom>
+          <a:noFill/>
+          <a:ln w="9525">
+            <a:noFill/>
+            <a:headEnd/>
+            <a:tailEnd/>
+          </a:ln>
+        </p:spPr>
+      </p:pic>
+    </p:spTree>
+  </p:cSld>
+</p:sld>
+</file>
+
+<file path=ppt/slides/slide52.xml><?xml version="1.0" encoding="utf-8"?>
+<p:sld xmlns:a="http://schemas.openxmlformats.org/drawingml/2006/main" xmlns:r="http://schemas.openxmlformats.org/officeDocument/2006/relationships" xmlns:p="http://schemas.openxmlformats.org/presentationml/2006/main">
+  <p:cSld>
+    <p:spTree>
+      <p:nvGrpSpPr>
+        <p:cNvPr id="1" name=""/>
+        <p:cNvGrpSpPr/>
+        <p:nvPr/>
+      </p:nvGrpSpPr>
+      <p:grpSpPr>
+        <a:xfrm>
+          <a:off x="0" y="0"/>
+          <a:ext cx="0" cy="0"/>
+          <a:chOff x="0" y="0"/>
+          <a:chExt cx="0" cy="0"/>
+        </a:xfrm>
+      </p:grpSpPr>
+      <p:sp>
+        <p:nvSpPr>
+          <p:cNvPr id="2" name="Title 1"/>
+          <p:cNvSpPr>
+            <a:spLocks noGrp="1"/>
+          </p:cNvSpPr>
+          <p:nvPr>
+            <p:ph type="title"/>
+          </p:nvPr>
+        </p:nvSpPr>
+        <p:spPr/>
+        <p:txBody>
+          <a:bodyPr/>
+          <a:lstStyle/>
+          <a:p>
+            <a:pPr lvl="0" indent="0" marL="0">
+              <a:buNone/>
+            </a:pPr>
+            <a:r>
+              <a:rPr/>
+              <a:t>Benefícios para o negócio</a:t>
+            </a:r>
+          </a:p>
+        </p:txBody>
+      </p:sp>
+      <p:sp>
+        <p:nvSpPr>
+          <p:cNvPr id="3" name="Content Placeholder 2"/>
+          <p:cNvSpPr>
+            <a:spLocks noGrp="1"/>
+          </p:cNvSpPr>
+          <p:nvPr>
+            <p:ph idx="1"/>
+          </p:nvPr>
+        </p:nvSpPr>
+        <p:spPr/>
+        <p:txBody>
+          <a:bodyPr/>
+          <a:lstStyle/>
+          <a:p>
+            <a:pPr lvl="0"/>
+            <a:r>
+              <a:rPr/>
+              <a:t>Atendimento mais rápido e preciso, com menos tempo de espera para o cliente</a:t>
+            </a:r>
+          </a:p>
+          <a:p>
+            <a:pPr lvl="0"/>
+            <a:r>
+              <a:rPr/>
+              <a:t>Menos cancelamentos, porque sinais de risco são tratados antes do vencimento da apólice</a:t>
+            </a:r>
+          </a:p>
+          <a:p>
+            <a:pPr lvl="0"/>
+            <a:r>
+              <a:rPr/>
+              <a:t>Previsão de receita mais confiável, o que ajuda o planejamento financeiro da corretora</a:t>
+            </a:r>
+          </a:p>
+          <a:p>
+            <a:pPr lvl="0"/>
+            <a:r>
+              <a:rPr/>
+              <a:t>Decisões melhores, apoiadas em uma visão mais completa de cada cliente</a:t>
+            </a:r>
+          </a:p>
+        </p:txBody>
+      </p:sp>
+    </p:spTree>
+  </p:cSld>
+</p:sld>
+</file>
+
+<file path=ppt/slides/slide53.xml><?xml version="1.0" encoding="utf-8"?>
+<p:sld xmlns:a="http://schemas.openxmlformats.org/drawingml/2006/main" xmlns:r="http://schemas.openxmlformats.org/officeDocument/2006/relationships" xmlns:p="http://schemas.openxmlformats.org/presentationml/2006/main">
+  <p:cSld>
+    <p:spTree>
+      <p:nvGrpSpPr>
+        <p:cNvPr id="1" name=""/>
+        <p:cNvGrpSpPr/>
+        <p:nvPr/>
+      </p:nvGrpSpPr>
+      <p:grpSpPr>
+        <a:xfrm>
+          <a:off x="0" y="0"/>
+          <a:ext cx="0" cy="0"/>
+          <a:chOff x="0" y="0"/>
+          <a:chExt cx="0" cy="0"/>
+        </a:xfrm>
+      </p:grpSpPr>
+      <p:sp>
+        <p:nvSpPr>
+          <p:cNvPr id="2" name="Title 1"/>
+          <p:cNvSpPr>
+            <a:spLocks noGrp="1"/>
+          </p:cNvSpPr>
+          <p:nvPr>
+            <p:ph type="title"/>
+          </p:nvPr>
+        </p:nvSpPr>
+        <p:spPr/>
+        <p:txBody>
+          <a:bodyPr/>
+          <a:lstStyle/>
+          <a:p>
+            <a:pPr lvl="0" indent="0" marL="0">
+              <a:buNone/>
+            </a:pPr>
+            <a:r>
+              <a:rPr/>
+              <a:t>Cuidados importantes</a:t>
+            </a:r>
+          </a:p>
+        </p:txBody>
+      </p:sp>
+      <p:sp>
+        <p:nvSpPr>
+          <p:cNvPr id="3" name="Content Placeholder 2"/>
+          <p:cNvSpPr>
+            <a:spLocks noGrp="1"/>
+          </p:cNvSpPr>
+          <p:nvPr>
+            <p:ph idx="1"/>
+          </p:nvPr>
+        </p:nvSpPr>
+        <p:spPr/>
+        <p:txBody>
+          <a:bodyPr/>
+          <a:lstStyle/>
+          <a:p>
+            <a:pPr lvl="0"/>
+            <a:r>
+              <a:rPr/>
+              <a:t>A qualidade da previsão depende da qualidade dos dados usados como fonte</a:t>
+            </a:r>
+          </a:p>
+          <a:p>
+            <a:pPr lvl="0"/>
+            <a:r>
+              <a:rPr/>
+              <a:t>Pessoas continuam responsáveis por revisar decisões de maior impacto</a:t>
+            </a:r>
+          </a:p>
+          <a:p>
+            <a:pPr lvl="0"/>
+            <a:r>
+              <a:rPr/>
+              <a:t>O contato automático com o cliente precisa ser cuidadoso, sem parecer invasivo ou impessoal</a:t>
+            </a:r>
+          </a:p>
+          <a:p>
+            <a:pPr lvl="0"/>
+            <a:r>
+              <a:rPr/>
+              <a:t>Inteligência artificial é uma ferramenta poderosa, mas não substitui a governança do negócio</a:t>
+            </a:r>
+          </a:p>
+        </p:txBody>
+      </p:sp>
+    </p:spTree>
+  </p:cSld>
+</p:sld>
+</file>
+
+<file path=ppt/slides/slide54.xml><?xml version="1.0" encoding="utf-8"?>
+<p:sld xmlns:a="http://schemas.openxmlformats.org/drawingml/2006/main" xmlns:r="http://schemas.openxmlformats.org/officeDocument/2006/relationships" xmlns:p="http://schemas.openxmlformats.org/presentationml/2006/main">
+  <p:cSld>
+    <p:spTree>
+      <p:nvGrpSpPr>
+        <p:cNvPr id="1" name=""/>
+        <p:cNvGrpSpPr/>
+        <p:nvPr/>
+      </p:nvGrpSpPr>
+      <p:grpSpPr>
+        <a:xfrm>
+          <a:off x="0" y="0"/>
+          <a:ext cx="0" cy="0"/>
+          <a:chOff x="0" y="0"/>
+          <a:chExt cx="0" cy="0"/>
+        </a:xfrm>
+      </p:grpSpPr>
+      <p:sp>
+        <p:nvSpPr>
+          <p:cNvPr id="2" name="Title 1"/>
+          <p:cNvSpPr>
+            <a:spLocks noGrp="1"/>
+          </p:cNvSpPr>
+          <p:nvPr>
+            <p:ph type="title"/>
+          </p:nvPr>
+        </p:nvSpPr>
+        <p:spPr>
+          <a:xfrm>
+            <a:off x="722313" y="4406900"/>
+            <a:ext cx="7772400" cy="1362075"/>
+          </a:xfrm>
+        </p:spPr>
+        <p:txBody>
+          <a:bodyPr/>
+          <a:lstStyle/>
+          <a:p>
+            <a:pPr lvl="0" indent="0" marL="0">
+              <a:buNone/>
+            </a:pPr>
+            <a:r>
+              <a:rPr/>
+              <a:t>Obrigado</a:t>
+            </a:r>
+          </a:p>
+        </p:txBody>
+      </p:sp>
     </p:spTree>
   </p:cSld>
 </p:sld>

</xml_diff>

<commit_message>
Consolidar papéis PO/System Engineer/Tech Lead em dois núcleos
Substitui os três papéis (PO, System Engineer, Tech Lead) por dois
núcleos: "Núcleo de Negócios" (voz do negócio e do cliente) e "Núcleo
Técnico", que consolida as responsabilidades de arquitetura/integração
do System Engineer com as de liderança técnica/qualidade do Tech Lead.
Atualiza o diagrama de papéis (2 nós em vez de 3) e a menção na seção
de mensagens-chave, e rebuilda o deck.

Co-Authored-By: Claude Sonnet 5 <noreply@anthropic.com>
Claude-Session: https://claude.ai/code/session_017dKXPAcE5bAggx1M3V9VCU
</commit_message>
<xml_diff>
--- a/presentation/apresentacao.pptx
+++ b/presentation/apresentacao.pptx
@@ -5,7 +5,7 @@
     <p:sldMasterId id="2147483648" r:id="rId1"/>
   </p:sldMasterIdLst>
   <p:notesMasterIdLst>
-    <p:notesMasterId r:id="rId56"/>
+    <p:notesMasterId r:id="rId55"/>
   </p:notesMasterIdLst>
   <p:sldIdLst>
     <p:sldId id="256" r:id="rId2"/>
@@ -61,7 +61,6 @@
     <p:sldId id="306" r:id="rId52"/>
     <p:sldId id="307" r:id="rId53"/>
     <p:sldId id="308" r:id="rId54"/>
-    <p:sldId id="309" r:id="rId55"/>
   </p:sldIdLst>
   <p:sldSz cx="12191695" cy="6858000" type="screen4x3"/>
   <p:notesSz cx="6858000" cy="9144000"/>
@@ -665,7 +664,7 @@
           <a:p>
             <a:fld id="{18BDFEC3-8487-43E8-A154-7C12CBC1FFF2}" type="slidenum">
               <a:rPr lang="en-US"/>
-              <a:t>47</a:t>
+              <a:t>46</a:t>
             </a:fld>
             <a:endParaRPr lang="en-US"/>
           </a:p>
@@ -829,7 +828,7 @@
           <a:p>
             <a:fld id="{18BDFEC3-8487-43E8-A154-7C12CBC1FFF2}" type="slidenum">
               <a:rPr lang="en-US"/>
-              <a:t>19</a:t>
+              <a:t>18</a:t>
             </a:fld>
             <a:endParaRPr lang="en-US"/>
           </a:p>
@@ -911,7 +910,7 @@
           <a:p>
             <a:fld id="{18BDFEC3-8487-43E8-A154-7C12CBC1FFF2}" type="slidenum">
               <a:rPr lang="en-US"/>
-              <a:t>23</a:t>
+              <a:t>22</a:t>
             </a:fld>
             <a:endParaRPr lang="en-US"/>
           </a:p>
@@ -993,7 +992,7 @@
           <a:p>
             <a:fld id="{18BDFEC3-8487-43E8-A154-7C12CBC1FFF2}" type="slidenum">
               <a:rPr lang="en-US"/>
-              <a:t>24</a:t>
+              <a:t>23</a:t>
             </a:fld>
             <a:endParaRPr lang="en-US"/>
           </a:p>
@@ -1075,7 +1074,7 @@
           <a:p>
             <a:fld id="{18BDFEC3-8487-43E8-A154-7C12CBC1FFF2}" type="slidenum">
               <a:rPr lang="en-US"/>
-              <a:t>28</a:t>
+              <a:t>27</a:t>
             </a:fld>
             <a:endParaRPr lang="en-US"/>
           </a:p>
@@ -1157,7 +1156,7 @@
           <a:p>
             <a:fld id="{18BDFEC3-8487-43E8-A154-7C12CBC1FFF2}" type="slidenum">
               <a:rPr lang="en-US"/>
-              <a:t>31</a:t>
+              <a:t>30</a:t>
             </a:fld>
             <a:endParaRPr lang="en-US"/>
           </a:p>
@@ -1239,7 +1238,7 @@
           <a:p>
             <a:fld id="{18BDFEC3-8487-43E8-A154-7C12CBC1FFF2}" type="slidenum">
               <a:rPr lang="en-US"/>
-              <a:t>35</a:t>
+              <a:t>34</a:t>
             </a:fld>
             <a:endParaRPr lang="en-US"/>
           </a:p>
@@ -1321,7 +1320,7 @@
           <a:p>
             <a:fld id="{18BDFEC3-8487-43E8-A154-7C12CBC1FFF2}" type="slidenum">
               <a:rPr lang="en-US"/>
-              <a:t>46</a:t>
+              <a:t>45</a:t>
             </a:fld>
             <a:endParaRPr lang="en-US"/>
           </a:p>
@@ -4437,7 +4436,7 @@
             </a:pPr>
             <a:r>
               <a:rPr/>
-              <a:t>Product Owner: a voz do negócio e do cliente</a:t>
+              <a:t>Núcleo de Negócios: a voz do negócio e do cliente</a:t>
             </a:r>
           </a:p>
         </p:txBody>
@@ -4528,7 +4527,7 @@
             </a:pPr>
             <a:r>
               <a:rPr/>
-              <a:t>System Engineer: a costura entre os sistemas</a:t>
+              <a:t>Núcleo Técnico: da arquitetura à entrega com qualidade</a:t>
             </a:r>
           </a:p>
         </p:txBody>
@@ -4551,28 +4550,28 @@
             <a:pPr lvl="0"/>
             <a:r>
               <a:rPr/>
-              <a:t>Olha para o produto de forma ampla, além de uma única funcionalidade</a:t>
-            </a:r>
-          </a:p>
-          <a:p>
-            <a:pPr lvl="0"/>
-            <a:r>
-              <a:rPr/>
-              <a:t>Garante que as diferentes partes do sistema conversem entre si sem atrito</a:t>
-            </a:r>
-          </a:p>
-          <a:p>
-            <a:pPr lvl="0"/>
-            <a:r>
-              <a:rPr/>
-              <a:t>Cuida da integração com sistemas de parceiros e de outras áreas da empresa</a:t>
-            </a:r>
-          </a:p>
-          <a:p>
-            <a:pPr lvl="0"/>
-            <a:r>
-              <a:rPr/>
-              <a:t>Pensa em crescimento futuro: a solução precisa continuar funcionando bem quando o uso aumentar</a:t>
+              <a:t>Olha para o produto de forma ampla e garante que as diferentes partes do sistema conversem entre si sem atrito, inclusive com sistemas de parceiros</a:t>
+            </a:r>
+          </a:p>
+          <a:p>
+            <a:pPr lvl="0"/>
+            <a:r>
+              <a:rPr/>
+              <a:t>Lidera o time responsável por construir a solução no dia a dia, decidindo a melhor forma técnica de resolver cada problema</a:t>
+            </a:r>
+          </a:p>
+          <a:p>
+            <a:pPr lvl="0"/>
+            <a:r>
+              <a:rPr/>
+              <a:t>Cuida da qualidade, da segurança e da manutenção do que é construído, hoje e conforme o uso cresce</a:t>
+            </a:r>
+          </a:p>
+          <a:p>
+            <a:pPr lvl="0"/>
+            <a:r>
+              <a:rPr/>
+              <a:t>Ajuda a estimar prazos e identificar riscos técnicos antes que eles virem problemas</a:t>
             </a:r>
           </a:p>
         </p:txBody>
@@ -4609,7 +4608,12 @@
             <p:ph type="title"/>
           </p:nvPr>
         </p:nvSpPr>
-        <p:spPr/>
+        <p:spPr>
+          <a:xfrm>
+            <a:off x="722313" y="4406900"/>
+            <a:ext cx="7772400" cy="1362075"/>
+          </a:xfrm>
+        </p:spPr>
         <p:txBody>
           <a:bodyPr/>
           <a:lstStyle/>
@@ -4619,51 +4623,7 @@
             </a:pPr>
             <a:r>
               <a:rPr/>
-              <a:t>Tech Lead: qualidade e liderança técnica</a:t>
-            </a:r>
-          </a:p>
-        </p:txBody>
-      </p:sp>
-      <p:sp>
-        <p:nvSpPr>
-          <p:cNvPr id="3" name="Content Placeholder 2"/>
-          <p:cNvSpPr>
-            <a:spLocks noGrp="1"/>
-          </p:cNvSpPr>
-          <p:nvPr>
-            <p:ph idx="1"/>
-          </p:nvPr>
-        </p:nvSpPr>
-        <p:spPr/>
-        <p:txBody>
-          <a:bodyPr/>
-          <a:lstStyle/>
-          <a:p>
-            <a:pPr lvl="0"/>
-            <a:r>
-              <a:rPr/>
-              <a:t>Lidera o time responsável por construir a solução no dia a dia</a:t>
-            </a:r>
-          </a:p>
-          <a:p>
-            <a:pPr lvl="0"/>
-            <a:r>
-              <a:rPr/>
-              <a:t>Decide, junto com o time, a melhor forma técnica de resolver cada problema</a:t>
-            </a:r>
-          </a:p>
-          <a:p>
-            <a:pPr lvl="0"/>
-            <a:r>
-              <a:rPr/>
-              <a:t>Cuida da qualidade, da segurança e da manutenção do que é construído</a:t>
-            </a:r>
-          </a:p>
-          <a:p>
-            <a:pPr lvl="0"/>
-            <a:r>
-              <a:rPr/>
-              <a:t>Ajuda a estimar prazos e a identificar riscos antes que eles virem problemas</a:t>
+              <a:t>Trabalhando em ciclos rápidos</a:t>
             </a:r>
           </a:p>
         </p:txBody>
@@ -4700,12 +4660,7 @@
             <p:ph type="title"/>
           </p:nvPr>
         </p:nvSpPr>
-        <p:spPr>
-          <a:xfrm>
-            <a:off x="722313" y="4406900"/>
-            <a:ext cx="7772400" cy="1362075"/>
-          </a:xfrm>
-        </p:spPr>
+        <p:spPr/>
         <p:txBody>
           <a:bodyPr/>
           <a:lstStyle/>
@@ -4715,7 +4670,51 @@
             </a:pPr>
             <a:r>
               <a:rPr/>
-              <a:t>Trabalhando em ciclos rápidos</a:t>
+              <a:t>O que são metodologias ágeis, em termos simples</a:t>
+            </a:r>
+          </a:p>
+        </p:txBody>
+      </p:sp>
+      <p:sp>
+        <p:nvSpPr>
+          <p:cNvPr id="3" name="Content Placeholder 2"/>
+          <p:cNvSpPr>
+            <a:spLocks noGrp="1"/>
+          </p:cNvSpPr>
+          <p:nvPr>
+            <p:ph idx="1"/>
+          </p:nvPr>
+        </p:nvSpPr>
+        <p:spPr/>
+        <p:txBody>
+          <a:bodyPr/>
+          <a:lstStyle/>
+          <a:p>
+            <a:pPr lvl="0"/>
+            <a:r>
+              <a:rPr/>
+              <a:t>São formas de organizar o trabalho em ciclos curtos, em vez de um grande projeto fechado</a:t>
+            </a:r>
+          </a:p>
+          <a:p>
+            <a:pPr lvl="0"/>
+            <a:r>
+              <a:rPr/>
+              <a:t>A cada ciclo, o time entrega algo que pode ser mostrado e avaliado</a:t>
+            </a:r>
+          </a:p>
+          <a:p>
+            <a:pPr lvl="0"/>
+            <a:r>
+              <a:rPr/>
+              <a:t>O plano se ajusta com frequência, a partir do que se aprende com clientes reais</a:t>
+            </a:r>
+          </a:p>
+          <a:p>
+            <a:pPr lvl="0"/>
+            <a:r>
+              <a:rPr/>
+              <a:t>O objetivo é reduzir o risco de investir muito tempo em algo que o mercado não quer</a:t>
             </a:r>
           </a:p>
         </p:txBody>
@@ -4762,7 +4761,7 @@
             </a:pPr>
             <a:r>
               <a:rPr/>
-              <a:t>O que são metodologias ágeis, em termos simples</a:t>
+              <a:t>Pequenas entregas, feedback constante</a:t>
             </a:r>
           </a:p>
         </p:txBody>
@@ -4785,28 +4784,28 @@
             <a:pPr lvl="0"/>
             <a:r>
               <a:rPr/>
-              <a:t>São formas de organizar o trabalho em ciclos curtos, em vez de um grande projeto fechado</a:t>
-            </a:r>
-          </a:p>
-          <a:p>
-            <a:pPr lvl="0"/>
-            <a:r>
-              <a:rPr/>
-              <a:t>A cada ciclo, o time entrega algo que pode ser mostrado e avaliado</a:t>
-            </a:r>
-          </a:p>
-          <a:p>
-            <a:pPr lvl="0"/>
-            <a:r>
-              <a:rPr/>
-              <a:t>O plano se ajusta com frequência, a partir do que se aprende com clientes reais</a:t>
-            </a:r>
-          </a:p>
-          <a:p>
-            <a:pPr lvl="0"/>
-            <a:r>
-              <a:rPr/>
-              <a:t>O objetivo é reduzir o risco de investir muito tempo em algo que o mercado não quer</a:t>
+              <a:t>O trabalho é dividido em ciclos de poucas semanas</a:t>
+            </a:r>
+          </a:p>
+          <a:p>
+            <a:pPr lvl="0"/>
+            <a:r>
+              <a:rPr/>
+              <a:t>Ao final de cada ciclo, o time mostra o que foi construído e recebe feedback</a:t>
+            </a:r>
+          </a:p>
+          <a:p>
+            <a:pPr lvl="0"/>
+            <a:r>
+              <a:rPr/>
+              <a:t>Problemas são identificados cedo, quando ainda são baratos e fáceis de corrigir</a:t>
+            </a:r>
+          </a:p>
+          <a:p>
+            <a:pPr lvl="0"/>
+            <a:r>
+              <a:rPr/>
+              <a:t>A equipe de negócio acompanha o progresso de perto, sem surpresas no final</a:t>
             </a:r>
           </a:p>
         </p:txBody>
@@ -4853,7 +4852,7 @@
             </a:pPr>
             <a:r>
               <a:rPr/>
-              <a:t>Pequenas entregas, feedback constante</a:t>
+              <a:t>Ciclo de validação rápida</a:t>
             </a:r>
           </a:p>
         </p:txBody>
@@ -4876,28 +4875,28 @@
             <a:pPr lvl="0"/>
             <a:r>
               <a:rPr/>
-              <a:t>O trabalho é dividido em ciclos de poucas semanas</a:t>
-            </a:r>
-          </a:p>
-          <a:p>
-            <a:pPr lvl="0"/>
-            <a:r>
-              <a:rPr/>
-              <a:t>Ao final de cada ciclo, o time mostra o que foi construído e recebe feedback</a:t>
-            </a:r>
-          </a:p>
-          <a:p>
-            <a:pPr lvl="0"/>
-            <a:r>
-              <a:rPr/>
-              <a:t>Problemas são identificados cedo, quando ainda são baratos e fáceis de corrigir</a:t>
-            </a:r>
-          </a:p>
-          <a:p>
-            <a:pPr lvl="0"/>
-            <a:r>
-              <a:rPr/>
-              <a:t>A equipe de negócio acompanha o progresso de perto, sem surpresas no final</a:t>
+              <a:t>Antes de construir a solução completa, testamos uma versão simples da ideia</a:t>
+            </a:r>
+          </a:p>
+          <a:p>
+            <a:pPr lvl="0"/>
+            <a:r>
+              <a:rPr/>
+              <a:t>Essa versão é colocada na frente de clientes reais o quanto antes</a:t>
+            </a:r>
+          </a:p>
+          <a:p>
+            <a:pPr lvl="0"/>
+            <a:r>
+              <a:rPr/>
+              <a:t>Os resultados reais substituem suposições: aprendemos o que funciona de verdade</a:t>
+            </a:r>
+          </a:p>
+          <a:p>
+            <a:pPr lvl="0"/>
+            <a:r>
+              <a:rPr/>
+              <a:t>Só investimos pesado depois de validar que a ideia gera o resultado esperado</a:t>
             </a:r>
           </a:p>
         </p:txBody>
@@ -4944,7 +4943,7 @@
             </a:pPr>
             <a:r>
               <a:rPr/>
-              <a:t>Ciclo de validação rápida</a:t>
+              <a:t>Por que isso importa para o negócio</a:t>
             </a:r>
           </a:p>
         </p:txBody>
@@ -4967,28 +4966,28 @@
             <a:pPr lvl="0"/>
             <a:r>
               <a:rPr/>
-              <a:t>Antes de construir a solução completa, testamos uma versão simples da ideia</a:t>
-            </a:r>
-          </a:p>
-          <a:p>
-            <a:pPr lvl="0"/>
-            <a:r>
-              <a:rPr/>
-              <a:t>Essa versão é colocada na frente de clientes reais o quanto antes</a:t>
-            </a:r>
-          </a:p>
-          <a:p>
-            <a:pPr lvl="0"/>
-            <a:r>
-              <a:rPr/>
-              <a:t>Os resultados reais substituem suposições: aprendemos o que funciona de verdade</a:t>
-            </a:r>
-          </a:p>
-          <a:p>
-            <a:pPr lvl="0"/>
-            <a:r>
-              <a:rPr/>
-              <a:t>Só investimos pesado depois de validar que a ideia gera o resultado esperado</a:t>
+              <a:t>Reduz o risco de gastar tempo e dinheiro em algo que ninguém vai usar</a:t>
+            </a:r>
+          </a:p>
+          <a:p>
+            <a:pPr lvl="0"/>
+            <a:r>
+              <a:rPr/>
+              <a:t>Acelera o tempo entre a ideia e o valor entregue ao cliente</a:t>
+            </a:r>
+          </a:p>
+          <a:p>
+            <a:pPr lvl="0"/>
+            <a:r>
+              <a:rPr/>
+              <a:t>Dá visibilidade constante ao negócio sobre o andamento do trabalho</a:t>
+            </a:r>
+          </a:p>
+          <a:p>
+            <a:pPr lvl="0"/>
+            <a:r>
+              <a:rPr/>
+              <a:t>Permite mudar de direção rapidamente quando o mercado muda</a:t>
             </a:r>
           </a:p>
         </p:txBody>
@@ -5025,7 +5024,12 @@
             <p:ph type="title"/>
           </p:nvPr>
         </p:nvSpPr>
-        <p:spPr/>
+        <p:spPr>
+          <a:xfrm>
+            <a:off x="722313" y="4406900"/>
+            <a:ext cx="7772400" cy="1362075"/>
+          </a:xfrm>
+        </p:spPr>
         <p:txBody>
           <a:bodyPr/>
           <a:lstStyle/>
@@ -5035,51 +5039,7 @@
             </a:pPr>
             <a:r>
               <a:rPr/>
-              <a:t>Por que isso importa para o negócio</a:t>
-            </a:r>
-          </a:p>
-        </p:txBody>
-      </p:sp>
-      <p:sp>
-        <p:nvSpPr>
-          <p:cNvPr id="3" name="Content Placeholder 2"/>
-          <p:cNvSpPr>
-            <a:spLocks noGrp="1"/>
-          </p:cNvSpPr>
-          <p:nvPr>
-            <p:ph idx="1"/>
-          </p:nvPr>
-        </p:nvSpPr>
-        <p:spPr/>
-        <p:txBody>
-          <a:bodyPr/>
-          <a:lstStyle/>
-          <a:p>
-            <a:pPr lvl="0"/>
-            <a:r>
-              <a:rPr/>
-              <a:t>Reduz o risco de gastar tempo e dinheiro em algo que ninguém vai usar</a:t>
-            </a:r>
-          </a:p>
-          <a:p>
-            <a:pPr lvl="0"/>
-            <a:r>
-              <a:rPr/>
-              <a:t>Acelera o tempo entre a ideia e o valor entregue ao cliente</a:t>
-            </a:r>
-          </a:p>
-          <a:p>
-            <a:pPr lvl="0"/>
-            <a:r>
-              <a:rPr/>
-              <a:t>Dá visibilidade constante ao negócio sobre o andamento do trabalho</a:t>
-            </a:r>
-          </a:p>
-          <a:p>
-            <a:pPr lvl="0"/>
-            <a:r>
-              <a:rPr/>
-              <a:t>Permite mudar de direção rapidamente quando o mercado muda</a:t>
+              <a:t>Comprar ou construir a própria solução</a:t>
             </a:r>
           </a:p>
         </p:txBody>
@@ -5090,58 +5050,6 @@
 </file>
 
 <file path=ppt/slides/slide18.xml><?xml version="1.0" encoding="utf-8"?>
-<p:sld xmlns:a="http://schemas.openxmlformats.org/drawingml/2006/main" xmlns:r="http://schemas.openxmlformats.org/officeDocument/2006/relationships" xmlns:p="http://schemas.openxmlformats.org/presentationml/2006/main">
-  <p:cSld>
-    <p:spTree>
-      <p:nvGrpSpPr>
-        <p:cNvPr id="1" name=""/>
-        <p:cNvGrpSpPr/>
-        <p:nvPr/>
-      </p:nvGrpSpPr>
-      <p:grpSpPr>
-        <a:xfrm>
-          <a:off x="0" y="0"/>
-          <a:ext cx="0" cy="0"/>
-          <a:chOff x="0" y="0"/>
-          <a:chExt cx="0" cy="0"/>
-        </a:xfrm>
-      </p:grpSpPr>
-      <p:sp>
-        <p:nvSpPr>
-          <p:cNvPr id="2" name="Title 1"/>
-          <p:cNvSpPr>
-            <a:spLocks noGrp="1"/>
-          </p:cNvSpPr>
-          <p:nvPr>
-            <p:ph type="title"/>
-          </p:nvPr>
-        </p:nvSpPr>
-        <p:spPr>
-          <a:xfrm>
-            <a:off x="722313" y="4406900"/>
-            <a:ext cx="7772400" cy="1362075"/>
-          </a:xfrm>
-        </p:spPr>
-        <p:txBody>
-          <a:bodyPr/>
-          <a:lstStyle/>
-          <a:p>
-            <a:pPr lvl="0" indent="0" marL="0">
-              <a:buNone/>
-            </a:pPr>
-            <a:r>
-              <a:rPr/>
-              <a:t>Comprar ou construir a própria solução</a:t>
-            </a:r>
-          </a:p>
-        </p:txBody>
-      </p:sp>
-    </p:spTree>
-  </p:cSld>
-</p:sld>
-</file>
-
-<file path=ppt/slides/slide19.xml><?xml version="1.0" encoding="utf-8"?>
 <p:sld xmlns:a="http://schemas.openxmlformats.org/drawingml/2006/main" xmlns:r="http://schemas.openxmlformats.org/officeDocument/2006/relationships" xmlns:p="http://schemas.openxmlformats.org/presentationml/2006/main">
   <p:cSld>
     <p:spTree>
@@ -5218,6 +5126,97 @@
 </p:sld>
 </file>
 
+<file path=ppt/slides/slide19.xml><?xml version="1.0" encoding="utf-8"?>
+<p:sld xmlns:a="http://schemas.openxmlformats.org/drawingml/2006/main" xmlns:r="http://schemas.openxmlformats.org/officeDocument/2006/relationships" xmlns:p="http://schemas.openxmlformats.org/presentationml/2006/main">
+  <p:cSld>
+    <p:spTree>
+      <p:nvGrpSpPr>
+        <p:cNvPr id="1" name=""/>
+        <p:cNvGrpSpPr/>
+        <p:nvPr/>
+      </p:nvGrpSpPr>
+      <p:grpSpPr>
+        <a:xfrm>
+          <a:off x="0" y="0"/>
+          <a:ext cx="0" cy="0"/>
+          <a:chOff x="0" y="0"/>
+          <a:chExt cx="0" cy="0"/>
+        </a:xfrm>
+      </p:grpSpPr>
+      <p:sp>
+        <p:nvSpPr>
+          <p:cNvPr id="2" name="Title 1"/>
+          <p:cNvSpPr>
+            <a:spLocks noGrp="1"/>
+          </p:cNvSpPr>
+          <p:nvPr>
+            <p:ph type="title"/>
+          </p:nvPr>
+        </p:nvSpPr>
+        <p:spPr/>
+        <p:txBody>
+          <a:bodyPr/>
+          <a:lstStyle/>
+          <a:p>
+            <a:pPr lvl="0" indent="0" marL="0">
+              <a:buNone/>
+            </a:pPr>
+            <a:r>
+              <a:rPr/>
+              <a:t>Quando compensa comprar uma solução pronta</a:t>
+            </a:r>
+          </a:p>
+        </p:txBody>
+      </p:sp>
+      <p:sp>
+        <p:nvSpPr>
+          <p:cNvPr id="3" name="Content Placeholder 2"/>
+          <p:cNvSpPr>
+            <a:spLocks noGrp="1"/>
+          </p:cNvSpPr>
+          <p:nvPr>
+            <p:ph idx="1"/>
+          </p:nvPr>
+        </p:nvSpPr>
+        <p:spPr/>
+        <p:txBody>
+          <a:bodyPr/>
+          <a:lstStyle/>
+          <a:p>
+            <a:pPr lvl="0"/>
+            <a:r>
+              <a:rPr/>
+              <a:t>O problema já foi resolvido por outras empresas de forma madura e testada</a:t>
+            </a:r>
+          </a:p>
+          <a:p>
+            <a:pPr lvl="0"/>
+            <a:r>
+              <a:rPr/>
+              <a:t>A velocidade de implantação importa mais do que a personalização</a:t>
+            </a:r>
+          </a:p>
+          <a:p>
+            <a:pPr lvl="0"/>
+            <a:r>
+              <a:rPr/>
+              <a:t>O time interno pode focar energia no que realmente diferencia o negócio</a:t>
+            </a:r>
+          </a:p>
+          <a:p>
+            <a:pPr lvl="0"/>
+            <a:r>
+              <a:rPr/>
+              <a:t>O custo inicial é mais previsível e geralmente mais baixo</a:t>
+            </a:r>
+          </a:p>
+        </p:txBody>
+      </p:sp>
+    </p:spTree>
+  </p:cSld>
+</p:sld>
+</file>
+
 <file path=ppt/slides/slide2.xml><?xml version="1.0" encoding="utf-8"?>
 <p:sld xmlns:a="http://schemas.openxmlformats.org/drawingml/2006/main" xmlns:r="http://schemas.openxmlformats.org/officeDocument/2006/relationships" xmlns:p="http://schemas.openxmlformats.org/presentationml/2006/main">
   <p:cSld>
@@ -5367,7 +5366,7 @@
             </a:pPr>
             <a:r>
               <a:rPr/>
-              <a:t>Quando compensa comprar uma solução pronta</a:t>
+              <a:t>Quando compensa construir a própria solução</a:t>
             </a:r>
           </a:p>
         </p:txBody>
@@ -5390,28 +5389,28 @@
             <a:pPr lvl="0"/>
             <a:r>
               <a:rPr/>
-              <a:t>O problema já foi resolvido por outras empresas de forma madura e testada</a:t>
-            </a:r>
-          </a:p>
-          <a:p>
-            <a:pPr lvl="0"/>
-            <a:r>
-              <a:rPr/>
-              <a:t>A velocidade de implantação importa mais do que a personalização</a:t>
-            </a:r>
-          </a:p>
-          <a:p>
-            <a:pPr lvl="0"/>
-            <a:r>
-              <a:rPr/>
-              <a:t>O time interno pode focar energia no que realmente diferencia o negócio</a:t>
-            </a:r>
-          </a:p>
-          <a:p>
-            <a:pPr lvl="0"/>
-            <a:r>
-              <a:rPr/>
-              <a:t>O custo inicial é mais previsível e geralmente mais baixo</a:t>
+              <a:t>A necessidade é muito específica do negócio, e não existe solução pronta parecida</a:t>
+            </a:r>
+          </a:p>
+          <a:p>
+            <a:pPr lvl="0"/>
+            <a:r>
+              <a:rPr/>
+              <a:t>Essa capacidade é uma vantagem competitiva que vale a pena proteger</a:t>
+            </a:r>
+          </a:p>
+          <a:p>
+            <a:pPr lvl="0"/>
+            <a:r>
+              <a:rPr/>
+              <a:t>Há dependência de integração profunda com outros sistemas internos</a:t>
+            </a:r>
+          </a:p>
+          <a:p>
+            <a:pPr lvl="0"/>
+            <a:r>
+              <a:rPr/>
+              <a:t>No longo prazo, construir pode custar menos do que pagar por uso crescente</a:t>
             </a:r>
           </a:p>
         </p:txBody>
@@ -5458,7 +5457,7 @@
             </a:pPr>
             <a:r>
               <a:rPr/>
-              <a:t>Quando compensa construir a própria solução</a:t>
+              <a:t>O crescimento das assinaturas (SaaS)</a:t>
             </a:r>
           </a:p>
         </p:txBody>
@@ -5481,28 +5480,28 @@
             <a:pPr lvl="0"/>
             <a:r>
               <a:rPr/>
-              <a:t>A necessidade é muito específica do negócio, e não existe solução pronta parecida</a:t>
-            </a:r>
-          </a:p>
-          <a:p>
-            <a:pPr lvl="0"/>
-            <a:r>
-              <a:rPr/>
-              <a:t>Essa capacidade é uma vantagem competitiva que vale a pena proteger</a:t>
-            </a:r>
-          </a:p>
-          <a:p>
-            <a:pPr lvl="0"/>
-            <a:r>
-              <a:rPr/>
-              <a:t>Há dependência de integração profunda com outros sistemas internos</a:t>
-            </a:r>
-          </a:p>
-          <a:p>
-            <a:pPr lvl="0"/>
-            <a:r>
-              <a:rPr/>
-              <a:t>No longo prazo, construir pode custar menos do que pagar por uso crescente</a:t>
+              <a:t>Cada vez mais empresas oferecem software como um serviço por assinatura, em vez de vender uma licença única</a:t>
+            </a:r>
+          </a:p>
+          <a:p>
+            <a:pPr lvl="0"/>
+            <a:r>
+              <a:rPr/>
+              <a:t>O cliente paga um valor recorrente, geralmente mensal ou anual, para continuar usando</a:t>
+            </a:r>
+          </a:p>
+          <a:p>
+            <a:pPr lvl="0"/>
+            <a:r>
+              <a:rPr/>
+              <a:t>Isso reduz o investimento inicial de quem compra, e cria uma receita previsível para quem vende</a:t>
+            </a:r>
+          </a:p>
+          <a:p>
+            <a:pPr lvl="0"/>
+            <a:r>
+              <a:rPr/>
+              <a:t>O sucesso desse modelo depende de uma coisa acima de tudo: o cliente continuar renovando</a:t>
             </a:r>
           </a:p>
         </p:txBody>
@@ -5513,97 +5512,6 @@
 </file>
 
 <file path=ppt/slides/slide22.xml><?xml version="1.0" encoding="utf-8"?>
-<p:sld xmlns:a="http://schemas.openxmlformats.org/drawingml/2006/main" xmlns:r="http://schemas.openxmlformats.org/officeDocument/2006/relationships" xmlns:p="http://schemas.openxmlformats.org/presentationml/2006/main">
-  <p:cSld>
-    <p:spTree>
-      <p:nvGrpSpPr>
-        <p:cNvPr id="1" name=""/>
-        <p:cNvGrpSpPr/>
-        <p:nvPr/>
-      </p:nvGrpSpPr>
-      <p:grpSpPr>
-        <a:xfrm>
-          <a:off x="0" y="0"/>
-          <a:ext cx="0" cy="0"/>
-          <a:chOff x="0" y="0"/>
-          <a:chExt cx="0" cy="0"/>
-        </a:xfrm>
-      </p:grpSpPr>
-      <p:sp>
-        <p:nvSpPr>
-          <p:cNvPr id="2" name="Title 1"/>
-          <p:cNvSpPr>
-            <a:spLocks noGrp="1"/>
-          </p:cNvSpPr>
-          <p:nvPr>
-            <p:ph type="title"/>
-          </p:nvPr>
-        </p:nvSpPr>
-        <p:spPr/>
-        <p:txBody>
-          <a:bodyPr/>
-          <a:lstStyle/>
-          <a:p>
-            <a:pPr lvl="0" indent="0" marL="0">
-              <a:buNone/>
-            </a:pPr>
-            <a:r>
-              <a:rPr/>
-              <a:t>O crescimento das assinaturas (SaaS)</a:t>
-            </a:r>
-          </a:p>
-        </p:txBody>
-      </p:sp>
-      <p:sp>
-        <p:nvSpPr>
-          <p:cNvPr id="3" name="Content Placeholder 2"/>
-          <p:cNvSpPr>
-            <a:spLocks noGrp="1"/>
-          </p:cNvSpPr>
-          <p:nvPr>
-            <p:ph idx="1"/>
-          </p:nvPr>
-        </p:nvSpPr>
-        <p:spPr/>
-        <p:txBody>
-          <a:bodyPr/>
-          <a:lstStyle/>
-          <a:p>
-            <a:pPr lvl="0"/>
-            <a:r>
-              <a:rPr/>
-              <a:t>Cada vez mais empresas oferecem software como um serviço por assinatura, em vez de vender uma licença única</a:t>
-            </a:r>
-          </a:p>
-          <a:p>
-            <a:pPr lvl="0"/>
-            <a:r>
-              <a:rPr/>
-              <a:t>O cliente paga um valor recorrente, geralmente mensal ou anual, para continuar usando</a:t>
-            </a:r>
-          </a:p>
-          <a:p>
-            <a:pPr lvl="0"/>
-            <a:r>
-              <a:rPr/>
-              <a:t>Isso reduz o investimento inicial de quem compra, e cria uma receita previsível para quem vende</a:t>
-            </a:r>
-          </a:p>
-          <a:p>
-            <a:pPr lvl="0"/>
-            <a:r>
-              <a:rPr/>
-              <a:t>O sucesso desse modelo depende de uma coisa acima de tudo: o cliente continuar renovando</a:t>
-            </a:r>
-          </a:p>
-        </p:txBody>
-      </p:sp>
-    </p:spTree>
-  </p:cSld>
-</p:sld>
-</file>
-
-<file path=ppt/slides/slide23.xml><?xml version="1.0" encoding="utf-8"?>
 <p:sld xmlns:a="http://schemas.openxmlformats.org/drawingml/2006/main" xmlns:r="http://schemas.openxmlformats.org/officeDocument/2006/relationships" xmlns:p="http://schemas.openxmlformats.org/presentationml/2006/main">
   <p:cSld>
     <p:spTree>
@@ -5680,7 +5588,7 @@
 </p:sld>
 </file>
 
-<file path=ppt/slides/slide24.xml><?xml version="1.0" encoding="utf-8"?>
+<file path=ppt/slides/slide23.xml><?xml version="1.0" encoding="utf-8"?>
 <p:sld xmlns:a="http://schemas.openxmlformats.org/drawingml/2006/main" xmlns:r="http://schemas.openxmlformats.org/officeDocument/2006/relationships" xmlns:p="http://schemas.openxmlformats.org/presentationml/2006/main">
   <p:cSld>
     <p:spTree>
@@ -5757,6 +5665,97 @@
 </p:sld>
 </file>
 
+<file path=ppt/slides/slide24.xml><?xml version="1.0" encoding="utf-8"?>
+<p:sld xmlns:a="http://schemas.openxmlformats.org/drawingml/2006/main" xmlns:r="http://schemas.openxmlformats.org/officeDocument/2006/relationships" xmlns:p="http://schemas.openxmlformats.org/presentationml/2006/main">
+  <p:cSld>
+    <p:spTree>
+      <p:nvGrpSpPr>
+        <p:cNvPr id="1" name=""/>
+        <p:cNvGrpSpPr/>
+        <p:nvPr/>
+      </p:nvGrpSpPr>
+      <p:grpSpPr>
+        <a:xfrm>
+          <a:off x="0" y="0"/>
+          <a:ext cx="0" cy="0"/>
+          <a:chOff x="0" y="0"/>
+          <a:chExt cx="0" cy="0"/>
+        </a:xfrm>
+      </p:grpSpPr>
+      <p:sp>
+        <p:nvSpPr>
+          <p:cNvPr id="2" name="Title 1"/>
+          <p:cNvSpPr>
+            <a:spLocks noGrp="1"/>
+          </p:cNvSpPr>
+          <p:nvPr>
+            <p:ph type="title"/>
+          </p:nvPr>
+        </p:nvSpPr>
+        <p:spPr/>
+        <p:txBody>
+          <a:bodyPr/>
+          <a:lstStyle/>
+          <a:p>
+            <a:pPr lvl="0" indent="0" marL="0">
+              <a:buNone/>
+            </a:pPr>
+            <a:r>
+              <a:rPr/>
+              <a:t>O que isso significa para quem decide</a:t>
+            </a:r>
+          </a:p>
+        </p:txBody>
+      </p:sp>
+      <p:sp>
+        <p:nvSpPr>
+          <p:cNvPr id="3" name="Content Placeholder 2"/>
+          <p:cNvSpPr>
+            <a:spLocks noGrp="1"/>
+          </p:cNvSpPr>
+          <p:nvPr>
+            <p:ph idx="1"/>
+          </p:nvPr>
+        </p:nvSpPr>
+        <p:spPr/>
+        <p:txBody>
+          <a:bodyPr/>
+          <a:lstStyle/>
+          <a:p>
+            <a:pPr lvl="0"/>
+            <a:r>
+              <a:rPr/>
+              <a:t>Comprar ou construir depende do quanto aquela solução diferencia o negócio, não só do preço</a:t>
+            </a:r>
+          </a:p>
+          <a:p>
+            <a:pPr lvl="0"/>
+            <a:r>
+              <a:rPr/>
+              <a:t>Um contrato de assinatura troca um gasto grande e único por um compromisso contínuo</a:t>
+            </a:r>
+          </a:p>
+          <a:p>
+            <a:pPr lvl="0"/>
+            <a:r>
+              <a:rPr/>
+              <a:t>A saúde financeira de um negócio de assinatura se mede pela renovação, não só pela venda inicial</a:t>
+            </a:r>
+          </a:p>
+          <a:p>
+            <a:pPr lvl="0"/>
+            <a:r>
+              <a:rPr/>
+              <a:t>Cancelamentos custam caro: cada cliente perdido reduz a receita futura já esperada</a:t>
+            </a:r>
+          </a:p>
+        </p:txBody>
+      </p:sp>
+    </p:spTree>
+  </p:cSld>
+</p:sld>
+</file>
+
 <file path=ppt/slides/slide25.xml><?xml version="1.0" encoding="utf-8"?>
 <p:sld xmlns:a="http://schemas.openxmlformats.org/drawingml/2006/main" xmlns:r="http://schemas.openxmlformats.org/officeDocument/2006/relationships" xmlns:p="http://schemas.openxmlformats.org/presentationml/2006/main">
   <p:cSld>
@@ -5784,7 +5783,12 @@
             <p:ph type="title"/>
           </p:nvPr>
         </p:nvSpPr>
-        <p:spPr/>
+        <p:spPr>
+          <a:xfrm>
+            <a:off x="722313" y="4406900"/>
+            <a:ext cx="7772400" cy="1362075"/>
+          </a:xfrm>
+        </p:spPr>
         <p:txBody>
           <a:bodyPr/>
           <a:lstStyle/>
@@ -5794,51 +5798,7 @@
             </a:pPr>
             <a:r>
               <a:rPr/>
-              <a:t>O que isso significa para quem decide</a:t>
-            </a:r>
-          </a:p>
-        </p:txBody>
-      </p:sp>
-      <p:sp>
-        <p:nvSpPr>
-          <p:cNvPr id="3" name="Content Placeholder 2"/>
-          <p:cNvSpPr>
-            <a:spLocks noGrp="1"/>
-          </p:cNvSpPr>
-          <p:nvPr>
-            <p:ph idx="1"/>
-          </p:nvPr>
-        </p:nvSpPr>
-        <p:spPr/>
-        <p:txBody>
-          <a:bodyPr/>
-          <a:lstStyle/>
-          <a:p>
-            <a:pPr lvl="0"/>
-            <a:r>
-              <a:rPr/>
-              <a:t>Comprar ou construir depende do quanto aquela solução diferencia o negócio, não só do preço</a:t>
-            </a:r>
-          </a:p>
-          <a:p>
-            <a:pPr lvl="0"/>
-            <a:r>
-              <a:rPr/>
-              <a:t>Um contrato de assinatura troca um gasto grande e único por um compromisso contínuo</a:t>
-            </a:r>
-          </a:p>
-          <a:p>
-            <a:pPr lvl="0"/>
-            <a:r>
-              <a:rPr/>
-              <a:t>A saúde financeira de um negócio de assinatura se mede pela renovação, não só pela venda inicial</a:t>
-            </a:r>
-          </a:p>
-          <a:p>
-            <a:pPr lvl="0"/>
-            <a:r>
-              <a:rPr/>
-              <a:t>Cancelamentos custam caro: cada cliente perdido reduz a receita futura já esperada</a:t>
+              <a:t>Como medir o sucesso de um produto</a:t>
             </a:r>
           </a:p>
         </p:txBody>
@@ -5875,12 +5835,7 @@
             <p:ph type="title"/>
           </p:nvPr>
         </p:nvSpPr>
-        <p:spPr>
-          <a:xfrm>
-            <a:off x="722313" y="4406900"/>
-            <a:ext cx="7772400" cy="1362075"/>
-          </a:xfrm>
-        </p:spPr>
+        <p:spPr/>
         <p:txBody>
           <a:bodyPr/>
           <a:lstStyle/>
@@ -5890,7 +5845,51 @@
             </a:pPr>
             <a:r>
               <a:rPr/>
-              <a:t>Como medir o sucesso de um produto</a:t>
+              <a:t>Por que medir importa</a:t>
+            </a:r>
+          </a:p>
+        </p:txBody>
+      </p:sp>
+      <p:sp>
+        <p:nvSpPr>
+          <p:cNvPr id="3" name="Content Placeholder 2"/>
+          <p:cNvSpPr>
+            <a:spLocks noGrp="1"/>
+          </p:cNvSpPr>
+          <p:nvPr>
+            <p:ph idx="1"/>
+          </p:nvPr>
+        </p:nvSpPr>
+        <p:spPr/>
+        <p:txBody>
+          <a:bodyPr/>
+          <a:lstStyle/>
+          <a:p>
+            <a:pPr lvl="0"/>
+            <a:r>
+              <a:rPr/>
+              <a:t>Lançar um produto ou uma funcionalidade não é o fim da história, é o começo de uma nova etapa</a:t>
+            </a:r>
+          </a:p>
+          <a:p>
+            <a:pPr lvl="0"/>
+            <a:r>
+              <a:rPr/>
+              <a:t>Sem números, decisões viram opinião: “eu acho que está indo bem” não é o mesmo que saber</a:t>
+            </a:r>
+          </a:p>
+          <a:p>
+            <a:pPr lvl="0"/>
+            <a:r>
+              <a:rPr/>
+              <a:t>Métricas bem escolhidas mostram se o problema do cliente foi realmente resolvido</a:t>
+            </a:r>
+          </a:p>
+          <a:p>
+            <a:pPr lvl="0"/>
+            <a:r>
+              <a:rPr/>
+              <a:t>É esse acompanhamento que fecha o ciclo de aprendizado visto no início desta conversa</a:t>
             </a:r>
           </a:p>
         </p:txBody>
@@ -5901,97 +5900,6 @@
 </file>
 
 <file path=ppt/slides/slide27.xml><?xml version="1.0" encoding="utf-8"?>
-<p:sld xmlns:a="http://schemas.openxmlformats.org/drawingml/2006/main" xmlns:r="http://schemas.openxmlformats.org/officeDocument/2006/relationships" xmlns:p="http://schemas.openxmlformats.org/presentationml/2006/main">
-  <p:cSld>
-    <p:spTree>
-      <p:nvGrpSpPr>
-        <p:cNvPr id="1" name=""/>
-        <p:cNvGrpSpPr/>
-        <p:nvPr/>
-      </p:nvGrpSpPr>
-      <p:grpSpPr>
-        <a:xfrm>
-          <a:off x="0" y="0"/>
-          <a:ext cx="0" cy="0"/>
-          <a:chOff x="0" y="0"/>
-          <a:chExt cx="0" cy="0"/>
-        </a:xfrm>
-      </p:grpSpPr>
-      <p:sp>
-        <p:nvSpPr>
-          <p:cNvPr id="2" name="Title 1"/>
-          <p:cNvSpPr>
-            <a:spLocks noGrp="1"/>
-          </p:cNvSpPr>
-          <p:nvPr>
-            <p:ph type="title"/>
-          </p:nvPr>
-        </p:nvSpPr>
-        <p:spPr/>
-        <p:txBody>
-          <a:bodyPr/>
-          <a:lstStyle/>
-          <a:p>
-            <a:pPr lvl="0" indent="0" marL="0">
-              <a:buNone/>
-            </a:pPr>
-            <a:r>
-              <a:rPr/>
-              <a:t>Por que medir importa</a:t>
-            </a:r>
-          </a:p>
-        </p:txBody>
-      </p:sp>
-      <p:sp>
-        <p:nvSpPr>
-          <p:cNvPr id="3" name="Content Placeholder 2"/>
-          <p:cNvSpPr>
-            <a:spLocks noGrp="1"/>
-          </p:cNvSpPr>
-          <p:nvPr>
-            <p:ph idx="1"/>
-          </p:nvPr>
-        </p:nvSpPr>
-        <p:spPr/>
-        <p:txBody>
-          <a:bodyPr/>
-          <a:lstStyle/>
-          <a:p>
-            <a:pPr lvl="0"/>
-            <a:r>
-              <a:rPr/>
-              <a:t>Lançar um produto ou uma funcionalidade não é o fim da história, é o começo de uma nova etapa</a:t>
-            </a:r>
-          </a:p>
-          <a:p>
-            <a:pPr lvl="0"/>
-            <a:r>
-              <a:rPr/>
-              <a:t>Sem números, decisões viram opinião: “eu acho que está indo bem” não é o mesmo que saber</a:t>
-            </a:r>
-          </a:p>
-          <a:p>
-            <a:pPr lvl="0"/>
-            <a:r>
-              <a:rPr/>
-              <a:t>Métricas bem escolhidas mostram se o problema do cliente foi realmente resolvido</a:t>
-            </a:r>
-          </a:p>
-          <a:p>
-            <a:pPr lvl="0"/>
-            <a:r>
-              <a:rPr/>
-              <a:t>É esse acompanhamento que fecha o ciclo de aprendizado visto no início desta conversa</a:t>
-            </a:r>
-          </a:p>
-        </p:txBody>
-      </p:sp>
-    </p:spTree>
-  </p:cSld>
-</p:sld>
-</file>
-
-<file path=ppt/slides/slide28.xml><?xml version="1.0" encoding="utf-8"?>
 <p:sld xmlns:a="http://schemas.openxmlformats.org/drawingml/2006/main" xmlns:r="http://schemas.openxmlformats.org/officeDocument/2006/relationships" xmlns:p="http://schemas.openxmlformats.org/presentationml/2006/main">
   <p:cSld>
     <p:spTree>
@@ -6068,6 +5976,97 @@
 </p:sld>
 </file>
 
+<file path=ppt/slides/slide28.xml><?xml version="1.0" encoding="utf-8"?>
+<p:sld xmlns:a="http://schemas.openxmlformats.org/drawingml/2006/main" xmlns:r="http://schemas.openxmlformats.org/officeDocument/2006/relationships" xmlns:p="http://schemas.openxmlformats.org/presentationml/2006/main">
+  <p:cSld>
+    <p:spTree>
+      <p:nvGrpSpPr>
+        <p:cNvPr id="1" name=""/>
+        <p:cNvGrpSpPr/>
+        <p:nvPr/>
+      </p:nvGrpSpPr>
+      <p:grpSpPr>
+        <a:xfrm>
+          <a:off x="0" y="0"/>
+          <a:ext cx="0" cy="0"/>
+          <a:chOff x="0" y="0"/>
+          <a:chExt cx="0" cy="0"/>
+        </a:xfrm>
+      </p:grpSpPr>
+      <p:sp>
+        <p:nvSpPr>
+          <p:cNvPr id="2" name="Title 1"/>
+          <p:cNvSpPr>
+            <a:spLocks noGrp="1"/>
+          </p:cNvSpPr>
+          <p:nvPr>
+            <p:ph type="title"/>
+          </p:nvPr>
+        </p:nvSpPr>
+        <p:spPr/>
+        <p:txBody>
+          <a:bodyPr/>
+          <a:lstStyle/>
+          <a:p>
+            <a:pPr lvl="0" indent="0" marL="0">
+              <a:buNone/>
+            </a:pPr>
+            <a:r>
+              <a:rPr/>
+              <a:t>Licenças ativas: quantidade não é tudo</a:t>
+            </a:r>
+          </a:p>
+        </p:txBody>
+      </p:sp>
+      <p:sp>
+        <p:nvSpPr>
+          <p:cNvPr id="3" name="Content Placeholder 2"/>
+          <p:cNvSpPr>
+            <a:spLocks noGrp="1"/>
+          </p:cNvSpPr>
+          <p:nvPr>
+            <p:ph idx="1"/>
+          </p:nvPr>
+        </p:nvSpPr>
+        <p:spPr/>
+        <p:txBody>
+          <a:bodyPr/>
+          <a:lstStyle/>
+          <a:p>
+            <a:pPr lvl="0"/>
+            <a:r>
+              <a:rPr/>
+              <a:t>Contar licenças ou usuários ativos é o primeiro passo, mas não o único</a:t>
+            </a:r>
+          </a:p>
+          <a:p>
+            <a:pPr lvl="0"/>
+            <a:r>
+              <a:rPr/>
+              <a:t>Uma licença comprada e nunca usada é um sinal de alerta, não de sucesso</a:t>
+            </a:r>
+          </a:p>
+          <a:p>
+            <a:pPr lvl="0"/>
+            <a:r>
+              <a:rPr/>
+              <a:t>O que importa é a proporção de usuários que voltam a usar o produto com frequência</a:t>
+            </a:r>
+          </a:p>
+          <a:p>
+            <a:pPr lvl="0"/>
+            <a:r>
+              <a:rPr/>
+              <a:t>Esse número ajuda a antecipar cancelamentos antes que eles aconteçam</a:t>
+            </a:r>
+          </a:p>
+        </p:txBody>
+      </p:sp>
+    </p:spTree>
+  </p:cSld>
+</p:sld>
+</file>
+
 <file path=ppt/slides/slide29.xml><?xml version="1.0" encoding="utf-8"?>
 <p:sld xmlns:a="http://schemas.openxmlformats.org/drawingml/2006/main" xmlns:r="http://schemas.openxmlformats.org/officeDocument/2006/relationships" xmlns:p="http://schemas.openxmlformats.org/presentationml/2006/main">
   <p:cSld>
@@ -6105,7 +6104,7 @@
             </a:pPr>
             <a:r>
               <a:rPr/>
-              <a:t>Licenças ativas: quantidade não é tudo</a:t>
+              <a:t>A porcentagem de renovação: o termômetro do negócio</a:t>
             </a:r>
           </a:p>
         </p:txBody>
@@ -6128,28 +6127,28 @@
             <a:pPr lvl="0"/>
             <a:r>
               <a:rPr/>
-              <a:t>Contar licenças ou usuários ativos é o primeiro passo, mas não o único</a:t>
-            </a:r>
-          </a:p>
-          <a:p>
-            <a:pPr lvl="0"/>
-            <a:r>
-              <a:rPr/>
-              <a:t>Uma licença comprada e nunca usada é um sinal de alerta, não de sucesso</a:t>
-            </a:r>
-          </a:p>
-          <a:p>
-            <a:pPr lvl="0"/>
-            <a:r>
-              <a:rPr/>
-              <a:t>O que importa é a proporção de usuários que voltam a usar o produto com frequência</a:t>
-            </a:r>
-          </a:p>
-          <a:p>
-            <a:pPr lvl="0"/>
-            <a:r>
-              <a:rPr/>
-              <a:t>Esse número ajuda a antecipar cancelamentos antes que eles aconteçam</a:t>
+              <a:t>Mede quantos clientes decidem continuar, quando chega a hora de renovar</a:t>
+            </a:r>
+          </a:p>
+          <a:p>
+            <a:pPr lvl="0"/>
+            <a:r>
+              <a:rPr/>
+              <a:t>Uma renovação alta confirma que o produto entrega valor de forma consistente</a:t>
+            </a:r>
+          </a:p>
+          <a:p>
+            <a:pPr lvl="0"/>
+            <a:r>
+              <a:rPr/>
+              <a:t>Uma renovação baixa é um alerta antecipado, mesmo que a venda inicial tenha sido um sucesso</a:t>
+            </a:r>
+          </a:p>
+          <a:p>
+            <a:pPr lvl="0"/>
+            <a:r>
+              <a:rPr/>
+              <a:t>É a métrica mais próxima de uma resposta direta à pergunta: “o cliente pagaria por isso de novo?”</a:t>
             </a:r>
           </a:p>
         </p:txBody>
@@ -6212,97 +6211,6 @@
 </file>
 
 <file path=ppt/slides/slide30.xml><?xml version="1.0" encoding="utf-8"?>
-<p:sld xmlns:a="http://schemas.openxmlformats.org/drawingml/2006/main" xmlns:r="http://schemas.openxmlformats.org/officeDocument/2006/relationships" xmlns:p="http://schemas.openxmlformats.org/presentationml/2006/main">
-  <p:cSld>
-    <p:spTree>
-      <p:nvGrpSpPr>
-        <p:cNvPr id="1" name=""/>
-        <p:cNvGrpSpPr/>
-        <p:nvPr/>
-      </p:nvGrpSpPr>
-      <p:grpSpPr>
-        <a:xfrm>
-          <a:off x="0" y="0"/>
-          <a:ext cx="0" cy="0"/>
-          <a:chOff x="0" y="0"/>
-          <a:chExt cx="0" cy="0"/>
-        </a:xfrm>
-      </p:grpSpPr>
-      <p:sp>
-        <p:nvSpPr>
-          <p:cNvPr id="2" name="Title 1"/>
-          <p:cNvSpPr>
-            <a:spLocks noGrp="1"/>
-          </p:cNvSpPr>
-          <p:nvPr>
-            <p:ph type="title"/>
-          </p:nvPr>
-        </p:nvSpPr>
-        <p:spPr/>
-        <p:txBody>
-          <a:bodyPr/>
-          <a:lstStyle/>
-          <a:p>
-            <a:pPr lvl="0" indent="0" marL="0">
-              <a:buNone/>
-            </a:pPr>
-            <a:r>
-              <a:rPr/>
-              <a:t>A porcentagem de renovação: o termômetro do negócio</a:t>
-            </a:r>
-          </a:p>
-        </p:txBody>
-      </p:sp>
-      <p:sp>
-        <p:nvSpPr>
-          <p:cNvPr id="3" name="Content Placeholder 2"/>
-          <p:cNvSpPr>
-            <a:spLocks noGrp="1"/>
-          </p:cNvSpPr>
-          <p:nvPr>
-            <p:ph idx="1"/>
-          </p:nvPr>
-        </p:nvSpPr>
-        <p:spPr/>
-        <p:txBody>
-          <a:bodyPr/>
-          <a:lstStyle/>
-          <a:p>
-            <a:pPr lvl="0"/>
-            <a:r>
-              <a:rPr/>
-              <a:t>Mede quantos clientes decidem continuar, quando chega a hora de renovar</a:t>
-            </a:r>
-          </a:p>
-          <a:p>
-            <a:pPr lvl="0"/>
-            <a:r>
-              <a:rPr/>
-              <a:t>Uma renovação alta confirma que o produto entrega valor de forma consistente</a:t>
-            </a:r>
-          </a:p>
-          <a:p>
-            <a:pPr lvl="0"/>
-            <a:r>
-              <a:rPr/>
-              <a:t>Uma renovação baixa é um alerta antecipado, mesmo que a venda inicial tenha sido um sucesso</a:t>
-            </a:r>
-          </a:p>
-          <a:p>
-            <a:pPr lvl="0"/>
-            <a:r>
-              <a:rPr/>
-              <a:t>É a métrica mais próxima de uma resposta direta à pergunta: “o cliente pagaria por isso de novo?”</a:t>
-            </a:r>
-          </a:p>
-        </p:txBody>
-      </p:sp>
-    </p:spTree>
-  </p:cSld>
-</p:sld>
-</file>
-
-<file path=ppt/slides/slide31.xml><?xml version="1.0" encoding="utf-8"?>
 <p:sld xmlns:a="http://schemas.openxmlformats.org/drawingml/2006/main" xmlns:r="http://schemas.openxmlformats.org/officeDocument/2006/relationships" xmlns:p="http://schemas.openxmlformats.org/presentationml/2006/main">
   <p:cSld>
     <p:spTree>
@@ -6379,6 +6287,97 @@
 </p:sld>
 </file>
 
+<file path=ppt/slides/slide31.xml><?xml version="1.0" encoding="utf-8"?>
+<p:sld xmlns:a="http://schemas.openxmlformats.org/drawingml/2006/main" xmlns:r="http://schemas.openxmlformats.org/officeDocument/2006/relationships" xmlns:p="http://schemas.openxmlformats.org/presentationml/2006/main">
+  <p:cSld>
+    <p:spTree>
+      <p:nvGrpSpPr>
+        <p:cNvPr id="1" name=""/>
+        <p:cNvGrpSpPr/>
+        <p:nvPr/>
+      </p:nvGrpSpPr>
+      <p:grpSpPr>
+        <a:xfrm>
+          <a:off x="0" y="0"/>
+          <a:ext cx="0" cy="0"/>
+          <a:chOff x="0" y="0"/>
+          <a:chExt cx="0" cy="0"/>
+        </a:xfrm>
+      </p:grpSpPr>
+      <p:sp>
+        <p:nvSpPr>
+          <p:cNvPr id="2" name="Title 1"/>
+          <p:cNvSpPr>
+            <a:spLocks noGrp="1"/>
+          </p:cNvSpPr>
+          <p:nvPr>
+            <p:ph type="title"/>
+          </p:nvPr>
+        </p:nvSpPr>
+        <p:spPr/>
+        <p:txBody>
+          <a:bodyPr/>
+          <a:lstStyle/>
+          <a:p>
+            <a:pPr lvl="0" indent="0" marL="0">
+              <a:buNone/>
+            </a:pPr>
+            <a:r>
+              <a:rPr/>
+              <a:t>Transformando números em decisão</a:t>
+            </a:r>
+          </a:p>
+        </p:txBody>
+      </p:sp>
+      <p:sp>
+        <p:nvSpPr>
+          <p:cNvPr id="3" name="Content Placeholder 2"/>
+          <p:cNvSpPr>
+            <a:spLocks noGrp="1"/>
+          </p:cNvSpPr>
+          <p:nvPr>
+            <p:ph idx="1"/>
+          </p:nvPr>
+        </p:nvSpPr>
+        <p:spPr/>
+        <p:txBody>
+          <a:bodyPr/>
+          <a:lstStyle/>
+          <a:p>
+            <a:pPr lvl="0"/>
+            <a:r>
+              <a:rPr/>
+              <a:t>Escolher poucas métricas, bem definidas, vale mais do que acompanhar dezenas de números soltos</a:t>
+            </a:r>
+          </a:p>
+          <a:p>
+            <a:pPr lvl="0"/>
+            <a:r>
+              <a:rPr/>
+              <a:t>Cada métrica deve ter um responsável e um motivo claro para existir</a:t>
+            </a:r>
+          </a:p>
+          <a:p>
+            <a:pPr lvl="0"/>
+            <a:r>
+              <a:rPr/>
+              <a:t>Uma métrica só é útil se ela muda alguma decisão quando o número se move</a:t>
+            </a:r>
+          </a:p>
+          <a:p>
+            <a:pPr lvl="0"/>
+            <a:r>
+              <a:rPr/>
+              <a:t>Revisar essas métricas com frequência é parte do trabalho, não uma tarefa extra</a:t>
+            </a:r>
+          </a:p>
+        </p:txBody>
+      </p:sp>
+    </p:spTree>
+  </p:cSld>
+</p:sld>
+</file>
+
 <file path=ppt/slides/slide32.xml><?xml version="1.0" encoding="utf-8"?>
 <p:sld xmlns:a="http://schemas.openxmlformats.org/drawingml/2006/main" xmlns:r="http://schemas.openxmlformats.org/officeDocument/2006/relationships" xmlns:p="http://schemas.openxmlformats.org/presentationml/2006/main">
   <p:cSld>
@@ -6406,7 +6405,12 @@
             <p:ph type="title"/>
           </p:nvPr>
         </p:nvSpPr>
-        <p:spPr/>
+        <p:spPr>
+          <a:xfrm>
+            <a:off x="722313" y="4406900"/>
+            <a:ext cx="7772400" cy="1362075"/>
+          </a:xfrm>
+        </p:spPr>
         <p:txBody>
           <a:bodyPr/>
           <a:lstStyle/>
@@ -6416,51 +6420,7 @@
             </a:pPr>
             <a:r>
               <a:rPr/>
-              <a:t>Transformando números em decisão</a:t>
-            </a:r>
-          </a:p>
-        </p:txBody>
-      </p:sp>
-      <p:sp>
-        <p:nvSpPr>
-          <p:cNvPr id="3" name="Content Placeholder 2"/>
-          <p:cNvSpPr>
-            <a:spLocks noGrp="1"/>
-          </p:cNvSpPr>
-          <p:nvPr>
-            <p:ph idx="1"/>
-          </p:nvPr>
-        </p:nvSpPr>
-        <p:spPr/>
-        <p:txBody>
-          <a:bodyPr/>
-          <a:lstStyle/>
-          <a:p>
-            <a:pPr lvl="0"/>
-            <a:r>
-              <a:rPr/>
-              <a:t>Escolher poucas métricas, bem definidas, vale mais do que acompanhar dezenas de números soltos</a:t>
-            </a:r>
-          </a:p>
-          <a:p>
-            <a:pPr lvl="0"/>
-            <a:r>
-              <a:rPr/>
-              <a:t>Cada métrica deve ter um responsável e um motivo claro para existir</a:t>
-            </a:r>
-          </a:p>
-          <a:p>
-            <a:pPr lvl="0"/>
-            <a:r>
-              <a:rPr/>
-              <a:t>Uma métrica só é útil se ela muda alguma decisão quando o número se move</a:t>
-            </a:r>
-          </a:p>
-          <a:p>
-            <a:pPr lvl="0"/>
-            <a:r>
-              <a:rPr/>
-              <a:t>Revisar essas métricas com frequência é parte do trabalho, não uma tarefa extra</a:t>
+              <a:t>Inteligência artificial no software</a:t>
             </a:r>
           </a:p>
         </p:txBody>
@@ -6497,12 +6457,7 @@
             <p:ph type="title"/>
           </p:nvPr>
         </p:nvSpPr>
-        <p:spPr>
-          <a:xfrm>
-            <a:off x="722313" y="4406900"/>
-            <a:ext cx="7772400" cy="1362075"/>
-          </a:xfrm>
-        </p:spPr>
+        <p:spPr/>
         <p:txBody>
           <a:bodyPr/>
           <a:lstStyle/>
@@ -6512,7 +6467,51 @@
             </a:pPr>
             <a:r>
               <a:rPr/>
-              <a:t>Inteligência artificial no software</a:t>
+              <a:t>IA como uma nova camada dos produtos digitais</a:t>
+            </a:r>
+          </a:p>
+        </p:txBody>
+      </p:sp>
+      <p:sp>
+        <p:nvSpPr>
+          <p:cNvPr id="3" name="Content Placeholder 2"/>
+          <p:cNvSpPr>
+            <a:spLocks noGrp="1"/>
+          </p:cNvSpPr>
+          <p:nvPr>
+            <p:ph idx="1"/>
+          </p:nvPr>
+        </p:nvSpPr>
+        <p:spPr/>
+        <p:txBody>
+          <a:bodyPr/>
+          <a:lstStyle/>
+          <a:p>
+            <a:pPr lvl="0"/>
+            <a:r>
+              <a:rPr/>
+              <a:t>Até pouco tempo atrás, sistemas seguiam apenas regras fixas, escritas por pessoas</a:t>
+            </a:r>
+          </a:p>
+          <a:p>
+            <a:pPr lvl="0"/>
+            <a:r>
+              <a:rPr/>
+              <a:t>Hoje, a inteligência artificial permite que sistemas entendam linguagem natural e respondam de forma mais flexível</a:t>
+            </a:r>
+          </a:p>
+          <a:p>
+            <a:pPr lvl="0"/>
+            <a:r>
+              <a:rPr/>
+              <a:t>Isso abre espaço para assistentes que conversam com o cliente, resumem informações e ajudam pessoas a decidir mais rápido</a:t>
+            </a:r>
+          </a:p>
+          <a:p>
+            <a:pPr lvl="0"/>
+            <a:r>
+              <a:rPr/>
+              <a:t>O desafio deixou de ser “o sistema entende o pedido?” e passou a ser “a resposta é confiável?”</a:t>
             </a:r>
           </a:p>
         </p:txBody>
@@ -6523,97 +6522,6 @@
 </file>
 
 <file path=ppt/slides/slide34.xml><?xml version="1.0" encoding="utf-8"?>
-<p:sld xmlns:a="http://schemas.openxmlformats.org/drawingml/2006/main" xmlns:r="http://schemas.openxmlformats.org/officeDocument/2006/relationships" xmlns:p="http://schemas.openxmlformats.org/presentationml/2006/main">
-  <p:cSld>
-    <p:spTree>
-      <p:nvGrpSpPr>
-        <p:cNvPr id="1" name=""/>
-        <p:cNvGrpSpPr/>
-        <p:nvPr/>
-      </p:nvGrpSpPr>
-      <p:grpSpPr>
-        <a:xfrm>
-          <a:off x="0" y="0"/>
-          <a:ext cx="0" cy="0"/>
-          <a:chOff x="0" y="0"/>
-          <a:chExt cx="0" cy="0"/>
-        </a:xfrm>
-      </p:grpSpPr>
-      <p:sp>
-        <p:nvSpPr>
-          <p:cNvPr id="2" name="Title 1"/>
-          <p:cNvSpPr>
-            <a:spLocks noGrp="1"/>
-          </p:cNvSpPr>
-          <p:nvPr>
-            <p:ph type="title"/>
-          </p:nvPr>
-        </p:nvSpPr>
-        <p:spPr/>
-        <p:txBody>
-          <a:bodyPr/>
-          <a:lstStyle/>
-          <a:p>
-            <a:pPr lvl="0" indent="0" marL="0">
-              <a:buNone/>
-            </a:pPr>
-            <a:r>
-              <a:rPr/>
-              <a:t>IA como uma nova camada dos produtos digitais</a:t>
-            </a:r>
-          </a:p>
-        </p:txBody>
-      </p:sp>
-      <p:sp>
-        <p:nvSpPr>
-          <p:cNvPr id="3" name="Content Placeholder 2"/>
-          <p:cNvSpPr>
-            <a:spLocks noGrp="1"/>
-          </p:cNvSpPr>
-          <p:nvPr>
-            <p:ph idx="1"/>
-          </p:nvPr>
-        </p:nvSpPr>
-        <p:spPr/>
-        <p:txBody>
-          <a:bodyPr/>
-          <a:lstStyle/>
-          <a:p>
-            <a:pPr lvl="0"/>
-            <a:r>
-              <a:rPr/>
-              <a:t>Até pouco tempo atrás, sistemas seguiam apenas regras fixas, escritas por pessoas</a:t>
-            </a:r>
-          </a:p>
-          <a:p>
-            <a:pPr lvl="0"/>
-            <a:r>
-              <a:rPr/>
-              <a:t>Hoje, a inteligência artificial permite que sistemas entendam linguagem natural e respondam de forma mais flexível</a:t>
-            </a:r>
-          </a:p>
-          <a:p>
-            <a:pPr lvl="0"/>
-            <a:r>
-              <a:rPr/>
-              <a:t>Isso abre espaço para assistentes que conversam com o cliente, resumem informações e ajudam pessoas a decidir mais rápido</a:t>
-            </a:r>
-          </a:p>
-          <a:p>
-            <a:pPr lvl="0"/>
-            <a:r>
-              <a:rPr/>
-              <a:t>O desafio deixou de ser “o sistema entende o pedido?” e passou a ser “a resposta é confiável?”</a:t>
-            </a:r>
-          </a:p>
-        </p:txBody>
-      </p:sp>
-    </p:spTree>
-  </p:cSld>
-</p:sld>
-</file>
-
-<file path=ppt/slides/slide35.xml><?xml version="1.0" encoding="utf-8"?>
 <p:sld xmlns:a="http://schemas.openxmlformats.org/drawingml/2006/main" xmlns:r="http://schemas.openxmlformats.org/officeDocument/2006/relationships" xmlns:p="http://schemas.openxmlformats.org/presentationml/2006/main">
   <p:cSld>
     <p:spTree>
@@ -6690,6 +6598,58 @@
 </p:sld>
 </file>
 
+<file path=ppt/slides/slide35.xml><?xml version="1.0" encoding="utf-8"?>
+<p:sld xmlns:a="http://schemas.openxmlformats.org/drawingml/2006/main" xmlns:r="http://schemas.openxmlformats.org/officeDocument/2006/relationships" xmlns:p="http://schemas.openxmlformats.org/presentationml/2006/main">
+  <p:cSld>
+    <p:spTree>
+      <p:nvGrpSpPr>
+        <p:cNvPr id="1" name=""/>
+        <p:cNvGrpSpPr/>
+        <p:nvPr/>
+      </p:nvGrpSpPr>
+      <p:grpSpPr>
+        <a:xfrm>
+          <a:off x="0" y="0"/>
+          <a:ext cx="0" cy="0"/>
+          <a:chOff x="0" y="0"/>
+          <a:chExt cx="0" cy="0"/>
+        </a:xfrm>
+      </p:grpSpPr>
+      <p:sp>
+        <p:nvSpPr>
+          <p:cNvPr id="2" name="Title 1"/>
+          <p:cNvSpPr>
+            <a:spLocks noGrp="1"/>
+          </p:cNvSpPr>
+          <p:nvPr>
+            <p:ph type="title"/>
+          </p:nvPr>
+        </p:nvSpPr>
+        <p:spPr>
+          <a:xfrm>
+            <a:off x="722313" y="4406900"/>
+            <a:ext cx="7772400" cy="1362075"/>
+          </a:xfrm>
+        </p:spPr>
+        <p:txBody>
+          <a:bodyPr/>
+          <a:lstStyle/>
+          <a:p>
+            <a:pPr lvl="0" indent="0" marL="0">
+              <a:buNone/>
+            </a:pPr>
+            <a:r>
+              <a:rPr/>
+              <a:t>Mensagens-chave</a:t>
+            </a:r>
+          </a:p>
+        </p:txBody>
+      </p:sp>
+    </p:spTree>
+  </p:cSld>
+</p:sld>
+</file>
+
 <file path=ppt/slides/slide36.xml><?xml version="1.0" encoding="utf-8"?>
 <p:sld xmlns:a="http://schemas.openxmlformats.org/drawingml/2006/main" xmlns:r="http://schemas.openxmlformats.org/officeDocument/2006/relationships" xmlns:p="http://schemas.openxmlformats.org/presentationml/2006/main">
   <p:cSld>
@@ -6717,12 +6677,7 @@
             <p:ph type="title"/>
           </p:nvPr>
         </p:nvSpPr>
-        <p:spPr>
-          <a:xfrm>
-            <a:off x="722313" y="4406900"/>
-            <a:ext cx="7772400" cy="1362075"/>
-          </a:xfrm>
-        </p:spPr>
+        <p:spPr/>
         <p:txBody>
           <a:bodyPr/>
           <a:lstStyle/>
@@ -6732,7 +6687,65 @@
             </a:pPr>
             <a:r>
               <a:rPr/>
-              <a:t>Mensagens-chave</a:t>
+              <a:t>O que vale levar desta conversa</a:t>
+            </a:r>
+          </a:p>
+        </p:txBody>
+      </p:sp>
+      <p:sp>
+        <p:nvSpPr>
+          <p:cNvPr id="3" name="Content Placeholder 2"/>
+          <p:cNvSpPr>
+            <a:spLocks noGrp="1"/>
+          </p:cNvSpPr>
+          <p:nvPr>
+            <p:ph idx="1"/>
+          </p:nvPr>
+        </p:nvSpPr>
+        <p:spPr/>
+        <p:txBody>
+          <a:bodyPr/>
+          <a:lstStyle/>
+          <a:p>
+            <a:pPr lvl="0"/>
+            <a:r>
+              <a:rPr/>
+              <a:t>Todo produto e toda funcionalidade seguem um ciclo, da oportunidade ao aprendizado</a:t>
+            </a:r>
+          </a:p>
+          <a:p>
+            <a:pPr lvl="0"/>
+            <a:r>
+              <a:rPr/>
+              <a:t>Núcleo de Negócios e Núcleo Técnico olham para o mesmo problema sob ângulos complementares</a:t>
+            </a:r>
+          </a:p>
+          <a:p>
+            <a:pPr lvl="0"/>
+            <a:r>
+              <a:rPr/>
+              <a:t>Ciclos curtos e validação rápida reduzem risco e aceleram resultados</a:t>
+            </a:r>
+          </a:p>
+          <a:p>
+            <a:pPr lvl="0"/>
+            <a:r>
+              <a:rPr/>
+              <a:t>Comprar ou construir depende do quanto a solução diferencia o negócio, e um modelo por assinatura vive da renovação</a:t>
+            </a:r>
+          </a:p>
+          <a:p>
+            <a:pPr lvl="0"/>
+            <a:r>
+              <a:rPr/>
+              <a:t>Métricas de uso, receita e satisfação mostram se um produto está realmente funcionando</a:t>
+            </a:r>
+          </a:p>
+          <a:p>
+            <a:pPr lvl="0"/>
+            <a:r>
+              <a:rPr/>
+              <a:t>A inteligência artificial adiciona uma nova camada de valor, mas exige dados confiáveis e boa governança</a:t>
             </a:r>
           </a:p>
         </p:txBody>
@@ -6769,7 +6782,12 @@
             <p:ph type="title"/>
           </p:nvPr>
         </p:nvSpPr>
-        <p:spPr/>
+        <p:spPr>
+          <a:xfrm>
+            <a:off x="722313" y="4406900"/>
+            <a:ext cx="7772400" cy="1362075"/>
+          </a:xfrm>
+        </p:spPr>
         <p:txBody>
           <a:bodyPr/>
           <a:lstStyle/>
@@ -6779,65 +6797,7 @@
             </a:pPr>
             <a:r>
               <a:rPr/>
-              <a:t>O que vale levar desta conversa</a:t>
-            </a:r>
-          </a:p>
-        </p:txBody>
-      </p:sp>
-      <p:sp>
-        <p:nvSpPr>
-          <p:cNvPr id="3" name="Content Placeholder 2"/>
-          <p:cNvSpPr>
-            <a:spLocks noGrp="1"/>
-          </p:cNvSpPr>
-          <p:nvPr>
-            <p:ph idx="1"/>
-          </p:nvPr>
-        </p:nvSpPr>
-        <p:spPr/>
-        <p:txBody>
-          <a:bodyPr/>
-          <a:lstStyle/>
-          <a:p>
-            <a:pPr lvl="0"/>
-            <a:r>
-              <a:rPr/>
-              <a:t>Todo produto e toda funcionalidade seguem um ciclo, da oportunidade ao aprendizado</a:t>
-            </a:r>
-          </a:p>
-          <a:p>
-            <a:pPr lvl="0"/>
-            <a:r>
-              <a:rPr/>
-              <a:t>Product Owner, System Engineer e Tech Lead olham para o mesmo problema sob ângulos diferentes</a:t>
-            </a:r>
-          </a:p>
-          <a:p>
-            <a:pPr lvl="0"/>
-            <a:r>
-              <a:rPr/>
-              <a:t>Ciclos curtos e validação rápida reduzem risco e aceleram resultados</a:t>
-            </a:r>
-          </a:p>
-          <a:p>
-            <a:pPr lvl="0"/>
-            <a:r>
-              <a:rPr/>
-              <a:t>Comprar ou construir depende do quanto a solução diferencia o negócio, e um modelo por assinatura vive da renovação</a:t>
-            </a:r>
-          </a:p>
-          <a:p>
-            <a:pPr lvl="0"/>
-            <a:r>
-              <a:rPr/>
-              <a:t>Métricas de uso, receita e satisfação mostram se um produto está realmente funcionando</a:t>
-            </a:r>
-          </a:p>
-          <a:p>
-            <a:pPr lvl="0"/>
-            <a:r>
-              <a:rPr/>
-              <a:t>A inteligência artificial adiciona uma nova camada de valor, mas exige dados confiáveis e boa governança</a:t>
+              <a:t>Um caso prático: juntando tudo o que vimos</a:t>
             </a:r>
           </a:p>
         </p:txBody>
@@ -6874,12 +6834,7 @@
             <p:ph type="title"/>
           </p:nvPr>
         </p:nvSpPr>
-        <p:spPr>
-          <a:xfrm>
-            <a:off x="722313" y="4406900"/>
-            <a:ext cx="7772400" cy="1362075"/>
-          </a:xfrm>
-        </p:spPr>
+        <p:spPr/>
         <p:txBody>
           <a:bodyPr/>
           <a:lstStyle/>
@@ -6889,7 +6844,51 @@
             </a:pPr>
             <a:r>
               <a:rPr/>
-              <a:t>Um caso prático: juntando tudo o que vimos</a:t>
+              <a:t>O contexto: NovaSeguro Corretora (exemplo fictício)</a:t>
+            </a:r>
+          </a:p>
+        </p:txBody>
+      </p:sp>
+      <p:sp>
+        <p:nvSpPr>
+          <p:cNvPr id="3" name="Content Placeholder 2"/>
+          <p:cNvSpPr>
+            <a:spLocks noGrp="1"/>
+          </p:cNvSpPr>
+          <p:nvPr>
+            <p:ph idx="1"/>
+          </p:nvPr>
+        </p:nvSpPr>
+        <p:spPr/>
+        <p:txBody>
+          <a:bodyPr/>
+          <a:lstStyle/>
+          <a:p>
+            <a:pPr lvl="0"/>
+            <a:r>
+              <a:rPr/>
+              <a:t>A NovaSeguro trabalha com várias seguradoras parceiras ao mesmo tempo</a:t>
+            </a:r>
+          </a:p>
+          <a:p>
+            <a:pPr lvl="0"/>
+            <a:r>
+              <a:rPr/>
+              <a:t>Cada seguradora tem suas próprias regras, apólices, coberturas e prazos</a:t>
+            </a:r>
+          </a:p>
+          <a:p>
+            <a:pPr lvl="0"/>
+            <a:r>
+              <a:rPr/>
+              <a:t>Os corretores precisam responder perguntas de clientes com rapidez e precisão</a:t>
+            </a:r>
+          </a:p>
+          <a:p>
+            <a:pPr lvl="0"/>
+            <a:r>
+              <a:rPr/>
+              <a:t>Hoje, essa informação está espalhada entre manuais, planilhas e sistemas diferentes</a:t>
             </a:r>
           </a:p>
         </p:txBody>
@@ -6936,7 +6935,7 @@
             </a:pPr>
             <a:r>
               <a:rPr/>
-              <a:t>O contexto: NovaSeguro Corretora (exemplo fictício)</a:t>
+              <a:t>O desafio do dia a dia</a:t>
             </a:r>
           </a:p>
         </p:txBody>
@@ -6959,28 +6958,28 @@
             <a:pPr lvl="0"/>
             <a:r>
               <a:rPr/>
-              <a:t>A NovaSeguro trabalha com várias seguradoras parceiras ao mesmo tempo</a:t>
-            </a:r>
-          </a:p>
-          <a:p>
-            <a:pPr lvl="0"/>
-            <a:r>
-              <a:rPr/>
-              <a:t>Cada seguradora tem suas próprias regras, apólices, coberturas e prazos</a:t>
-            </a:r>
-          </a:p>
-          <a:p>
-            <a:pPr lvl="0"/>
-            <a:r>
-              <a:rPr/>
-              <a:t>Os corretores precisam responder perguntas de clientes com rapidez e precisão</a:t>
-            </a:r>
-          </a:p>
-          <a:p>
-            <a:pPr lvl="0"/>
-            <a:r>
-              <a:rPr/>
-              <a:t>Hoje, essa informação está espalhada entre manuais, planilhas e sistemas diferentes</a:t>
+              <a:t>Encontrar a informação certa toma tempo e depende de quem está de plantão</a:t>
+            </a:r>
+          </a:p>
+          <a:p>
+            <a:pPr lvl="0"/>
+            <a:r>
+              <a:rPr/>
+              <a:t>É difícil comparar coberturas entre seguradoras diferentes na hora da conversa com o cliente</a:t>
+            </a:r>
+          </a:p>
+          <a:p>
+            <a:pPr lvl="0"/>
+            <a:r>
+              <a:rPr/>
+              <a:t>Perguntas mais complexas, como possíveis sobreposições de cobertura, quase nunca são respondidas na hora</a:t>
+            </a:r>
+          </a:p>
+          <a:p>
+            <a:pPr lvl="0"/>
+            <a:r>
+              <a:rPr/>
+              <a:t>O resultado é atendimento mais lento e risco de informação incorreta</a:t>
             </a:r>
           </a:p>
         </p:txBody>
@@ -7118,7 +7117,7 @@
             </a:pPr>
             <a:r>
               <a:rPr/>
-              <a:t>O desafio do dia a dia</a:t>
+              <a:t>Um detalhe importante: apólices também se renovam</a:t>
             </a:r>
           </a:p>
         </p:txBody>
@@ -7141,28 +7140,28 @@
             <a:pPr lvl="0"/>
             <a:r>
               <a:rPr/>
-              <a:t>Encontrar a informação certa toma tempo e depende de quem está de plantão</a:t>
-            </a:r>
-          </a:p>
-          <a:p>
-            <a:pPr lvl="0"/>
-            <a:r>
-              <a:rPr/>
-              <a:t>É difícil comparar coberturas entre seguradoras diferentes na hora da conversa com o cliente</a:t>
-            </a:r>
-          </a:p>
-          <a:p>
-            <a:pPr lvl="0"/>
-            <a:r>
-              <a:rPr/>
-              <a:t>Perguntas mais complexas, como possíveis sobreposições de cobertura, quase nunca são respondidas na hora</a:t>
-            </a:r>
-          </a:p>
-          <a:p>
-            <a:pPr lvl="0"/>
-            <a:r>
-              <a:rPr/>
-              <a:t>O resultado é atendimento mais lento e risco de informação incorreta</a:t>
+              <a:t>Diferente de uma compra única, uma apólice de seguro é renovada periodicamente, quase sempre uma vez por ano</a:t>
+            </a:r>
+          </a:p>
+          <a:p>
+            <a:pPr lvl="0"/>
+            <a:r>
+              <a:rPr/>
+              <a:t>Isso significa que os mesmos conceitos vistos em negócios por assinatura se aplicam aqui: uso, satisfação e, principalmente, renovação</a:t>
+            </a:r>
+          </a:p>
+          <a:p>
+            <a:pPr lvl="0"/>
+            <a:r>
+              <a:rPr/>
+              <a:t>Cada renovação bem-sucedida garante receita futura; cada cancelamento é uma perda que poderia ter sido antecipada</a:t>
+            </a:r>
+          </a:p>
+          <a:p>
+            <a:pPr lvl="0"/>
+            <a:r>
+              <a:rPr/>
+              <a:t>Por isso a NovaSeguro decide usar tecnologia não só para atender bem, mas para entender e influenciar essas renovações</a:t>
             </a:r>
           </a:p>
         </p:txBody>
@@ -7173,97 +7172,6 @@
 </file>
 
 <file path=ppt/slides/slide41.xml><?xml version="1.0" encoding="utf-8"?>
-<p:sld xmlns:a="http://schemas.openxmlformats.org/drawingml/2006/main" xmlns:r="http://schemas.openxmlformats.org/officeDocument/2006/relationships" xmlns:p="http://schemas.openxmlformats.org/presentationml/2006/main">
-  <p:cSld>
-    <p:spTree>
-      <p:nvGrpSpPr>
-        <p:cNvPr id="1" name=""/>
-        <p:cNvGrpSpPr/>
-        <p:nvPr/>
-      </p:nvGrpSpPr>
-      <p:grpSpPr>
-        <a:xfrm>
-          <a:off x="0" y="0"/>
-          <a:ext cx="0" cy="0"/>
-          <a:chOff x="0" y="0"/>
-          <a:chExt cx="0" cy="0"/>
-        </a:xfrm>
-      </p:grpSpPr>
-      <p:sp>
-        <p:nvSpPr>
-          <p:cNvPr id="2" name="Title 1"/>
-          <p:cNvSpPr>
-            <a:spLocks noGrp="1"/>
-          </p:cNvSpPr>
-          <p:nvPr>
-            <p:ph type="title"/>
-          </p:nvPr>
-        </p:nvSpPr>
-        <p:spPr/>
-        <p:txBody>
-          <a:bodyPr/>
-          <a:lstStyle/>
-          <a:p>
-            <a:pPr lvl="0" indent="0" marL="0">
-              <a:buNone/>
-            </a:pPr>
-            <a:r>
-              <a:rPr/>
-              <a:t>Um detalhe importante: apólices também se renovam</a:t>
-            </a:r>
-          </a:p>
-        </p:txBody>
-      </p:sp>
-      <p:sp>
-        <p:nvSpPr>
-          <p:cNvPr id="3" name="Content Placeholder 2"/>
-          <p:cNvSpPr>
-            <a:spLocks noGrp="1"/>
-          </p:cNvSpPr>
-          <p:nvPr>
-            <p:ph idx="1"/>
-          </p:nvPr>
-        </p:nvSpPr>
-        <p:spPr/>
-        <p:txBody>
-          <a:bodyPr/>
-          <a:lstStyle/>
-          <a:p>
-            <a:pPr lvl="0"/>
-            <a:r>
-              <a:rPr/>
-              <a:t>Diferente de uma compra única, uma apólice de seguro é renovada periodicamente, quase sempre uma vez por ano</a:t>
-            </a:r>
-          </a:p>
-          <a:p>
-            <a:pPr lvl="0"/>
-            <a:r>
-              <a:rPr/>
-              <a:t>Isso significa que os mesmos conceitos vistos em negócios por assinatura se aplicam aqui: uso, satisfação e, principalmente, renovação</a:t>
-            </a:r>
-          </a:p>
-          <a:p>
-            <a:pPr lvl="0"/>
-            <a:r>
-              <a:rPr/>
-              <a:t>Cada renovação bem-sucedida garante receita futura; cada cancelamento é uma perda que poderia ter sido antecipada</a:t>
-            </a:r>
-          </a:p>
-          <a:p>
-            <a:pPr lvl="0"/>
-            <a:r>
-              <a:rPr/>
-              <a:t>Por isso a NovaSeguro decide usar tecnologia não só para atender bem, mas para entender e influenciar essas renovações</a:t>
-            </a:r>
-          </a:p>
-        </p:txBody>
-      </p:sp>
-    </p:spTree>
-  </p:cSld>
-</p:sld>
-</file>
-
-<file path=ppt/slides/slide42.xml><?xml version="1.0" encoding="utf-8"?>
 <p:sld xmlns:a="http://schemas.openxmlformats.org/drawingml/2006/main" xmlns:r="http://schemas.openxmlformats.org/officeDocument/2006/relationships" xmlns:p="http://schemas.openxmlformats.org/presentationml/2006/main">
   <p:cSld>
     <p:spTree>
@@ -7340,6 +7248,97 @@
 </p:sld>
 </file>
 
+<file path=ppt/slides/slide42.xml><?xml version="1.0" encoding="utf-8"?>
+<p:sld xmlns:a="http://schemas.openxmlformats.org/drawingml/2006/main" xmlns:r="http://schemas.openxmlformats.org/officeDocument/2006/relationships" xmlns:p="http://schemas.openxmlformats.org/presentationml/2006/main">
+  <p:cSld>
+    <p:spTree>
+      <p:nvGrpSpPr>
+        <p:cNvPr id="1" name=""/>
+        <p:cNvGrpSpPr/>
+        <p:nvPr/>
+      </p:nvGrpSpPr>
+      <p:grpSpPr>
+        <a:xfrm>
+          <a:off x="0" y="0"/>
+          <a:ext cx="0" cy="0"/>
+          <a:chOff x="0" y="0"/>
+          <a:chExt cx="0" cy="0"/>
+        </a:xfrm>
+      </p:grpSpPr>
+      <p:sp>
+        <p:nvSpPr>
+          <p:cNvPr id="2" name="Title 1"/>
+          <p:cNvSpPr>
+            <a:spLocks noGrp="1"/>
+          </p:cNvSpPr>
+          <p:nvPr>
+            <p:ph type="title"/>
+          </p:nvPr>
+        </p:nvSpPr>
+        <p:spPr/>
+        <p:txBody>
+          <a:bodyPr/>
+          <a:lstStyle/>
+          <a:p>
+            <a:pPr lvl="0" indent="0" marL="0">
+              <a:buNone/>
+            </a:pPr>
+            <a:r>
+              <a:rPr/>
+              <a:t>Começando simples: consulta a documentos</a:t>
+            </a:r>
+          </a:p>
+        </p:txBody>
+      </p:sp>
+      <p:sp>
+        <p:nvSpPr>
+          <p:cNvPr id="3" name="Content Placeholder 2"/>
+          <p:cNvSpPr>
+            <a:spLocks noGrp="1"/>
+          </p:cNvSpPr>
+          <p:nvPr>
+            <p:ph idx="1"/>
+          </p:nvPr>
+        </p:nvSpPr>
+        <p:spPr/>
+        <p:txBody>
+          <a:bodyPr/>
+          <a:lstStyle/>
+          <a:p>
+            <a:pPr lvl="0"/>
+            <a:r>
+              <a:rPr/>
+              <a:t>O assistente é treinado para consultar manuais, apólices e contratos das seguradoras parceiras</a:t>
+            </a:r>
+          </a:p>
+          <a:p>
+            <a:pPr lvl="0"/>
+            <a:r>
+              <a:rPr/>
+              <a:t>Quando o corretor faz uma pergunta, ele busca a informação nos documentos certos</a:t>
+            </a:r>
+          </a:p>
+          <a:p>
+            <a:pPr lvl="0"/>
+            <a:r>
+              <a:rPr/>
+              <a:t>A resposta sempre indica de onde veio a informação, para gerar confiança</a:t>
+            </a:r>
+          </a:p>
+          <a:p>
+            <a:pPr lvl="0"/>
+            <a:r>
+              <a:rPr/>
+              <a:t>Essa é a base: uma forma de a IA responder com apoio em fontes confiáveis, e não apenas “adivinhar”</a:t>
+            </a:r>
+          </a:p>
+        </p:txBody>
+      </p:sp>
+    </p:spTree>
+  </p:cSld>
+</p:sld>
+</file>
+
 <file path=ppt/slides/slide43.xml><?xml version="1.0" encoding="utf-8"?>
 <p:sld xmlns:a="http://schemas.openxmlformats.org/drawingml/2006/main" xmlns:r="http://schemas.openxmlformats.org/officeDocument/2006/relationships" xmlns:p="http://schemas.openxmlformats.org/presentationml/2006/main">
   <p:cSld>
@@ -7377,7 +7376,7 @@
             </a:pPr>
             <a:r>
               <a:rPr/>
-              <a:t>Começando simples: consulta a documentos</a:t>
+              <a:t>Evoluindo: entendendo as conexões entre as informações</a:t>
             </a:r>
           </a:p>
         </p:txBody>
@@ -7400,28 +7399,28 @@
             <a:pPr lvl="0"/>
             <a:r>
               <a:rPr/>
-              <a:t>O assistente é treinado para consultar manuais, apólices e contratos das seguradoras parceiras</a:t>
-            </a:r>
-          </a:p>
-          <a:p>
-            <a:pPr lvl="0"/>
-            <a:r>
-              <a:rPr/>
-              <a:t>Quando o corretor faz uma pergunta, ele busca a informação nos documentos certos</a:t>
-            </a:r>
-          </a:p>
-          <a:p>
-            <a:pPr lvl="0"/>
-            <a:r>
-              <a:rPr/>
-              <a:t>A resposta sempre indica de onde veio a informação, para gerar confiança</a:t>
-            </a:r>
-          </a:p>
-          <a:p>
-            <a:pPr lvl="0"/>
-            <a:r>
-              <a:rPr/>
-              <a:t>Essa é a base: uma forma de a IA responder com apoio em fontes confiáveis, e não apenas “adivinhar”</a:t>
+              <a:t>Com o tempo, a NovaSeguro passa a mapear como as informações se relacionam: clientes, apólices, coberturas, sinistros e seguradoras</a:t>
+            </a:r>
+          </a:p>
+          <a:p>
+            <a:pPr lvl="0"/>
+            <a:r>
+              <a:rPr/>
+              <a:t>Isso permite responder perguntas mais ricas, como identificar sobreposições de cobertura entre seguradoras diferentes</a:t>
+            </a:r>
+          </a:p>
+          <a:p>
+            <a:pPr lvl="0"/>
+            <a:r>
+              <a:rPr/>
+              <a:t>O assistente passa a enxergar o panorama completo do cliente, e não apenas um documento isolado</a:t>
+            </a:r>
+          </a:p>
+          <a:p>
+            <a:pPr lvl="0"/>
+            <a:r>
+              <a:rPr/>
+              <a:t>É um salto de “responder perguntas” para “gerar recomendações de negócio”</a:t>
             </a:r>
           </a:p>
         </p:txBody>
@@ -7468,7 +7467,7 @@
             </a:pPr>
             <a:r>
               <a:rPr/>
-              <a:t>Evoluindo: entendendo as conexões entre as informações</a:t>
+              <a:t>Indo além: prevendo receita e risco de cancelamento</a:t>
             </a:r>
           </a:p>
         </p:txBody>
@@ -7491,28 +7490,28 @@
             <a:pPr lvl="0"/>
             <a:r>
               <a:rPr/>
-              <a:t>Com o tempo, a NovaSeguro passa a mapear como as informações se relacionam: clientes, apólices, coberturas, sinistros e seguradoras</a:t>
-            </a:r>
-          </a:p>
-          <a:p>
-            <a:pPr lvl="0"/>
-            <a:r>
-              <a:rPr/>
-              <a:t>Isso permite responder perguntas mais ricas, como identificar sobreposições de cobertura entre seguradoras diferentes</a:t>
-            </a:r>
-          </a:p>
-          <a:p>
-            <a:pPr lvl="0"/>
-            <a:r>
-              <a:rPr/>
-              <a:t>O assistente passa a enxergar o panorama completo do cliente, e não apenas um documento isolado</a:t>
-            </a:r>
-          </a:p>
-          <a:p>
-            <a:pPr lvl="0"/>
-            <a:r>
-              <a:rPr/>
-              <a:t>É um salto de “responder perguntas” para “gerar recomendações de negócio”</a:t>
+              <a:t>O mesmo assistente passa a olhar para o histórico de uso e de relacionamento de cada cliente</a:t>
+            </a:r>
+          </a:p>
+          <a:p>
+            <a:pPr lvl="0"/>
+            <a:r>
+              <a:rPr/>
+              <a:t>Com base nesses sinais, ele estima a chance de cada apólice ser renovada ou cancelada</a:t>
+            </a:r>
+          </a:p>
+          <a:p>
+            <a:pPr lvl="0"/>
+            <a:r>
+              <a:rPr/>
+              <a:t>Essa estimativa alimenta uma projeção da receita futura da corretora, mês a mês</a:t>
+            </a:r>
+          </a:p>
+          <a:p>
+            <a:pPr lvl="0"/>
+            <a:r>
+              <a:rPr/>
+              <a:t>Uma decisão antes baseada só em intuição passa a ser apoiada em dados</a:t>
             </a:r>
           </a:p>
         </p:txBody>
@@ -7523,97 +7522,6 @@
 </file>
 
 <file path=ppt/slides/slide45.xml><?xml version="1.0" encoding="utf-8"?>
-<p:sld xmlns:a="http://schemas.openxmlformats.org/drawingml/2006/main" xmlns:r="http://schemas.openxmlformats.org/officeDocument/2006/relationships" xmlns:p="http://schemas.openxmlformats.org/presentationml/2006/main">
-  <p:cSld>
-    <p:spTree>
-      <p:nvGrpSpPr>
-        <p:cNvPr id="1" name=""/>
-        <p:cNvGrpSpPr/>
-        <p:nvPr/>
-      </p:nvGrpSpPr>
-      <p:grpSpPr>
-        <a:xfrm>
-          <a:off x="0" y="0"/>
-          <a:ext cx="0" cy="0"/>
-          <a:chOff x="0" y="0"/>
-          <a:chExt cx="0" cy="0"/>
-        </a:xfrm>
-      </p:grpSpPr>
-      <p:sp>
-        <p:nvSpPr>
-          <p:cNvPr id="2" name="Title 1"/>
-          <p:cNvSpPr>
-            <a:spLocks noGrp="1"/>
-          </p:cNvSpPr>
-          <p:nvPr>
-            <p:ph type="title"/>
-          </p:nvPr>
-        </p:nvSpPr>
-        <p:spPr/>
-        <p:txBody>
-          <a:bodyPr/>
-          <a:lstStyle/>
-          <a:p>
-            <a:pPr lvl="0" indent="0" marL="0">
-              <a:buNone/>
-            </a:pPr>
-            <a:r>
-              <a:rPr/>
-              <a:t>Indo além: prevendo receita e risco de cancelamento</a:t>
-            </a:r>
-          </a:p>
-        </p:txBody>
-      </p:sp>
-      <p:sp>
-        <p:nvSpPr>
-          <p:cNvPr id="3" name="Content Placeholder 2"/>
-          <p:cNvSpPr>
-            <a:spLocks noGrp="1"/>
-          </p:cNvSpPr>
-          <p:nvPr>
-            <p:ph idx="1"/>
-          </p:nvPr>
-        </p:nvSpPr>
-        <p:spPr/>
-        <p:txBody>
-          <a:bodyPr/>
-          <a:lstStyle/>
-          <a:p>
-            <a:pPr lvl="0"/>
-            <a:r>
-              <a:rPr/>
-              <a:t>O mesmo assistente passa a olhar para o histórico de uso e de relacionamento de cada cliente</a:t>
-            </a:r>
-          </a:p>
-          <a:p>
-            <a:pPr lvl="0"/>
-            <a:r>
-              <a:rPr/>
-              <a:t>Com base nesses sinais, ele estima a chance de cada apólice ser renovada ou cancelada</a:t>
-            </a:r>
-          </a:p>
-          <a:p>
-            <a:pPr lvl="0"/>
-            <a:r>
-              <a:rPr/>
-              <a:t>Essa estimativa alimenta uma projeção da receita futura da corretora, mês a mês</a:t>
-            </a:r>
-          </a:p>
-          <a:p>
-            <a:pPr lvl="0"/>
-            <a:r>
-              <a:rPr/>
-              <a:t>Uma decisão antes baseada só em intuição passa a ser apoiada em dados</a:t>
-            </a:r>
-          </a:p>
-        </p:txBody>
-      </p:sp>
-    </p:spTree>
-  </p:cSld>
-</p:sld>
-</file>
-
-<file path=ppt/slides/slide46.xml><?xml version="1.0" encoding="utf-8"?>
 <p:sld xmlns:a="http://schemas.openxmlformats.org/drawingml/2006/main" xmlns:r="http://schemas.openxmlformats.org/officeDocument/2006/relationships" xmlns:p="http://schemas.openxmlformats.org/presentationml/2006/main">
   <p:cSld>
     <p:spTree>
@@ -7690,6 +7598,83 @@
 </p:sld>
 </file>
 
+<file path=ppt/slides/slide46.xml><?xml version="1.0" encoding="utf-8"?>
+<p:sld xmlns:a="http://schemas.openxmlformats.org/drawingml/2006/main" xmlns:r="http://schemas.openxmlformats.org/officeDocument/2006/relationships" xmlns:p="http://schemas.openxmlformats.org/presentationml/2006/main">
+  <p:cSld>
+    <p:spTree>
+      <p:nvGrpSpPr>
+        <p:cNvPr id="1" name=""/>
+        <p:cNvGrpSpPr/>
+        <p:nvPr/>
+      </p:nvGrpSpPr>
+      <p:grpSpPr>
+        <a:xfrm>
+          <a:off x="0" y="0"/>
+          <a:ext cx="0" cy="0"/>
+          <a:chOff x="0" y="0"/>
+          <a:chExt cx="0" cy="0"/>
+        </a:xfrm>
+      </p:grpSpPr>
+      <p:sp>
+        <p:nvSpPr>
+          <p:cNvPr id="2" name="Title 1"/>
+          <p:cNvSpPr>
+            <a:spLocks noGrp="1"/>
+          </p:cNvSpPr>
+          <p:nvPr>
+            <p:ph type="title"/>
+          </p:nvPr>
+        </p:nvSpPr>
+        <p:spPr/>
+        <p:txBody>
+          <a:bodyPr/>
+          <a:lstStyle/>
+          <a:p>
+            <a:pPr lvl="0" indent="0" marL="0">
+              <a:buNone/>
+            </a:pPr>
+            <a:r>
+              <a:rPr/>
+              <a:t>Do papel para a tela: a ferramenta em produção</a:t>
+            </a:r>
+          </a:p>
+        </p:txBody>
+      </p:sp>
+      <p:pic>
+        <p:nvPicPr>
+          <p:cNvPr descr="assets/screenshots/app_home.png" id="0" name="Picture 1"/>
+          <p:cNvPicPr>
+            <a:picLocks noGrp="1" noChangeAspect="1"/>
+          </p:cNvPicPr>
+          <p:nvPr/>
+        </p:nvPicPr>
+        <p:blipFill>
+          <a:blip r:embed="rId3"/>
+          <a:stretch>
+            <a:fillRect/>
+          </a:stretch>
+        </p:blipFill>
+        <p:spPr bwMode="auto">
+          <a:xfrm>
+            <a:off x="952500" y="1600200"/>
+            <a:ext cx="7239000" cy="4521200"/>
+          </a:xfrm>
+          <a:prstGeom prst="rect">
+            <a:avLst/>
+          </a:prstGeom>
+          <a:noFill/>
+          <a:ln w="9525">
+            <a:noFill/>
+            <a:headEnd/>
+            <a:tailEnd/>
+          </a:ln>
+        </p:spPr>
+      </p:pic>
+    </p:spTree>
+  </p:cSld>
+</p:sld>
+</file>
+
 <file path=ppt/slides/slide47.xml><?xml version="1.0" encoding="utf-8"?>
 <p:sld xmlns:a="http://schemas.openxmlformats.org/drawingml/2006/main" xmlns:r="http://schemas.openxmlformats.org/officeDocument/2006/relationships" xmlns:p="http://schemas.openxmlformats.org/presentationml/2006/main">
   <p:cSld>
@@ -7727,21 +7712,21 @@
             </a:pPr>
             <a:r>
               <a:rPr/>
-              <a:t>Do papel para a tela: a ferramenta em produção</a:t>
+              <a:t>Painel do corretor, com dados reais da carteira</a:t>
             </a:r>
           </a:p>
         </p:txBody>
       </p:sp>
       <p:pic>
         <p:nvPicPr>
-          <p:cNvPr descr="assets/screenshots/app_home.png" id="0" name="Picture 1"/>
+          <p:cNvPr descr="assets/screenshots/app_dashboard.png" id="0" name="Picture 1"/>
           <p:cNvPicPr>
             <a:picLocks noGrp="1" noChangeAspect="1"/>
           </p:cNvPicPr>
           <p:nvPr/>
         </p:nvPicPr>
         <p:blipFill>
-          <a:blip r:embed="rId3"/>
+          <a:blip r:embed="rId2"/>
           <a:stretch>
             <a:fillRect/>
           </a:stretch>
@@ -7804,14 +7789,14 @@
             </a:pPr>
             <a:r>
               <a:rPr/>
-              <a:t>Painel do corretor, com dados reais da carteira</a:t>
+              <a:t>Conversando com o copiloto de IA</a:t>
             </a:r>
           </a:p>
         </p:txBody>
       </p:sp>
       <p:pic>
         <p:nvPicPr>
-          <p:cNvPr descr="assets/screenshots/app_dashboard.png" id="0" name="Picture 1"/>
+          <p:cNvPr descr="assets/screenshots/app_chat.png" id="0" name="Picture 1"/>
           <p:cNvPicPr>
             <a:picLocks noGrp="1" noChangeAspect="1"/>
           </p:cNvPicPr>
@@ -7881,14 +7866,14 @@
             </a:pPr>
             <a:r>
               <a:rPr/>
-              <a:t>Conversando com o copiloto de IA</a:t>
+              <a:t>Visão da carteira de clientes</a:t>
             </a:r>
           </a:p>
         </p:txBody>
       </p:sp>
       <p:pic>
         <p:nvPicPr>
-          <p:cNvPr descr="assets/screenshots/app_chat.png" id="0" name="Picture 1"/>
+          <p:cNvPr descr="assets/screenshots/app_clientes.png" id="0" name="Picture 1"/>
           <p:cNvPicPr>
             <a:picLocks noGrp="1" noChangeAspect="1"/>
           </p:cNvPicPr>
@@ -8035,14 +8020,14 @@
             </a:pPr>
             <a:r>
               <a:rPr/>
-              <a:t>Visão da carteira de clientes</a:t>
+              <a:t>Enviando apólices em PDF para a base de conhecimento</a:t>
             </a:r>
           </a:p>
         </p:txBody>
       </p:sp>
       <p:pic>
         <p:nvPicPr>
-          <p:cNvPr descr="assets/screenshots/app_clientes.png" id="0" name="Picture 1"/>
+          <p:cNvPr descr="assets/screenshots/app_documentos.png" id="0" name="Picture 1"/>
           <p:cNvPicPr>
             <a:picLocks noGrp="1" noChangeAspect="1"/>
           </p:cNvPicPr>
@@ -8112,41 +8097,55 @@
             </a:pPr>
             <a:r>
               <a:rPr/>
-              <a:t>Enviando apólices em PDF para a base de conhecimento</a:t>
-            </a:r>
-          </a:p>
-        </p:txBody>
-      </p:sp>
-      <p:pic>
-        <p:nvPicPr>
-          <p:cNvPr descr="assets/screenshots/app_documentos.png" id="0" name="Picture 1"/>
-          <p:cNvPicPr>
-            <a:picLocks noGrp="1" noChangeAspect="1"/>
-          </p:cNvPicPr>
-          <p:nvPr/>
-        </p:nvPicPr>
-        <p:blipFill>
-          <a:blip r:embed="rId2"/>
-          <a:stretch>
-            <a:fillRect/>
-          </a:stretch>
-        </p:blipFill>
-        <p:spPr bwMode="auto">
-          <a:xfrm>
-            <a:off x="952500" y="1600200"/>
-            <a:ext cx="7239000" cy="4521200"/>
-          </a:xfrm>
-          <a:prstGeom prst="rect">
-            <a:avLst/>
-          </a:prstGeom>
-          <a:noFill/>
-          <a:ln w="9525">
-            <a:noFill/>
-            <a:headEnd/>
-            <a:tailEnd/>
-          </a:ln>
-        </p:spPr>
-      </p:pic>
+              <a:t>Benefícios para o negócio</a:t>
+            </a:r>
+          </a:p>
+        </p:txBody>
+      </p:sp>
+      <p:sp>
+        <p:nvSpPr>
+          <p:cNvPr id="3" name="Content Placeholder 2"/>
+          <p:cNvSpPr>
+            <a:spLocks noGrp="1"/>
+          </p:cNvSpPr>
+          <p:nvPr>
+            <p:ph idx="1"/>
+          </p:nvPr>
+        </p:nvSpPr>
+        <p:spPr/>
+        <p:txBody>
+          <a:bodyPr/>
+          <a:lstStyle/>
+          <a:p>
+            <a:pPr lvl="0"/>
+            <a:r>
+              <a:rPr/>
+              <a:t>Atendimento mais rápido e preciso, com menos tempo de espera para o cliente</a:t>
+            </a:r>
+          </a:p>
+          <a:p>
+            <a:pPr lvl="0"/>
+            <a:r>
+              <a:rPr/>
+              <a:t>Menos cancelamentos, porque sinais de risco são tratados antes do vencimento da apólice</a:t>
+            </a:r>
+          </a:p>
+          <a:p>
+            <a:pPr lvl="0"/>
+            <a:r>
+              <a:rPr/>
+              <a:t>Previsão de receita mais confiável, o que ajuda o planejamento financeiro da corretora</a:t>
+            </a:r>
+          </a:p>
+          <a:p>
+            <a:pPr lvl="0"/>
+            <a:r>
+              <a:rPr/>
+              <a:t>Decisões melhores, apoiadas em uma visão mais completa de cada cliente</a:t>
+            </a:r>
+          </a:p>
+        </p:txBody>
+      </p:sp>
     </p:spTree>
   </p:cSld>
 </p:sld>
@@ -8189,7 +8188,7 @@
             </a:pPr>
             <a:r>
               <a:rPr/>
-              <a:t>Benefícios para o negócio</a:t>
+              <a:t>Cuidados importantes</a:t>
             </a:r>
           </a:p>
         </p:txBody>
@@ -8212,28 +8211,28 @@
             <a:pPr lvl="0"/>
             <a:r>
               <a:rPr/>
-              <a:t>Atendimento mais rápido e preciso, com menos tempo de espera para o cliente</a:t>
-            </a:r>
-          </a:p>
-          <a:p>
-            <a:pPr lvl="0"/>
-            <a:r>
-              <a:rPr/>
-              <a:t>Menos cancelamentos, porque sinais de risco são tratados antes do vencimento da apólice</a:t>
-            </a:r>
-          </a:p>
-          <a:p>
-            <a:pPr lvl="0"/>
-            <a:r>
-              <a:rPr/>
-              <a:t>Previsão de receita mais confiável, o que ajuda o planejamento financeiro da corretora</a:t>
-            </a:r>
-          </a:p>
-          <a:p>
-            <a:pPr lvl="0"/>
-            <a:r>
-              <a:rPr/>
-              <a:t>Decisões melhores, apoiadas em uma visão mais completa de cada cliente</a:t>
+              <a:t>A qualidade da previsão depende da qualidade dos dados usados como fonte</a:t>
+            </a:r>
+          </a:p>
+          <a:p>
+            <a:pPr lvl="0"/>
+            <a:r>
+              <a:rPr/>
+              <a:t>Pessoas continuam responsáveis por revisar decisões de maior impacto</a:t>
+            </a:r>
+          </a:p>
+          <a:p>
+            <a:pPr lvl="0"/>
+            <a:r>
+              <a:rPr/>
+              <a:t>O contato automático com o cliente precisa ser cuidadoso, sem parecer invasivo ou impessoal</a:t>
+            </a:r>
+          </a:p>
+          <a:p>
+            <a:pPr lvl="0"/>
+            <a:r>
+              <a:rPr/>
+              <a:t>Inteligência artificial é uma ferramenta poderosa, mas não substitui a governança do negócio</a:t>
             </a:r>
           </a:p>
         </p:txBody>
@@ -8270,97 +8269,6 @@
             <p:ph type="title"/>
           </p:nvPr>
         </p:nvSpPr>
-        <p:spPr/>
-        <p:txBody>
-          <a:bodyPr/>
-          <a:lstStyle/>
-          <a:p>
-            <a:pPr lvl="0" indent="0" marL="0">
-              <a:buNone/>
-            </a:pPr>
-            <a:r>
-              <a:rPr/>
-              <a:t>Cuidados importantes</a:t>
-            </a:r>
-          </a:p>
-        </p:txBody>
-      </p:sp>
-      <p:sp>
-        <p:nvSpPr>
-          <p:cNvPr id="3" name="Content Placeholder 2"/>
-          <p:cNvSpPr>
-            <a:spLocks noGrp="1"/>
-          </p:cNvSpPr>
-          <p:nvPr>
-            <p:ph idx="1"/>
-          </p:nvPr>
-        </p:nvSpPr>
-        <p:spPr/>
-        <p:txBody>
-          <a:bodyPr/>
-          <a:lstStyle/>
-          <a:p>
-            <a:pPr lvl="0"/>
-            <a:r>
-              <a:rPr/>
-              <a:t>A qualidade da previsão depende da qualidade dos dados usados como fonte</a:t>
-            </a:r>
-          </a:p>
-          <a:p>
-            <a:pPr lvl="0"/>
-            <a:r>
-              <a:rPr/>
-              <a:t>Pessoas continuam responsáveis por revisar decisões de maior impacto</a:t>
-            </a:r>
-          </a:p>
-          <a:p>
-            <a:pPr lvl="0"/>
-            <a:r>
-              <a:rPr/>
-              <a:t>O contato automático com o cliente precisa ser cuidadoso, sem parecer invasivo ou impessoal</a:t>
-            </a:r>
-          </a:p>
-          <a:p>
-            <a:pPr lvl="0"/>
-            <a:r>
-              <a:rPr/>
-              <a:t>Inteligência artificial é uma ferramenta poderosa, mas não substitui a governança do negócio</a:t>
-            </a:r>
-          </a:p>
-        </p:txBody>
-      </p:sp>
-    </p:spTree>
-  </p:cSld>
-</p:sld>
-</file>
-
-<file path=ppt/slides/slide54.xml><?xml version="1.0" encoding="utf-8"?>
-<p:sld xmlns:a="http://schemas.openxmlformats.org/drawingml/2006/main" xmlns:r="http://schemas.openxmlformats.org/officeDocument/2006/relationships" xmlns:p="http://schemas.openxmlformats.org/presentationml/2006/main">
-  <p:cSld>
-    <p:spTree>
-      <p:nvGrpSpPr>
-        <p:cNvPr id="1" name=""/>
-        <p:cNvGrpSpPr/>
-        <p:nvPr/>
-      </p:nvGrpSpPr>
-      <p:grpSpPr>
-        <a:xfrm>
-          <a:off x="0" y="0"/>
-          <a:ext cx="0" cy="0"/>
-          <a:chOff x="0" y="0"/>
-          <a:chExt cx="0" cy="0"/>
-        </a:xfrm>
-      </p:grpSpPr>
-      <p:sp>
-        <p:nvSpPr>
-          <p:cNvPr id="2" name="Title 1"/>
-          <p:cNvSpPr>
-            <a:spLocks noGrp="1"/>
-          </p:cNvSpPr>
-          <p:nvPr>
-            <p:ph type="title"/>
-          </p:nvPr>
-        </p:nvSpPr>
         <p:spPr>
           <a:xfrm>
             <a:off x="722313" y="4406900"/>
@@ -8664,7 +8572,7 @@
             </a:pPr>
             <a:r>
               <a:rPr/>
-              <a:t>Três papéis, um objetivo em comum</a:t>
+              <a:t>Dois núcleos, um objetivo em comum</a:t>
             </a:r>
           </a:p>
         </p:txBody>

</xml_diff>

<commit_message>
Adicionar dashboard de patrimônio assegurado na página de clientes
Cada apólice passa a guardar o valor e a descrição do patrimônio
segurado (veículo, imóvel, equipamentos da empresa), além das datas de
início e renovação já existentes (migração
04_patrimonio_apolices.sql, com backfill dos dados fictícios do seed).
O endpoint /api/data/clientes do BFF agora retorna as apólices de cada
cliente com esses campos, e a página /clientes foi refeita como um
dashboard: cartões de KPI (patrimônio total assegurado, apólices na
carteira, clientes a renovar em 30 dias) e uma tabela com linhas
expansíveis mostrando o patrimônio de cada apólice do cliente.

Também insere dois prints dessa tela no case study final da
apresentação (visão geral e detalhe expandido de um cliente).

Co-Authored-By: Claude Sonnet 5 <noreply@anthropic.com>
Claude-Session: https://claude.ai/code/session_017dKXPAcE5bAggx1M3V9VCU
</commit_message>
<xml_diff>
--- a/presentation/apresentacao.pptx
+++ b/presentation/apresentacao.pptx
@@ -5,7 +5,7 @@
     <p:sldMasterId id="2147483648" r:id="rId1"/>
   </p:sldMasterIdLst>
   <p:notesMasterIdLst>
-    <p:notesMasterId r:id="rId55"/>
+    <p:notesMasterId r:id="rId56"/>
   </p:notesMasterIdLst>
   <p:sldIdLst>
     <p:sldId id="256" r:id="rId2"/>
@@ -61,6 +61,7 @@
     <p:sldId id="306" r:id="rId52"/>
     <p:sldId id="307" r:id="rId53"/>
     <p:sldId id="308" r:id="rId54"/>
+    <p:sldId id="309" r:id="rId55"/>
   </p:sldIdLst>
   <p:sldSz cx="12191695" cy="6858000" type="screen4x3"/>
   <p:notesSz cx="6858000" cy="9144000"/>
@@ -665,6 +666,88 @@
             <a:fld id="{18BDFEC3-8487-43E8-A154-7C12CBC1FFF2}" type="slidenum">
               <a:rPr lang="en-US"/>
               <a:t>46</a:t>
+            </a:fld>
+            <a:endParaRPr lang="en-US"/>
+          </a:p>
+        </p:txBody>
+      </p:sp>
+    </p:spTree>
+  </p:cSld>
+</p:notes>
+</file>
+
+<file path=ppt/notesSlides/notesSlide11.xml><?xml version="1.0" encoding="utf-8"?>
+<p:notes xmlns:a="http://schemas.openxmlformats.org/drawingml/2006/main" xmlns:r="http://schemas.openxmlformats.org/officeDocument/2006/relationships" xmlns:p="http://schemas.openxmlformats.org/presentationml/2006/main">
+  <p:cSld>
+    <p:spTree>
+      <p:nvGrpSpPr>
+        <p:cNvPr id="1" name=""/>
+        <p:cNvGrpSpPr/>
+        <p:nvPr/>
+      </p:nvGrpSpPr>
+      <p:grpSpPr>
+        <a:xfrm>
+          <a:off x="0" y="0"/>
+          <a:ext cx="0" cy="0"/>
+          <a:chOff x="0" y="0"/>
+          <a:chExt cx="0" cy="0"/>
+        </a:xfrm>
+      </p:grpSpPr>
+      <p:sp>
+        <p:nvSpPr>
+          <p:cNvPr id="2" name="Slide Image Placeholder 1"/>
+          <p:cNvSpPr>
+            <a:spLocks noGrp="1" noRot="1" noChangeAspect="1"/>
+          </p:cNvSpPr>
+          <p:nvPr>
+            <p:ph type="sldImg"/>
+          </p:nvPr>
+        </p:nvSpPr>
+        <p:spPr/>
+      </p:sp>
+      <p:sp>
+        <p:nvSpPr>
+          <p:cNvPr id="3" name="Notes Placeholder 2"/>
+          <p:cNvSpPr>
+            <a:spLocks noGrp="1"/>
+          </p:cNvSpPr>
+          <p:nvPr>
+            <p:ph type="body" idx="1"/>
+          </p:nvPr>
+        </p:nvSpPr>
+        <p:spPr/>
+        <p:txBody>
+          <a:bodyPr/>
+          <a:lstStyle/>
+          <a:p>
+            <a:pPr lvl="0" indent="0" marL="0">
+              <a:buNone/>
+            </a:pPr>
+            <a:r>
+              <a:rPr/>
+              <a:t>Cada apólice segura um patrimônio específico do cliente — um carro, um imóvel, os equipamentos de uma empresa. Ao abrir um cliente, o corretor vê o valor desse patrimônio, a descrição do que está sendo segurado, a data em que a apólice começou e a data da próxima renovação, tudo lado a lado. Isso substitui planilhas soltas e torna imediato saber quanto patrimônio a corretora protege e quando cada contrato precisa de atenção.</a:t>
+            </a:r>
+          </a:p>
+        </p:txBody>
+      </p:sp>
+      <p:sp>
+        <p:nvSpPr>
+          <p:cNvPr id="4" name="Slide Number Placeholder 3"/>
+          <p:cNvSpPr>
+            <a:spLocks noGrp="1"/>
+          </p:cNvSpPr>
+          <p:nvPr>
+            <p:ph type="sldNum" sz="quarter" idx="10"/>
+          </p:nvPr>
+        </p:nvSpPr>
+        <p:spPr/>
+        <p:txBody>
+          <a:bodyPr/>
+          <a:lstStyle/>
+          <a:p>
+            <a:fld id="{18BDFEC3-8487-43E8-A154-7C12CBC1FFF2}" type="slidenum">
+              <a:rPr lang="en-US"/>
+              <a:t>50</a:t>
             </a:fld>
             <a:endParaRPr lang="en-US"/>
           </a:p>
@@ -8020,21 +8103,21 @@
             </a:pPr>
             <a:r>
               <a:rPr/>
-              <a:t>Enviando apólices em PDF para a base de conhecimento</a:t>
+              <a:t>O patrimônio de cada cliente, em um só lugar</a:t>
             </a:r>
           </a:p>
         </p:txBody>
       </p:sp>
       <p:pic>
         <p:nvPicPr>
-          <p:cNvPr descr="assets/screenshots/app_documentos.png" id="0" name="Picture 1"/>
+          <p:cNvPr descr="assets/screenshots/app_clientes_detalhe.png" id="0" name="Picture 1"/>
           <p:cNvPicPr>
             <a:picLocks noGrp="1" noChangeAspect="1"/>
           </p:cNvPicPr>
           <p:nvPr/>
         </p:nvPicPr>
         <p:blipFill>
-          <a:blip r:embed="rId2"/>
+          <a:blip r:embed="rId3"/>
           <a:stretch>
             <a:fillRect/>
           </a:stretch>
@@ -8097,55 +8180,41 @@
             </a:pPr>
             <a:r>
               <a:rPr/>
-              <a:t>Benefícios para o negócio</a:t>
-            </a:r>
-          </a:p>
-        </p:txBody>
-      </p:sp>
-      <p:sp>
-        <p:nvSpPr>
-          <p:cNvPr id="3" name="Content Placeholder 2"/>
-          <p:cNvSpPr>
-            <a:spLocks noGrp="1"/>
-          </p:cNvSpPr>
-          <p:nvPr>
-            <p:ph idx="1"/>
-          </p:nvPr>
-        </p:nvSpPr>
-        <p:spPr/>
-        <p:txBody>
-          <a:bodyPr/>
-          <a:lstStyle/>
-          <a:p>
-            <a:pPr lvl="0"/>
-            <a:r>
-              <a:rPr/>
-              <a:t>Atendimento mais rápido e preciso, com menos tempo de espera para o cliente</a:t>
-            </a:r>
-          </a:p>
-          <a:p>
-            <a:pPr lvl="0"/>
-            <a:r>
-              <a:rPr/>
-              <a:t>Menos cancelamentos, porque sinais de risco são tratados antes do vencimento da apólice</a:t>
-            </a:r>
-          </a:p>
-          <a:p>
-            <a:pPr lvl="0"/>
-            <a:r>
-              <a:rPr/>
-              <a:t>Previsão de receita mais confiável, o que ajuda o planejamento financeiro da corretora</a:t>
-            </a:r>
-          </a:p>
-          <a:p>
-            <a:pPr lvl="0"/>
-            <a:r>
-              <a:rPr/>
-              <a:t>Decisões melhores, apoiadas em uma visão mais completa de cada cliente</a:t>
-            </a:r>
-          </a:p>
-        </p:txBody>
-      </p:sp>
+              <a:t>Enviando apólices em PDF para a base de conhecimento</a:t>
+            </a:r>
+          </a:p>
+        </p:txBody>
+      </p:sp>
+      <p:pic>
+        <p:nvPicPr>
+          <p:cNvPr descr="assets/screenshots/app_documentos.png" id="0" name="Picture 1"/>
+          <p:cNvPicPr>
+            <a:picLocks noGrp="1" noChangeAspect="1"/>
+          </p:cNvPicPr>
+          <p:nvPr/>
+        </p:nvPicPr>
+        <p:blipFill>
+          <a:blip r:embed="rId2"/>
+          <a:stretch>
+            <a:fillRect/>
+          </a:stretch>
+        </p:blipFill>
+        <p:spPr bwMode="auto">
+          <a:xfrm>
+            <a:off x="952500" y="1600200"/>
+            <a:ext cx="7239000" cy="4521200"/>
+          </a:xfrm>
+          <a:prstGeom prst="rect">
+            <a:avLst/>
+          </a:prstGeom>
+          <a:noFill/>
+          <a:ln w="9525">
+            <a:noFill/>
+            <a:headEnd/>
+            <a:tailEnd/>
+          </a:ln>
+        </p:spPr>
+      </p:pic>
     </p:spTree>
   </p:cSld>
 </p:sld>
@@ -8188,7 +8257,7 @@
             </a:pPr>
             <a:r>
               <a:rPr/>
-              <a:t>Cuidados importantes</a:t>
+              <a:t>Benefícios para o negócio</a:t>
             </a:r>
           </a:p>
         </p:txBody>
@@ -8211,28 +8280,28 @@
             <a:pPr lvl="0"/>
             <a:r>
               <a:rPr/>
-              <a:t>A qualidade da previsão depende da qualidade dos dados usados como fonte</a:t>
-            </a:r>
-          </a:p>
-          <a:p>
-            <a:pPr lvl="0"/>
-            <a:r>
-              <a:rPr/>
-              <a:t>Pessoas continuam responsáveis por revisar decisões de maior impacto</a:t>
-            </a:r>
-          </a:p>
-          <a:p>
-            <a:pPr lvl="0"/>
-            <a:r>
-              <a:rPr/>
-              <a:t>O contato automático com o cliente precisa ser cuidadoso, sem parecer invasivo ou impessoal</a:t>
-            </a:r>
-          </a:p>
-          <a:p>
-            <a:pPr lvl="0"/>
-            <a:r>
-              <a:rPr/>
-              <a:t>Inteligência artificial é uma ferramenta poderosa, mas não substitui a governança do negócio</a:t>
+              <a:t>Atendimento mais rápido e preciso, com menos tempo de espera para o cliente</a:t>
+            </a:r>
+          </a:p>
+          <a:p>
+            <a:pPr lvl="0"/>
+            <a:r>
+              <a:rPr/>
+              <a:t>Menos cancelamentos, porque sinais de risco são tratados antes do vencimento da apólice</a:t>
+            </a:r>
+          </a:p>
+          <a:p>
+            <a:pPr lvl="0"/>
+            <a:r>
+              <a:rPr/>
+              <a:t>Previsão de receita mais confiável, o que ajuda o planejamento financeiro da corretora</a:t>
+            </a:r>
+          </a:p>
+          <a:p>
+            <a:pPr lvl="0"/>
+            <a:r>
+              <a:rPr/>
+              <a:t>Decisões melhores, apoiadas em uma visão mais completa de cada cliente</a:t>
             </a:r>
           </a:p>
         </p:txBody>
@@ -8243,6 +8312,97 @@
 </file>
 
 <file path=ppt/slides/slide53.xml><?xml version="1.0" encoding="utf-8"?>
+<p:sld xmlns:a="http://schemas.openxmlformats.org/drawingml/2006/main" xmlns:r="http://schemas.openxmlformats.org/officeDocument/2006/relationships" xmlns:p="http://schemas.openxmlformats.org/presentationml/2006/main">
+  <p:cSld>
+    <p:spTree>
+      <p:nvGrpSpPr>
+        <p:cNvPr id="1" name=""/>
+        <p:cNvGrpSpPr/>
+        <p:nvPr/>
+      </p:nvGrpSpPr>
+      <p:grpSpPr>
+        <a:xfrm>
+          <a:off x="0" y="0"/>
+          <a:ext cx="0" cy="0"/>
+          <a:chOff x="0" y="0"/>
+          <a:chExt cx="0" cy="0"/>
+        </a:xfrm>
+      </p:grpSpPr>
+      <p:sp>
+        <p:nvSpPr>
+          <p:cNvPr id="2" name="Title 1"/>
+          <p:cNvSpPr>
+            <a:spLocks noGrp="1"/>
+          </p:cNvSpPr>
+          <p:nvPr>
+            <p:ph type="title"/>
+          </p:nvPr>
+        </p:nvSpPr>
+        <p:spPr/>
+        <p:txBody>
+          <a:bodyPr/>
+          <a:lstStyle/>
+          <a:p>
+            <a:pPr lvl="0" indent="0" marL="0">
+              <a:buNone/>
+            </a:pPr>
+            <a:r>
+              <a:rPr/>
+              <a:t>Cuidados importantes</a:t>
+            </a:r>
+          </a:p>
+        </p:txBody>
+      </p:sp>
+      <p:sp>
+        <p:nvSpPr>
+          <p:cNvPr id="3" name="Content Placeholder 2"/>
+          <p:cNvSpPr>
+            <a:spLocks noGrp="1"/>
+          </p:cNvSpPr>
+          <p:nvPr>
+            <p:ph idx="1"/>
+          </p:nvPr>
+        </p:nvSpPr>
+        <p:spPr/>
+        <p:txBody>
+          <a:bodyPr/>
+          <a:lstStyle/>
+          <a:p>
+            <a:pPr lvl="0"/>
+            <a:r>
+              <a:rPr/>
+              <a:t>A qualidade da previsão depende da qualidade dos dados usados como fonte</a:t>
+            </a:r>
+          </a:p>
+          <a:p>
+            <a:pPr lvl="0"/>
+            <a:r>
+              <a:rPr/>
+              <a:t>Pessoas continuam responsáveis por revisar decisões de maior impacto</a:t>
+            </a:r>
+          </a:p>
+          <a:p>
+            <a:pPr lvl="0"/>
+            <a:r>
+              <a:rPr/>
+              <a:t>O contato automático com o cliente precisa ser cuidadoso, sem parecer invasivo ou impessoal</a:t>
+            </a:r>
+          </a:p>
+          <a:p>
+            <a:pPr lvl="0"/>
+            <a:r>
+              <a:rPr/>
+              <a:t>Inteligência artificial é uma ferramenta poderosa, mas não substitui a governança do negócio</a:t>
+            </a:r>
+          </a:p>
+        </p:txBody>
+      </p:sp>
+    </p:spTree>
+  </p:cSld>
+</p:sld>
+</file>
+
+<file path=ppt/slides/slide54.xml><?xml version="1.0" encoding="utf-8"?>
 <p:sld xmlns:a="http://schemas.openxmlformats.org/drawingml/2006/main" xmlns:r="http://schemas.openxmlformats.org/officeDocument/2006/relationships" xmlns:p="http://schemas.openxmlformats.org/presentationml/2006/main">
   <p:cSld>
     <p:spTree>

</xml_diff>